<commit_message>
Finalize Challenge 2 corrections and dependency compatibility
</commit_message>
<xml_diff>
--- a/deliverables/HeartTrialTwin_Challenge2_Final.pptx
+++ b/deliverables/HeartTrialTwin_Challenge2_Final.pptx
@@ -2,22 +2,22 @@
 <file path=ppt/presentation.xml><?xml version="1.0" encoding="utf-8"?>
 <p:presentation xmlns:p="http://schemas.openxmlformats.org/presentationml/2006/main">
   <p:sldMasterIdLst>
-    <p:sldMasterId xmlns:r="http://schemas.openxmlformats.org/officeDocument/2006/relationships" id="2147483648" r:id="R8f5f64eda8e149f0"/>
+    <p:sldMasterId xmlns:r="http://schemas.openxmlformats.org/officeDocument/2006/relationships" id="2147483648" r:id="R9c19a50b4e4b40d9"/>
   </p:sldMasterIdLst>
   <p:notesMasterIdLst>
-    <p:notesMasterId xmlns:r="http://schemas.openxmlformats.org/officeDocument/2006/relationships" r:id="Ra84e09ad002e4d44"/>
+    <p:notesMasterId xmlns:r="http://schemas.openxmlformats.org/officeDocument/2006/relationships" r:id="R8408d436f46d45c8"/>
   </p:notesMasterIdLst>
   <p:sldIdLst>
-    <p:sldId xmlns:r="http://schemas.openxmlformats.org/officeDocument/2006/relationships" id="256" r:id="R334a5c389efe4222"/>
-    <p:sldId xmlns:r="http://schemas.openxmlformats.org/officeDocument/2006/relationships" id="257" r:id="R99eaf8fe964d415b"/>
-    <p:sldId xmlns:r="http://schemas.openxmlformats.org/officeDocument/2006/relationships" id="258" r:id="R3edbbb267ee6472e"/>
-    <p:sldId xmlns:r="http://schemas.openxmlformats.org/officeDocument/2006/relationships" id="259" r:id="Ra990e8444a59463d"/>
-    <p:sldId xmlns:r="http://schemas.openxmlformats.org/officeDocument/2006/relationships" id="260" r:id="Re068a72a6bdb4115"/>
-    <p:sldId xmlns:r="http://schemas.openxmlformats.org/officeDocument/2006/relationships" id="261" r:id="Rc7adf710bb0945d9"/>
-    <p:sldId xmlns:r="http://schemas.openxmlformats.org/officeDocument/2006/relationships" id="262" r:id="R6a6050085ed740fe"/>
-    <p:sldId xmlns:r="http://schemas.openxmlformats.org/officeDocument/2006/relationships" id="263" r:id="Rdb6ec31a6c26480f"/>
-    <p:sldId xmlns:r="http://schemas.openxmlformats.org/officeDocument/2006/relationships" id="264" r:id="R587b04cfe0d84d60"/>
-    <p:sldId xmlns:r="http://schemas.openxmlformats.org/officeDocument/2006/relationships" id="265" r:id="Rdb201cf1d7714aa5"/>
+    <p:sldId xmlns:r="http://schemas.openxmlformats.org/officeDocument/2006/relationships" id="256" r:id="R1e7dc5c160ae4510"/>
+    <p:sldId xmlns:r="http://schemas.openxmlformats.org/officeDocument/2006/relationships" id="257" r:id="R66c2145d501d4fe9"/>
+    <p:sldId xmlns:r="http://schemas.openxmlformats.org/officeDocument/2006/relationships" id="258" r:id="R85af9b78c34141ed"/>
+    <p:sldId xmlns:r="http://schemas.openxmlformats.org/officeDocument/2006/relationships" id="259" r:id="R1950901ae081402f"/>
+    <p:sldId xmlns:r="http://schemas.openxmlformats.org/officeDocument/2006/relationships" id="260" r:id="R7e7dff85e3b446ac"/>
+    <p:sldId xmlns:r="http://schemas.openxmlformats.org/officeDocument/2006/relationships" id="261" r:id="Rbec1a76842ca4456"/>
+    <p:sldId xmlns:r="http://schemas.openxmlformats.org/officeDocument/2006/relationships" id="262" r:id="R315134322a844583"/>
+    <p:sldId xmlns:r="http://schemas.openxmlformats.org/officeDocument/2006/relationships" id="263" r:id="R0951d1c4cd4540d5"/>
+    <p:sldId xmlns:r="http://schemas.openxmlformats.org/officeDocument/2006/relationships" id="264" r:id="R60886972163c47f4"/>
+    <p:sldId xmlns:r="http://schemas.openxmlformats.org/officeDocument/2006/relationships" id="265" r:id="R65f387a6554c44e4"/>
   </p:sldIdLst>
   <p:sldSz cx="12192000" cy="6858000"/>
   <p:notesSz cx="6858000" cy="9144000"/>
@@ -1081,7 +1081,7 @@
           <a:lstStyle xmlns:a="http://schemas.openxmlformats.org/drawingml/2006/main"/>
           <a:p xmlns:a="http://schemas.openxmlformats.org/drawingml/2006/main">
             <a:r>
-              <a:t>Source: local Git status and repository preparation completed for this delivery. Runtime behavior is documented in README.md and p1_app/app.py.</a:t>
+              <a:t>Sources: README.md, p1_app/app.py, test evidence, screenshot verification, presentation validation, and published repository https://github.com/akwasianing/HeartTrialTwin. Codex assisted development; the project owner approved scope, constraints, validation evidence, blocked outputs, and publication.</a:t>
             </a:r>
           </a:p>
         </p:txBody>
@@ -1149,7 +1149,7 @@
   </p:cSld>
   <p:clrMap bg1="lt1" tx1="dk1" bg2="lt2" tx2="dk2" accent1="accent1" accent2="accent2" accent3="accent3" accent4="accent4" accent5="accent5" accent6="accent6" hlink="hlink" folHlink="folHlink"/>
   <p:sldLayoutIdLst>
-    <p:sldLayoutId xmlns:r="http://schemas.openxmlformats.org/officeDocument/2006/relationships" id="2147483649" r:id="Rbe6b478929304226"/>
+    <p:sldLayoutId xmlns:r="http://schemas.openxmlformats.org/officeDocument/2006/relationships" id="2147483649" r:id="Re440c55aa4164604"/>
   </p:sldLayoutIdLst>
   <p:txStyles>
     <p:titleStyle>
@@ -2007,7 +2007,7 @@
           <p:cNvPr id="8" name="">
             <a:extLst xmlns:a="http://schemas.openxmlformats.org/drawingml/2006/main">
               <a:ext uri="{FF2B5EF4-FFF2-40B4-BE49-F238E27FC236}">
-                <a16:creationId xmlns:a16="http://schemas.microsoft.com/office/drawing/2014/main" id="{89CDC54A-725A-48F1-98C3-2EF95BCA31FB}"/>
+                <a16:creationId xmlns:a16="http://schemas.microsoft.com/office/drawing/2014/main" id="{FBCEA2D8-6268-4316-A26F-D66BEE631793}"/>
               </a:ext>
             </a:extLst>
           </p:cNvPr>
@@ -2039,7 +2039,7 @@
           <p:cNvPr id="2" name="">
             <a:extLst xmlns:a="http://schemas.openxmlformats.org/drawingml/2006/main">
               <a:ext uri="{FF2B5EF4-FFF2-40B4-BE49-F238E27FC236}">
-                <a16:creationId xmlns:a16="http://schemas.microsoft.com/office/drawing/2014/main" id="{5A42D1BB-6C22-4661-9856-90D9A83AA3D8}"/>
+                <a16:creationId xmlns:a16="http://schemas.microsoft.com/office/drawing/2014/main" id="{104B9103-0C06-4619-B595-F78EC6A139B6}"/>
               </a:ext>
             </a:extLst>
           </p:cNvPr>
@@ -2096,7 +2096,7 @@
           <p:cNvPr id="3" name="">
             <a:extLst xmlns:a="http://schemas.openxmlformats.org/drawingml/2006/main">
               <a:ext uri="{FF2B5EF4-FFF2-40B4-BE49-F238E27FC236}">
-                <a16:creationId xmlns:a16="http://schemas.microsoft.com/office/drawing/2014/main" id="{91AAEC39-D163-4342-AB08-694240889275}"/>
+                <a16:creationId xmlns:a16="http://schemas.microsoft.com/office/drawing/2014/main" id="{F15F6540-7EB7-40C7-80B4-789FC2F76A74}"/>
               </a:ext>
             </a:extLst>
           </p:cNvPr>
@@ -2108,7 +2108,7 @@
         <p:spPr>
           <a:xfrm xmlns:a="http://schemas.openxmlformats.org/drawingml/2006/main">
             <a:off x="838200" y="2057400"/>
-            <a:ext cx="9525000" cy="495300"/>
+            <a:ext cx="10287000" cy="495300"/>
           </a:xfrm>
           <a:prstGeom xmlns:a="http://schemas.openxmlformats.org/drawingml/2006/main" prst="rect">
             <a:avLst/>
@@ -2125,7 +2125,7 @@
           <a:lstStyle xmlns:a="http://schemas.openxmlformats.org/drawingml/2006/main"/>
           <a:p xmlns:a="http://schemas.openxmlformats.org/drawingml/2006/main">
             <a:pPr algn="l">
-              <a:defRPr sz="2550" b="0">
+              <a:defRPr sz="2250" b="0">
                 <a:solidFill>
                   <a:srgbClr val="D7E5EC"/>
                 </a:solidFill>
@@ -2135,7 +2135,7 @@
               </a:defRPr>
             </a:pPr>
             <a:r>
-              <a:rPr sz="2550" b="0">
+              <a:rPr sz="2250" b="0">
                 <a:solidFill>
                   <a:srgbClr val="D7E5EC"/>
                 </a:solidFill>
@@ -2143,7 +2143,7 @@
                 <a:ea typeface="Helvetica Neue"/>
                 <a:cs typeface="Helvetica Neue"/>
               </a:rPr>
-              <a:t>Safe AI for trial discontinuation risk</a:t>
+              <a:t>Model-release readiness review for a selected clinical trial</a:t>
             </a:r>
           </a:p>
         </p:txBody>
@@ -2153,7 +2153,7 @@
           <p:cNvPr id="4" name="">
             <a:extLst xmlns:a="http://schemas.openxmlformats.org/drawingml/2006/main">
               <a:ext uri="{FF2B5EF4-FFF2-40B4-BE49-F238E27FC236}">
-                <a16:creationId xmlns:a16="http://schemas.microsoft.com/office/drawing/2014/main" id="{81BDE01D-1107-4715-893E-08F05E4C4C12}"/>
+                <a16:creationId xmlns:a16="http://schemas.microsoft.com/office/drawing/2014/main" id="{E3BF3B1F-0806-4187-96B9-59831B6F518D}"/>
               </a:ext>
             </a:extLst>
           </p:cNvPr>
@@ -2210,7 +2210,7 @@
           <p:cNvPr id="5" name="">
             <a:extLst xmlns:a="http://schemas.openxmlformats.org/drawingml/2006/main">
               <a:ext uri="{FF2B5EF4-FFF2-40B4-BE49-F238E27FC236}">
-                <a16:creationId xmlns:a16="http://schemas.microsoft.com/office/drawing/2014/main" id="{75E2A919-5AC8-44CD-8DF3-A855CB9FBA5E}"/>
+                <a16:creationId xmlns:a16="http://schemas.microsoft.com/office/drawing/2014/main" id="{2D0EFDA0-D341-45AB-91C4-D8900B103F5A}"/>
               </a:ext>
             </a:extLst>
           </p:cNvPr>
@@ -2267,7 +2267,7 @@
           <p:cNvPr id="6" name="">
             <a:extLst xmlns:a="http://schemas.openxmlformats.org/drawingml/2006/main">
               <a:ext uri="{FF2B5EF4-FFF2-40B4-BE49-F238E27FC236}">
-                <a16:creationId xmlns:a16="http://schemas.microsoft.com/office/drawing/2014/main" id="{940FB3AB-D649-447A-8401-A3796DA040AD}"/>
+                <a16:creationId xmlns:a16="http://schemas.microsoft.com/office/drawing/2014/main" id="{C3F5DCF2-EEF4-42CF-9DD9-636540E1E3A6}"/>
               </a:ext>
             </a:extLst>
           </p:cNvPr>
@@ -2321,7 +2321,7 @@
                 <a:ea typeface="Helvetica Neue"/>
                 <a:cs typeface="Helvetica Neue"/>
               </a:rPr>
-              <a:t>Temporal baseline  /  technical proof of concept</a:t>
+              <a:t>Challenge 2  /  verified safe-failure workflow</a:t>
             </a:r>
           </a:p>
         </p:txBody>
@@ -2331,7 +2331,7 @@
           <p:cNvPr id="7" name="">
             <a:extLst xmlns:a="http://schemas.openxmlformats.org/drawingml/2006/main">
               <a:ext uri="{FF2B5EF4-FFF2-40B4-BE49-F238E27FC236}">
-                <a16:creationId xmlns:a16="http://schemas.microsoft.com/office/drawing/2014/main" id="{15C42C25-C7B9-4A5D-BA65-7195B30A9D65}"/>
+                <a16:creationId xmlns:a16="http://schemas.microsoft.com/office/drawing/2014/main" id="{D0EE421D-3A5B-44A4-9A65-5628E586C876}"/>
               </a:ext>
             </a:extLst>
           </p:cNvPr>
@@ -2386,7 +2386,7 @@
     </p:spTree>
     <p:extLst>
       <p:ext uri="{BB962C8B-B14F-4D97-AF65-F5344CB8AC3E}">
-        <p14:creationId xmlns:p14="http://schemas.microsoft.com/office/powerpoint/2010/main" val="1370685410"/>
+        <p14:creationId xmlns:p14="http://schemas.microsoft.com/office/powerpoint/2010/main" val="227667100"/>
       </p:ext>
     </p:extLst>
   </p:cSld>
@@ -2414,10 +2414,10 @@
       </p:grpSpPr>
       <p:sp>
         <p:nvSpPr>
-          <p:cNvPr id="16" name="">
-            <a:extLst xmlns:a="http://schemas.openxmlformats.org/drawingml/2006/main">
-              <a:ext uri="{FF2B5EF4-FFF2-40B4-BE49-F238E27FC236}">
-                <a16:creationId xmlns:a16="http://schemas.microsoft.com/office/drawing/2014/main" id="{A39C4D80-00E3-4FF9-8BDD-70E909FD3C7A}"/>
+          <p:cNvPr id="18" name="">
+            <a:extLst xmlns:a="http://schemas.openxmlformats.org/drawingml/2006/main">
+              <a:ext uri="{FF2B5EF4-FFF2-40B4-BE49-F238E27FC236}">
+                <a16:creationId xmlns:a16="http://schemas.microsoft.com/office/drawing/2014/main" id="{DA64A19F-2B42-430D-A5EC-6EFAFF260B4C}"/>
               </a:ext>
             </a:extLst>
           </p:cNvPr>
@@ -2474,19 +2474,19 @@
           <p:cNvPr id="2" name="">
             <a:extLst xmlns:a="http://schemas.openxmlformats.org/drawingml/2006/main">
               <a:ext uri="{FF2B5EF4-FFF2-40B4-BE49-F238E27FC236}">
-                <a16:creationId xmlns:a16="http://schemas.microsoft.com/office/drawing/2014/main" id="{A87D6847-5AA7-43CC-A558-64BE1EE708E5}"/>
-              </a:ext>
-            </a:extLst>
-          </p:cNvPr>
-          <p:cNvSpPr>
-            <a:spLocks xmlns:a="http://schemas.openxmlformats.org/drawingml/2006/main" noGrp="1"/>
-          </p:cNvSpPr>
-          <p:nvPr/>
-        </p:nvSpPr>
-        <p:spPr>
-          <a:xfrm xmlns:a="http://schemas.openxmlformats.org/drawingml/2006/main">
-            <a:off x="666750" y="1285875"/>
-            <a:ext cx="2476500" cy="876300"/>
+                <a16:creationId xmlns:a16="http://schemas.microsoft.com/office/drawing/2014/main" id="{930B184E-2F0B-4255-8D8A-2336EFF85114}"/>
+              </a:ext>
+            </a:extLst>
+          </p:cNvPr>
+          <p:cNvSpPr>
+            <a:spLocks xmlns:a="http://schemas.openxmlformats.org/drawingml/2006/main" noGrp="1"/>
+          </p:cNvSpPr>
+          <p:nvPr/>
+        </p:nvSpPr>
+        <p:spPr>
+          <a:xfrm xmlns:a="http://schemas.openxmlformats.org/drawingml/2006/main">
+            <a:off x="3476625" y="876300"/>
+            <a:ext cx="7810500" cy="381000"/>
           </a:xfrm>
           <a:prstGeom xmlns:a="http://schemas.openxmlformats.org/drawingml/2006/main" prst="rect">
             <a:avLst/>
@@ -2498,30 +2498,30 @@
         </p:spPr>
         <p:txBody>
           <a:bodyPr xmlns:a="http://schemas.openxmlformats.org/drawingml/2006/main" anchor="ctr">
-            <a:normAutofit fontScale="98095"/>
+            <a:normAutofit fontScale="100000"/>
           </a:bodyPr>
           <a:lstStyle xmlns:a="http://schemas.openxmlformats.org/drawingml/2006/main"/>
           <a:p xmlns:a="http://schemas.openxmlformats.org/drawingml/2006/main">
             <a:pPr algn="ctr">
-              <a:defRPr sz="5250" b="1">
-                <a:solidFill>
-                  <a:srgbClr val="77D5C9"/>
-                </a:solidFill>
-                <a:latin typeface="Helvetica Neue"/>
-                <a:ea typeface="Helvetica Neue"/>
-                <a:cs typeface="Helvetica Neue"/>
-              </a:defRPr>
-            </a:pPr>
-            <a:r>
-              <a:rPr sz="5250" b="1">
-                <a:solidFill>
-                  <a:srgbClr val="77D5C9"/>
-                </a:solidFill>
-                <a:latin typeface="Helvetica Neue"/>
-                <a:ea typeface="Helvetica Neue"/>
-                <a:cs typeface="Helvetica Neue"/>
-              </a:rPr>
-              <a:t>8 / 8</a:t>
+              <a:defRPr sz="1875" b="1">
+                <a:solidFill>
+                  <a:srgbClr val="FFB4B4"/>
+                </a:solidFill>
+                <a:latin typeface="Helvetica Neue"/>
+                <a:ea typeface="Helvetica Neue"/>
+                <a:cs typeface="Helvetica Neue"/>
+              </a:defRPr>
+            </a:pPr>
+            <a:r>
+              <a:rPr sz="1875" b="1">
+                <a:solidFill>
+                  <a:srgbClr val="FFB4B4"/>
+                </a:solidFill>
+                <a:latin typeface="Helvetica Neue"/>
+                <a:ea typeface="Helvetica Neue"/>
+                <a:cs typeface="Helvetica Neue"/>
+              </a:rPr>
+              <a:t>8 software tests passed; model validation failed.</a:t>
             </a:r>
           </a:p>
         </p:txBody>
@@ -2531,19 +2531,19 @@
           <p:cNvPr id="3" name="">
             <a:extLst xmlns:a="http://schemas.openxmlformats.org/drawingml/2006/main">
               <a:ext uri="{FF2B5EF4-FFF2-40B4-BE49-F238E27FC236}">
-                <a16:creationId xmlns:a16="http://schemas.microsoft.com/office/drawing/2014/main" id="{2FFC2CF8-0AE8-4980-873B-3452097D881F}"/>
-              </a:ext>
-            </a:extLst>
-          </p:cNvPr>
-          <p:cNvSpPr>
-            <a:spLocks xmlns:a="http://schemas.openxmlformats.org/drawingml/2006/main" noGrp="1"/>
-          </p:cNvSpPr>
-          <p:nvPr/>
-        </p:nvSpPr>
-        <p:spPr>
-          <a:xfrm xmlns:a="http://schemas.openxmlformats.org/drawingml/2006/main">
-            <a:off x="666750" y="2095500"/>
-            <a:ext cx="2476500" cy="666750"/>
+                <a16:creationId xmlns:a16="http://schemas.microsoft.com/office/drawing/2014/main" id="{E45FB4D0-2202-4B00-88C7-2420D2211A0A}"/>
+              </a:ext>
+            </a:extLst>
+          </p:cNvPr>
+          <p:cNvSpPr>
+            <a:spLocks xmlns:a="http://schemas.openxmlformats.org/drawingml/2006/main" noGrp="1"/>
+          </p:cNvSpPr>
+          <p:nvPr/>
+        </p:nvSpPr>
+        <p:spPr>
+          <a:xfrm xmlns:a="http://schemas.openxmlformats.org/drawingml/2006/main">
+            <a:off x="666750" y="1285875"/>
+            <a:ext cx="2476500" cy="876300"/>
           </a:xfrm>
           <a:prstGeom xmlns:a="http://schemas.openxmlformats.org/drawingml/2006/main" prst="rect">
             <a:avLst/>
@@ -2555,53 +2555,30 @@
         </p:spPr>
         <p:txBody>
           <a:bodyPr xmlns:a="http://schemas.openxmlformats.org/drawingml/2006/main" anchor="ctr">
-            <a:normAutofit fontScale="100000"/>
+            <a:normAutofit fontScale="98095"/>
           </a:bodyPr>
           <a:lstStyle xmlns:a="http://schemas.openxmlformats.org/drawingml/2006/main"/>
           <a:p xmlns:a="http://schemas.openxmlformats.org/drawingml/2006/main">
             <a:pPr algn="ctr">
-              <a:defRPr sz="1725" b="1">
-                <a:solidFill>
-                  <a:srgbClr val="D7E5EC"/>
-                </a:solidFill>
-                <a:latin typeface="Helvetica Neue"/>
-                <a:ea typeface="Helvetica Neue"/>
-                <a:cs typeface="Helvetica Neue"/>
-              </a:defRPr>
-            </a:pPr>
-            <a:r>
-              <a:rPr sz="1725" b="1">
-                <a:solidFill>
-                  <a:srgbClr val="D7E5EC"/>
-                </a:solidFill>
-                <a:latin typeface="Helvetica Neue"/>
-                <a:ea typeface="Helvetica Neue"/>
-                <a:cs typeface="Helvetica Neue"/>
-              </a:rPr>
-              <a:t>tests passed</a:t>
-            </a:r>
-          </a:p>
-          <a:p xmlns:a="http://schemas.openxmlformats.org/drawingml/2006/main">
-            <a:pPr algn="ctr">
-              <a:defRPr sz="1725" b="1">
-                <a:solidFill>
-                  <a:srgbClr val="D7E5EC"/>
-                </a:solidFill>
-                <a:latin typeface="Helvetica Neue"/>
-                <a:ea typeface="Helvetica Neue"/>
-                <a:cs typeface="Helvetica Neue"/>
-              </a:defRPr>
-            </a:pPr>
-            <a:r>
-              <a:rPr sz="1725" b="1">
-                <a:solidFill>
-                  <a:srgbClr val="D7E5EC"/>
-                </a:solidFill>
-                <a:latin typeface="Helvetica Neue"/>
-                <a:ea typeface="Helvetica Neue"/>
-                <a:cs typeface="Helvetica Neue"/>
-              </a:rPr>
-              <a:t>0 failed  ·  0 skipped</a:t>
+              <a:defRPr sz="5250" b="1">
+                <a:solidFill>
+                  <a:srgbClr val="77D5C9"/>
+                </a:solidFill>
+                <a:latin typeface="Helvetica Neue"/>
+                <a:ea typeface="Helvetica Neue"/>
+                <a:cs typeface="Helvetica Neue"/>
+              </a:defRPr>
+            </a:pPr>
+            <a:r>
+              <a:rPr sz="5250" b="1">
+                <a:solidFill>
+                  <a:srgbClr val="77D5C9"/>
+                </a:solidFill>
+                <a:latin typeface="Helvetica Neue"/>
+                <a:ea typeface="Helvetica Neue"/>
+                <a:cs typeface="Helvetica Neue"/>
+              </a:rPr>
+              <a:t>8 / 8</a:t>
             </a:r>
           </a:p>
         </p:txBody>
@@ -2611,19 +2588,19 @@
           <p:cNvPr id="4" name="">
             <a:extLst xmlns:a="http://schemas.openxmlformats.org/drawingml/2006/main">
               <a:ext uri="{FF2B5EF4-FFF2-40B4-BE49-F238E27FC236}">
-                <a16:creationId xmlns:a16="http://schemas.microsoft.com/office/drawing/2014/main" id="{5F4F97DC-18E8-420E-9AAF-374188F3ACE8}"/>
-              </a:ext>
-            </a:extLst>
-          </p:cNvPr>
-          <p:cNvSpPr>
-            <a:spLocks xmlns:a="http://schemas.openxmlformats.org/drawingml/2006/main" noGrp="1"/>
-          </p:cNvSpPr>
-          <p:nvPr/>
-        </p:nvSpPr>
-        <p:spPr>
-          <a:xfrm xmlns:a="http://schemas.openxmlformats.org/drawingml/2006/main">
-            <a:off x="3714750" y="1285875"/>
-            <a:ext cx="2857500" cy="342900"/>
+                <a16:creationId xmlns:a16="http://schemas.microsoft.com/office/drawing/2014/main" id="{F79F3DAA-7A6A-47ED-BE2D-9CB954755C26}"/>
+              </a:ext>
+            </a:extLst>
+          </p:cNvPr>
+          <p:cNvSpPr>
+            <a:spLocks xmlns:a="http://schemas.openxmlformats.org/drawingml/2006/main" noGrp="1"/>
+          </p:cNvSpPr>
+          <p:nvPr/>
+        </p:nvSpPr>
+        <p:spPr>
+          <a:xfrm xmlns:a="http://schemas.openxmlformats.org/drawingml/2006/main">
+            <a:off x="666750" y="2095500"/>
+            <a:ext cx="2476500" cy="666750"/>
           </a:xfrm>
           <a:prstGeom xmlns:a="http://schemas.openxmlformats.org/drawingml/2006/main" prst="rect">
             <a:avLst/>
@@ -2635,30 +2612,53 @@
         </p:spPr>
         <p:txBody>
           <a:bodyPr xmlns:a="http://schemas.openxmlformats.org/drawingml/2006/main" anchor="ctr">
-            <a:normAutofit fontScale="78571"/>
+            <a:normAutofit fontScale="100000"/>
           </a:bodyPr>
           <a:lstStyle xmlns:a="http://schemas.openxmlformats.org/drawingml/2006/main"/>
           <a:p xmlns:a="http://schemas.openxmlformats.org/drawingml/2006/main">
-            <a:pPr algn="l">
-              <a:defRPr sz="2100" b="1">
-                <a:solidFill>
-                  <a:srgbClr val="FFFFFF"/>
-                </a:solidFill>
-                <a:latin typeface="Helvetica Neue"/>
-                <a:ea typeface="Helvetica Neue"/>
-                <a:cs typeface="Helvetica Neue"/>
-              </a:defRPr>
-            </a:pPr>
-            <a:r>
-              <a:rPr sz="2100" b="1">
-                <a:solidFill>
-                  <a:srgbClr val="FFFFFF"/>
-                </a:solidFill>
-                <a:latin typeface="Helvetica Neue"/>
-                <a:ea typeface="Helvetica Neue"/>
-                <a:cs typeface="Helvetica Neue"/>
-              </a:rPr>
-              <a:t>Test coverage</a:t>
+            <a:pPr algn="ctr">
+              <a:defRPr sz="1650" b="1">
+                <a:solidFill>
+                  <a:srgbClr val="D7E5EC"/>
+                </a:solidFill>
+                <a:latin typeface="Helvetica Neue"/>
+                <a:ea typeface="Helvetica Neue"/>
+                <a:cs typeface="Helvetica Neue"/>
+              </a:defRPr>
+            </a:pPr>
+            <a:r>
+              <a:rPr sz="1650" b="1">
+                <a:solidFill>
+                  <a:srgbClr val="D7E5EC"/>
+                </a:solidFill>
+                <a:latin typeface="Helvetica Neue"/>
+                <a:ea typeface="Helvetica Neue"/>
+                <a:cs typeface="Helvetica Neue"/>
+              </a:rPr>
+              <a:t>software tests passed</a:t>
+            </a:r>
+          </a:p>
+          <a:p xmlns:a="http://schemas.openxmlformats.org/drawingml/2006/main">
+            <a:pPr algn="ctr">
+              <a:defRPr sz="1650" b="1">
+                <a:solidFill>
+                  <a:srgbClr val="D7E5EC"/>
+                </a:solidFill>
+                <a:latin typeface="Helvetica Neue"/>
+                <a:ea typeface="Helvetica Neue"/>
+                <a:cs typeface="Helvetica Neue"/>
+              </a:defRPr>
+            </a:pPr>
+            <a:r>
+              <a:rPr sz="1650" b="1">
+                <a:solidFill>
+                  <a:srgbClr val="D7E5EC"/>
+                </a:solidFill>
+                <a:latin typeface="Helvetica Neue"/>
+                <a:ea typeface="Helvetica Neue"/>
+                <a:cs typeface="Helvetica Neue"/>
+              </a:rPr>
+              <a:t>0 failed  /  0 skipped</a:t>
             </a:r>
           </a:p>
         </p:txBody>
@@ -2668,19 +2668,106 @@
           <p:cNvPr id="5" name="">
             <a:extLst xmlns:a="http://schemas.openxmlformats.org/drawingml/2006/main">
               <a:ext uri="{FF2B5EF4-FFF2-40B4-BE49-F238E27FC236}">
-                <a16:creationId xmlns:a16="http://schemas.microsoft.com/office/drawing/2014/main" id="{B51A58BA-F369-4890-B284-CDD054870BF2}"/>
-              </a:ext>
-            </a:extLst>
-          </p:cNvPr>
-          <p:cNvSpPr>
-            <a:spLocks xmlns:a="http://schemas.openxmlformats.org/drawingml/2006/main" noGrp="1"/>
-          </p:cNvSpPr>
-          <p:nvPr/>
-        </p:nvSpPr>
-        <p:spPr>
-          <a:xfrm xmlns:a="http://schemas.openxmlformats.org/drawingml/2006/main">
-            <a:off x="3714750" y="1809750"/>
-            <a:ext cx="3476625" cy="2000250"/>
+                <a16:creationId xmlns:a16="http://schemas.microsoft.com/office/drawing/2014/main" id="{8ED10220-AD97-4846-890A-7AABC02F0265}"/>
+              </a:ext>
+            </a:extLst>
+          </p:cNvPr>
+          <p:cNvSpPr>
+            <a:spLocks xmlns:a="http://schemas.openxmlformats.org/drawingml/2006/main" noGrp="1"/>
+          </p:cNvSpPr>
+          <p:nvPr/>
+        </p:nvSpPr>
+        <p:spPr>
+          <a:xfrm xmlns:a="http://schemas.openxmlformats.org/drawingml/2006/main">
+            <a:off x="809625" y="3095625"/>
+            <a:ext cx="2190750" cy="685800"/>
+          </a:xfrm>
+          <a:prstGeom xmlns:a="http://schemas.openxmlformats.org/drawingml/2006/main" prst="roundRect">
+            <a:avLst>
+              <a:gd name="adj" fmla="val 11111"/>
+            </a:avLst>
+          </a:prstGeom>
+          <a:solidFill xmlns:a="http://schemas.openxmlformats.org/drawingml/2006/main">
+            <a:srgbClr val="FBE8E8"/>
+          </a:solidFill>
+          <a:ln xmlns:a="http://schemas.openxmlformats.org/drawingml/2006/main" w="9525">
+            <a:solidFill>
+              <a:srgbClr val="FBE8E8"/>
+            </a:solidFill>
+            <a:prstDash val="solid"/>
+          </a:ln>
+        </p:spPr>
+        <p:txBody>
+          <a:bodyPr xmlns:a="http://schemas.openxmlformats.org/drawingml/2006/main" anchor="ctr">
+            <a:normAutofit fontScale="94911"/>
+          </a:bodyPr>
+          <a:lstStyle xmlns:a="http://schemas.openxmlformats.org/drawingml/2006/main"/>
+          <a:p xmlns:a="http://schemas.openxmlformats.org/drawingml/2006/main">
+            <a:pPr algn="ctr">
+              <a:defRPr sz="1650" b="1">
+                <a:solidFill>
+                  <a:srgbClr val="C43C45"/>
+                </a:solidFill>
+                <a:latin typeface="Helvetica Neue"/>
+                <a:ea typeface="Helvetica Neue"/>
+                <a:cs typeface="Helvetica Neue"/>
+              </a:defRPr>
+            </a:pPr>
+            <a:r>
+              <a:rPr sz="1650" b="1">
+                <a:solidFill>
+                  <a:srgbClr val="C43C45"/>
+                </a:solidFill>
+                <a:latin typeface="Helvetica Neue"/>
+                <a:ea typeface="Helvetica Neue"/>
+                <a:cs typeface="Helvetica Neue"/>
+              </a:rPr>
+              <a:t>MODEL VALIDATION</a:t>
+            </a:r>
+          </a:p>
+          <a:p xmlns:a="http://schemas.openxmlformats.org/drawingml/2006/main">
+            <a:pPr algn="ctr">
+              <a:defRPr sz="1650" b="1">
+                <a:solidFill>
+                  <a:srgbClr val="C43C45"/>
+                </a:solidFill>
+                <a:latin typeface="Helvetica Neue"/>
+                <a:ea typeface="Helvetica Neue"/>
+                <a:cs typeface="Helvetica Neue"/>
+              </a:defRPr>
+            </a:pPr>
+            <a:r>
+              <a:rPr sz="1650" b="1">
+                <a:solidFill>
+                  <a:srgbClr val="C43C45"/>
+                </a:solidFill>
+                <a:latin typeface="Helvetica Neue"/>
+                <a:ea typeface="Helvetica Neue"/>
+                <a:cs typeface="Helvetica Neue"/>
+              </a:rPr>
+              <a:t>FAILED</a:t>
+            </a:r>
+          </a:p>
+        </p:txBody>
+      </p:sp>
+      <p:sp>
+        <p:nvSpPr>
+          <p:cNvPr id="6" name="">
+            <a:extLst xmlns:a="http://schemas.openxmlformats.org/drawingml/2006/main">
+              <a:ext uri="{FF2B5EF4-FFF2-40B4-BE49-F238E27FC236}">
+                <a16:creationId xmlns:a16="http://schemas.microsoft.com/office/drawing/2014/main" id="{4BAB9D08-4186-4A0A-AA82-455F904113CB}"/>
+              </a:ext>
+            </a:extLst>
+          </p:cNvPr>
+          <p:cNvSpPr>
+            <a:spLocks xmlns:a="http://schemas.openxmlformats.org/drawingml/2006/main" noGrp="1"/>
+          </p:cNvSpPr>
+          <p:nvPr/>
+        </p:nvSpPr>
+        <p:spPr>
+          <a:xfrm xmlns:a="http://schemas.openxmlformats.org/drawingml/2006/main">
+            <a:off x="3714750" y="1285875"/>
+            <a:ext cx="2857500" cy="342900"/>
           </a:xfrm>
           <a:prstGeom xmlns:a="http://schemas.openxmlformats.org/drawingml/2006/main" prst="rect">
             <a:avLst/>
@@ -2692,121 +2779,52 @@
         </p:spPr>
         <p:txBody>
           <a:bodyPr xmlns:a="http://schemas.openxmlformats.org/drawingml/2006/main" anchor="ctr">
-            <a:normAutofit fontScale="100000"/>
+            <a:normAutofit fontScale="78571"/>
           </a:bodyPr>
           <a:lstStyle xmlns:a="http://schemas.openxmlformats.org/drawingml/2006/main"/>
           <a:p xmlns:a="http://schemas.openxmlformats.org/drawingml/2006/main">
             <a:pPr algn="l">
-              <a:defRPr sz="1650" b="0">
-                <a:solidFill>
-                  <a:srgbClr val="D7E5EC"/>
-                </a:solidFill>
-                <a:latin typeface="Helvetica Neue"/>
-                <a:ea typeface="Helvetica Neue"/>
-                <a:cs typeface="Helvetica Neue"/>
-              </a:defRPr>
-            </a:pPr>
-            <a:r>
-              <a:rPr sz="1650" b="0">
-                <a:solidFill>
-                  <a:srgbClr val="D7E5EC"/>
-                </a:solidFill>
-                <a:latin typeface="Helvetica Neue"/>
-                <a:ea typeface="Helvetica Neue"/>
-                <a:cs typeface="Helvetica Neue"/>
-              </a:rPr>
-              <a:t>Valid and invalid NCT selection</a:t>
-            </a:r>
-          </a:p>
-          <a:p xmlns:a="http://schemas.openxmlformats.org/drawingml/2006/main">
-            <a:pPr algn="l">
-              <a:defRPr sz="1650" b="0">
-                <a:solidFill>
-                  <a:srgbClr val="D7E5EC"/>
-                </a:solidFill>
-                <a:latin typeface="Helvetica Neue"/>
-                <a:ea typeface="Helvetica Neue"/>
-                <a:cs typeface="Helvetica Neue"/>
-              </a:defRPr>
-            </a:pPr>
-            <a:r>
-              <a:rPr sz="1650" b="0">
-                <a:solidFill>
-                  <a:srgbClr val="D7E5EC"/>
-                </a:solidFill>
-                <a:latin typeface="Helvetica Neue"/>
-                <a:ea typeface="Helvetica Neue"/>
-                <a:cs typeface="Helvetica Neue"/>
-              </a:rPr>
-              <a:t>Development-only fit and split integrity</a:t>
-            </a:r>
-          </a:p>
-          <a:p xmlns:a="http://schemas.openxmlformats.org/drawingml/2006/main">
-            <a:pPr algn="l">
-              <a:defRPr sz="1650" b="0">
-                <a:solidFill>
-                  <a:srgbClr val="D7E5EC"/>
-                </a:solidFill>
-                <a:latin typeface="Helvetica Neue"/>
-                <a:ea typeface="Helvetica Neue"/>
-                <a:cs typeface="Helvetica Neue"/>
-              </a:defRPr>
-            </a:pPr>
-            <a:r>
-              <a:rPr sz="1650" b="0">
-                <a:solidFill>
-                  <a:srgbClr val="D7E5EC"/>
-                </a:solidFill>
-                <a:latin typeface="Helvetica Neue"/>
-                <a:ea typeface="Helvetica Neue"/>
-                <a:cs typeface="Helvetica Neue"/>
-              </a:rPr>
-              <a:t>Probability consistency and output blocking</a:t>
-            </a:r>
-          </a:p>
-          <a:p xmlns:a="http://schemas.openxmlformats.org/drawingml/2006/main">
-            <a:pPr algn="l">
-              <a:defRPr sz="1650" b="0">
-                <a:solidFill>
-                  <a:srgbClr val="D7E5EC"/>
-                </a:solidFill>
-                <a:latin typeface="Helvetica Neue"/>
-                <a:ea typeface="Helvetica Neue"/>
-                <a:cs typeface="Helvetica Neue"/>
-              </a:defRPr>
-            </a:pPr>
-            <a:r>
-              <a:rPr sz="1650" b="0">
-                <a:solidFill>
-                  <a:srgbClr val="D7E5EC"/>
-                </a:solidFill>
-                <a:latin typeface="Helvetica Neue"/>
-                <a:ea typeface="Helvetica Neue"/>
-                <a:cs typeface="Helvetica Neue"/>
-              </a:rPr>
-              <a:t>SHAP additivity</a:t>
-            </a:r>
-          </a:p>
-        </p:txBody>
-      </p:sp>
-      <p:sp>
-        <p:nvSpPr>
-          <p:cNvPr id="6" name="">
-            <a:extLst xmlns:a="http://schemas.openxmlformats.org/drawingml/2006/main">
-              <a:ext uri="{FF2B5EF4-FFF2-40B4-BE49-F238E27FC236}">
-                <a16:creationId xmlns:a16="http://schemas.microsoft.com/office/drawing/2014/main" id="{54AE203A-8D36-422C-9DB9-779F6A256B28}"/>
-              </a:ext>
-            </a:extLst>
-          </p:cNvPr>
-          <p:cNvSpPr>
-            <a:spLocks xmlns:a="http://schemas.openxmlformats.org/drawingml/2006/main" noGrp="1"/>
-          </p:cNvSpPr>
-          <p:nvPr/>
-        </p:nvSpPr>
-        <p:spPr>
-          <a:xfrm xmlns:a="http://schemas.openxmlformats.org/drawingml/2006/main">
-            <a:off x="7715250" y="1285875"/>
-            <a:ext cx="2857500" cy="342900"/>
+              <a:defRPr sz="2100" b="1">
+                <a:solidFill>
+                  <a:srgbClr val="FFFFFF"/>
+                </a:solidFill>
+                <a:latin typeface="Helvetica Neue"/>
+                <a:ea typeface="Helvetica Neue"/>
+                <a:cs typeface="Helvetica Neue"/>
+              </a:defRPr>
+            </a:pPr>
+            <a:r>
+              <a:rPr sz="2100" b="1">
+                <a:solidFill>
+                  <a:srgbClr val="FFFFFF"/>
+                </a:solidFill>
+                <a:latin typeface="Helvetica Neue"/>
+                <a:ea typeface="Helvetica Neue"/>
+                <a:cs typeface="Helvetica Neue"/>
+              </a:rPr>
+              <a:t>Test coverage</a:t>
+            </a:r>
+          </a:p>
+        </p:txBody>
+      </p:sp>
+      <p:sp>
+        <p:nvSpPr>
+          <p:cNvPr id="7" name="">
+            <a:extLst xmlns:a="http://schemas.openxmlformats.org/drawingml/2006/main">
+              <a:ext uri="{FF2B5EF4-FFF2-40B4-BE49-F238E27FC236}">
+                <a16:creationId xmlns:a16="http://schemas.microsoft.com/office/drawing/2014/main" id="{D4F46E1B-6F47-405E-A627-F7F49EC65446}"/>
+              </a:ext>
+            </a:extLst>
+          </p:cNvPr>
+          <p:cNvSpPr>
+            <a:spLocks xmlns:a="http://schemas.openxmlformats.org/drawingml/2006/main" noGrp="1"/>
+          </p:cNvSpPr>
+          <p:nvPr/>
+        </p:nvSpPr>
+        <p:spPr>
+          <a:xfrm xmlns:a="http://schemas.openxmlformats.org/drawingml/2006/main">
+            <a:off x="3714750" y="1809750"/>
+            <a:ext cx="3476625" cy="2000250"/>
           </a:xfrm>
           <a:prstGeom xmlns:a="http://schemas.openxmlformats.org/drawingml/2006/main" prst="rect">
             <a:avLst/>
@@ -2818,52 +2836,121 @@
         </p:spPr>
         <p:txBody>
           <a:bodyPr xmlns:a="http://schemas.openxmlformats.org/drawingml/2006/main" anchor="ctr">
-            <a:normAutofit fontScale="78571"/>
+            <a:normAutofit fontScale="100000"/>
           </a:bodyPr>
           <a:lstStyle xmlns:a="http://schemas.openxmlformats.org/drawingml/2006/main"/>
           <a:p xmlns:a="http://schemas.openxmlformats.org/drawingml/2006/main">
             <a:pPr algn="l">
-              <a:defRPr sz="2100" b="1">
-                <a:solidFill>
-                  <a:srgbClr val="FFFFFF"/>
-                </a:solidFill>
-                <a:latin typeface="Helvetica Neue"/>
-                <a:ea typeface="Helvetica Neue"/>
-                <a:cs typeface="Helvetica Neue"/>
-              </a:defRPr>
-            </a:pPr>
-            <a:r>
-              <a:rPr sz="2100" b="1">
-                <a:solidFill>
-                  <a:srgbClr val="FFFFFF"/>
-                </a:solidFill>
-                <a:latin typeface="Helvetica Neue"/>
-                <a:ea typeface="Helvetica Neue"/>
-                <a:cs typeface="Helvetica Neue"/>
-              </a:rPr>
-              <a:t>Evidence and review</a:t>
-            </a:r>
-          </a:p>
-        </p:txBody>
-      </p:sp>
-      <p:sp>
-        <p:nvSpPr>
-          <p:cNvPr id="7" name="">
-            <a:extLst xmlns:a="http://schemas.openxmlformats.org/drawingml/2006/main">
-              <a:ext uri="{FF2B5EF4-FFF2-40B4-BE49-F238E27FC236}">
-                <a16:creationId xmlns:a16="http://schemas.microsoft.com/office/drawing/2014/main" id="{89BF842C-D4F7-4EA9-8223-776060F0C008}"/>
-              </a:ext>
-            </a:extLst>
-          </p:cNvPr>
-          <p:cNvSpPr>
-            <a:spLocks xmlns:a="http://schemas.openxmlformats.org/drawingml/2006/main" noGrp="1"/>
-          </p:cNvSpPr>
-          <p:nvPr/>
-        </p:nvSpPr>
-        <p:spPr>
-          <a:xfrm xmlns:a="http://schemas.openxmlformats.org/drawingml/2006/main">
-            <a:off x="7715250" y="1809750"/>
-            <a:ext cx="3333750" cy="2000250"/>
+              <a:defRPr sz="1650" b="0">
+                <a:solidFill>
+                  <a:srgbClr val="D7E5EC"/>
+                </a:solidFill>
+                <a:latin typeface="Helvetica Neue"/>
+                <a:ea typeface="Helvetica Neue"/>
+                <a:cs typeface="Helvetica Neue"/>
+              </a:defRPr>
+            </a:pPr>
+            <a:r>
+              <a:rPr sz="1650" b="0">
+                <a:solidFill>
+                  <a:srgbClr val="D7E5EC"/>
+                </a:solidFill>
+                <a:latin typeface="Helvetica Neue"/>
+                <a:ea typeface="Helvetica Neue"/>
+                <a:cs typeface="Helvetica Neue"/>
+              </a:rPr>
+              <a:t>Valid and invalid NCT selection</a:t>
+            </a:r>
+          </a:p>
+          <a:p xmlns:a="http://schemas.openxmlformats.org/drawingml/2006/main">
+            <a:pPr algn="l">
+              <a:defRPr sz="1650" b="0">
+                <a:solidFill>
+                  <a:srgbClr val="D7E5EC"/>
+                </a:solidFill>
+                <a:latin typeface="Helvetica Neue"/>
+                <a:ea typeface="Helvetica Neue"/>
+                <a:cs typeface="Helvetica Neue"/>
+              </a:defRPr>
+            </a:pPr>
+            <a:r>
+              <a:rPr sz="1650" b="0">
+                <a:solidFill>
+                  <a:srgbClr val="D7E5EC"/>
+                </a:solidFill>
+                <a:latin typeface="Helvetica Neue"/>
+                <a:ea typeface="Helvetica Neue"/>
+                <a:cs typeface="Helvetica Neue"/>
+              </a:rPr>
+              <a:t>Development-only fit and split integrity</a:t>
+            </a:r>
+          </a:p>
+          <a:p xmlns:a="http://schemas.openxmlformats.org/drawingml/2006/main">
+            <a:pPr algn="l">
+              <a:defRPr sz="1650" b="0">
+                <a:solidFill>
+                  <a:srgbClr val="D7E5EC"/>
+                </a:solidFill>
+                <a:latin typeface="Helvetica Neue"/>
+                <a:ea typeface="Helvetica Neue"/>
+                <a:cs typeface="Helvetica Neue"/>
+              </a:defRPr>
+            </a:pPr>
+            <a:r>
+              <a:rPr sz="1650" b="0">
+                <a:solidFill>
+                  <a:srgbClr val="D7E5EC"/>
+                </a:solidFill>
+                <a:latin typeface="Helvetica Neue"/>
+                <a:ea typeface="Helvetica Neue"/>
+                <a:cs typeface="Helvetica Neue"/>
+              </a:rPr>
+              <a:t>Probability consistency and output blocking</a:t>
+            </a:r>
+          </a:p>
+          <a:p xmlns:a="http://schemas.openxmlformats.org/drawingml/2006/main">
+            <a:pPr algn="l">
+              <a:defRPr sz="1650" b="0">
+                <a:solidFill>
+                  <a:srgbClr val="D7E5EC"/>
+                </a:solidFill>
+                <a:latin typeface="Helvetica Neue"/>
+                <a:ea typeface="Helvetica Neue"/>
+                <a:cs typeface="Helvetica Neue"/>
+              </a:defRPr>
+            </a:pPr>
+            <a:r>
+              <a:rPr sz="1650" b="0">
+                <a:solidFill>
+                  <a:srgbClr val="D7E5EC"/>
+                </a:solidFill>
+                <a:latin typeface="Helvetica Neue"/>
+                <a:ea typeface="Helvetica Neue"/>
+                <a:cs typeface="Helvetica Neue"/>
+              </a:rPr>
+              <a:t>SHAP additivity</a:t>
+            </a:r>
+          </a:p>
+        </p:txBody>
+      </p:sp>
+      <p:sp>
+        <p:nvSpPr>
+          <p:cNvPr id="8" name="">
+            <a:extLst xmlns:a="http://schemas.openxmlformats.org/drawingml/2006/main">
+              <a:ext uri="{FF2B5EF4-FFF2-40B4-BE49-F238E27FC236}">
+                <a16:creationId xmlns:a16="http://schemas.microsoft.com/office/drawing/2014/main" id="{8802F08E-559C-4ED2-A33E-3CEA20A9DCA9}"/>
+              </a:ext>
+            </a:extLst>
+          </p:cNvPr>
+          <p:cNvSpPr>
+            <a:spLocks xmlns:a="http://schemas.openxmlformats.org/drawingml/2006/main" noGrp="1"/>
+          </p:cNvSpPr>
+          <p:nvPr/>
+        </p:nvSpPr>
+        <p:spPr>
+          <a:xfrm xmlns:a="http://schemas.openxmlformats.org/drawingml/2006/main">
+            <a:off x="7715250" y="1285875"/>
+            <a:ext cx="2857500" cy="342900"/>
           </a:xfrm>
           <a:prstGeom xmlns:a="http://schemas.openxmlformats.org/drawingml/2006/main" prst="rect">
             <a:avLst/>
@@ -2875,6 +2962,63 @@
         </p:spPr>
         <p:txBody>
           <a:bodyPr xmlns:a="http://schemas.openxmlformats.org/drawingml/2006/main" anchor="ctr">
+            <a:normAutofit fontScale="78571"/>
+          </a:bodyPr>
+          <a:lstStyle xmlns:a="http://schemas.openxmlformats.org/drawingml/2006/main"/>
+          <a:p xmlns:a="http://schemas.openxmlformats.org/drawingml/2006/main">
+            <a:pPr algn="l">
+              <a:defRPr sz="2100" b="1">
+                <a:solidFill>
+                  <a:srgbClr val="FFFFFF"/>
+                </a:solidFill>
+                <a:latin typeface="Helvetica Neue"/>
+                <a:ea typeface="Helvetica Neue"/>
+                <a:cs typeface="Helvetica Neue"/>
+              </a:defRPr>
+            </a:pPr>
+            <a:r>
+              <a:rPr sz="2100" b="1">
+                <a:solidFill>
+                  <a:srgbClr val="FFFFFF"/>
+                </a:solidFill>
+                <a:latin typeface="Helvetica Neue"/>
+                <a:ea typeface="Helvetica Neue"/>
+                <a:cs typeface="Helvetica Neue"/>
+              </a:rPr>
+              <a:t>Evidence and review</a:t>
+            </a:r>
+          </a:p>
+        </p:txBody>
+      </p:sp>
+      <p:sp>
+        <p:nvSpPr>
+          <p:cNvPr id="9" name="">
+            <a:extLst xmlns:a="http://schemas.openxmlformats.org/drawingml/2006/main">
+              <a:ext uri="{FF2B5EF4-FFF2-40B4-BE49-F238E27FC236}">
+                <a16:creationId xmlns:a16="http://schemas.microsoft.com/office/drawing/2014/main" id="{A3DA198F-C16A-4451-B7D1-FA7672752BF7}"/>
+              </a:ext>
+            </a:extLst>
+          </p:cNvPr>
+          <p:cNvSpPr>
+            <a:spLocks xmlns:a="http://schemas.openxmlformats.org/drawingml/2006/main" noGrp="1"/>
+          </p:cNvSpPr>
+          <p:nvPr/>
+        </p:nvSpPr>
+        <p:spPr>
+          <a:xfrm xmlns:a="http://schemas.openxmlformats.org/drawingml/2006/main">
+            <a:off x="7715250" y="1809750"/>
+            <a:ext cx="3333750" cy="2000250"/>
+          </a:xfrm>
+          <a:prstGeom xmlns:a="http://schemas.openxmlformats.org/drawingml/2006/main" prst="rect">
+            <a:avLst/>
+          </a:prstGeom>
+          <a:noFill xmlns:a="http://schemas.openxmlformats.org/drawingml/2006/main"/>
+          <a:ln xmlns:a="http://schemas.openxmlformats.org/drawingml/2006/main" w="0">
+            <a:noFill/>
+          </a:ln>
+        </p:spPr>
+        <p:txBody>
+          <a:bodyPr xmlns:a="http://schemas.openxmlformats.org/drawingml/2006/main" anchor="ctr">
             <a:normAutofit fontScale="100000"/>
           </a:bodyPr>
           <a:lstStyle xmlns:a="http://schemas.openxmlformats.org/drawingml/2006/main"/>
@@ -2974,10 +3118,10 @@
       </p:sp>
       <p:sp>
         <p:nvSpPr>
-          <p:cNvPr id="8" name="">
-            <a:extLst xmlns:a="http://schemas.openxmlformats.org/drawingml/2006/main">
-              <a:ext uri="{FF2B5EF4-FFF2-40B4-BE49-F238E27FC236}">
-                <a16:creationId xmlns:a16="http://schemas.microsoft.com/office/drawing/2014/main" id="{7B9EAE14-81EB-4D09-B3A1-371D94DD5462}"/>
+          <p:cNvPr id="10" name="">
+            <a:extLst xmlns:a="http://schemas.openxmlformats.org/drawingml/2006/main">
+              <a:ext uri="{FF2B5EF4-FFF2-40B4-BE49-F238E27FC236}">
+                <a16:creationId xmlns:a16="http://schemas.microsoft.com/office/drawing/2014/main" id="{B1AC9992-904D-4093-9BB5-904B56025FBD}"/>
               </a:ext>
             </a:extLst>
           </p:cNvPr>
@@ -3004,10 +3148,10 @@
       </p:sp>
       <p:sp>
         <p:nvSpPr>
-          <p:cNvPr id="9" name="">
-            <a:extLst xmlns:a="http://schemas.openxmlformats.org/drawingml/2006/main">
-              <a:ext uri="{FF2B5EF4-FFF2-40B4-BE49-F238E27FC236}">
-                <a16:creationId xmlns:a16="http://schemas.microsoft.com/office/drawing/2014/main" id="{556F1511-3778-427E-A215-858CBAFB6BBB}"/>
+          <p:cNvPr id="11" name="">
+            <a:extLst xmlns:a="http://schemas.openxmlformats.org/drawingml/2006/main">
+              <a:ext uri="{FF2B5EF4-FFF2-40B4-BE49-F238E27FC236}">
+                <a16:creationId xmlns:a16="http://schemas.microsoft.com/office/drawing/2014/main" id="{6E9F039B-F972-4337-BE9B-6DEC27F7D09B}"/>
               </a:ext>
             </a:extLst>
           </p:cNvPr>
@@ -3061,10 +3205,10 @@
       </p:sp>
       <p:sp>
         <p:nvSpPr>
-          <p:cNvPr id="10" name="">
-            <a:extLst xmlns:a="http://schemas.openxmlformats.org/drawingml/2006/main">
-              <a:ext uri="{FF2B5EF4-FFF2-40B4-BE49-F238E27FC236}">
-                <a16:creationId xmlns:a16="http://schemas.microsoft.com/office/drawing/2014/main" id="{5B7F5D73-6724-4FAB-9BF6-836A2D77B340}"/>
+          <p:cNvPr id="12" name="">
+            <a:extLst xmlns:a="http://schemas.openxmlformats.org/drawingml/2006/main">
+              <a:ext uri="{FF2B5EF4-FFF2-40B4-BE49-F238E27FC236}">
+                <a16:creationId xmlns:a16="http://schemas.microsoft.com/office/drawing/2014/main" id="{F44CF739-1389-4D61-A910-260C12302876}"/>
               </a:ext>
             </a:extLst>
           </p:cNvPr>
@@ -3118,10 +3262,10 @@
       </p:sp>
       <p:sp>
         <p:nvSpPr>
-          <p:cNvPr id="11" name="">
-            <a:extLst xmlns:a="http://schemas.openxmlformats.org/drawingml/2006/main">
-              <a:ext uri="{FF2B5EF4-FFF2-40B4-BE49-F238E27FC236}">
-                <a16:creationId xmlns:a16="http://schemas.microsoft.com/office/drawing/2014/main" id="{54BF21DA-09E3-40E0-8A29-9FF4CE9AFE14}"/>
+          <p:cNvPr id="13" name="">
+            <a:extLst xmlns:a="http://schemas.openxmlformats.org/drawingml/2006/main">
+              <a:ext uri="{FF2B5EF4-FFF2-40B4-BE49-F238E27FC236}">
+                <a16:creationId xmlns:a16="http://schemas.microsoft.com/office/drawing/2014/main" id="{FC59E47E-E18F-4503-8858-3AE1839260CF}"/>
               </a:ext>
             </a:extLst>
           </p:cNvPr>
@@ -3175,10 +3319,10 @@
       </p:sp>
       <p:sp>
         <p:nvSpPr>
-          <p:cNvPr id="12" name="">
-            <a:extLst xmlns:a="http://schemas.openxmlformats.org/drawingml/2006/main">
-              <a:ext uri="{FF2B5EF4-FFF2-40B4-BE49-F238E27FC236}">
-                <a16:creationId xmlns:a16="http://schemas.microsoft.com/office/drawing/2014/main" id="{03595411-6C40-4045-86A2-3AE948B32B3D}"/>
+          <p:cNvPr id="14" name="">
+            <a:extLst xmlns:a="http://schemas.openxmlformats.org/drawingml/2006/main">
+              <a:ext uri="{FF2B5EF4-FFF2-40B4-BE49-F238E27FC236}">
+                <a16:creationId xmlns:a16="http://schemas.microsoft.com/office/drawing/2014/main" id="{D7E756B3-3B54-4FC4-92C4-11C26124AFC3}"/>
               </a:ext>
             </a:extLst>
           </p:cNvPr>
@@ -3232,10 +3376,10 @@
       </p:sp>
       <p:sp>
         <p:nvSpPr>
-          <p:cNvPr id="13" name="">
-            <a:extLst xmlns:a="http://schemas.openxmlformats.org/drawingml/2006/main">
-              <a:ext uri="{FF2B5EF4-FFF2-40B4-BE49-F238E27FC236}">
-                <a16:creationId xmlns:a16="http://schemas.microsoft.com/office/drawing/2014/main" id="{4A23C3C4-0427-4639-B03C-BCCEF48248D2}"/>
+          <p:cNvPr id="15" name="">
+            <a:extLst xmlns:a="http://schemas.openxmlformats.org/drawingml/2006/main">
+              <a:ext uri="{FF2B5EF4-FFF2-40B4-BE49-F238E27FC236}">
+                <a16:creationId xmlns:a16="http://schemas.microsoft.com/office/drawing/2014/main" id="{3FBC1C37-B486-4DC2-BF62-C89AB02EEDCA}"/>
               </a:ext>
             </a:extLst>
           </p:cNvPr>
@@ -3289,10 +3433,10 @@
       </p:sp>
       <p:sp>
         <p:nvSpPr>
-          <p:cNvPr id="14" name="">
-            <a:extLst xmlns:a="http://schemas.openxmlformats.org/drawingml/2006/main">
-              <a:ext uri="{FF2B5EF4-FFF2-40B4-BE49-F238E27FC236}">
-                <a16:creationId xmlns:a16="http://schemas.microsoft.com/office/drawing/2014/main" id="{5E5FBE97-FC0E-4921-8C20-5486814062F0}"/>
+          <p:cNvPr id="16" name="">
+            <a:extLst xmlns:a="http://schemas.openxmlformats.org/drawingml/2006/main">
+              <a:ext uri="{FF2B5EF4-FFF2-40B4-BE49-F238E27FC236}">
+                <a16:creationId xmlns:a16="http://schemas.microsoft.com/office/drawing/2014/main" id="{1C0B2171-AC3A-4589-BDC5-3B8C9D4E8DB7}"/>
               </a:ext>
             </a:extLst>
           </p:cNvPr>
@@ -3316,7 +3460,7 @@
         </p:spPr>
         <p:txBody>
           <a:bodyPr xmlns:a="http://schemas.openxmlformats.org/drawingml/2006/main" anchor="ctr">
-            <a:normAutofit fontScale="94711"/>
+            <a:normAutofit fontScale="100000"/>
           </a:bodyPr>
           <a:lstStyle xmlns:a="http://schemas.openxmlformats.org/drawingml/2006/main"/>
           <a:p xmlns:a="http://schemas.openxmlformats.org/drawingml/2006/main">
@@ -3339,17 +3483,17 @@
                 <a:ea typeface="Helvetica Neue"/>
                 <a:cs typeface="Helvetica Neue"/>
               </a:rPr>
-              <a:t>Publish the approved repository, then revisit historical predictors when a supported source exists</a:t>
-            </a:r>
-          </a:p>
-        </p:txBody>
-      </p:sp>
-      <p:sp>
-        <p:nvSpPr>
-          <p:cNvPr id="15" name="">
-            <a:extLst xmlns:a="http://schemas.openxmlformats.org/drawingml/2006/main">
-              <a:ext uri="{FF2B5EF4-FFF2-40B4-BE49-F238E27FC236}">
-                <a16:creationId xmlns:a16="http://schemas.microsoft.com/office/drawing/2014/main" id="{F686E731-F0F7-4879-9AB7-4B245B56F015}"/>
+              <a:t>Obtain verified historical predictors and add durable review storage before operational use</a:t>
+            </a:r>
+          </a:p>
+        </p:txBody>
+      </p:sp>
+      <p:sp>
+        <p:nvSpPr>
+          <p:cNvPr id="17" name="">
+            <a:extLst xmlns:a="http://schemas.openxmlformats.org/drawingml/2006/main">
+              <a:ext uri="{FF2B5EF4-FFF2-40B4-BE49-F238E27FC236}">
+                <a16:creationId xmlns:a16="http://schemas.microsoft.com/office/drawing/2014/main" id="{3C949F4D-D70B-48A9-83B4-505109062671}"/>
               </a:ext>
             </a:extLst>
           </p:cNvPr>
@@ -3404,7 +3548,7 @@
     </p:spTree>
     <p:extLst>
       <p:ext uri="{BB962C8B-B14F-4D97-AF65-F5344CB8AC3E}">
-        <p14:creationId xmlns:p14="http://schemas.microsoft.com/office/powerpoint/2010/main" val="1017201156"/>
+        <p14:creationId xmlns:p14="http://schemas.microsoft.com/office/powerpoint/2010/main" val="150757863"/>
       </p:ext>
     </p:extLst>
   </p:cSld>
@@ -3435,7 +3579,7 @@
           <p:cNvPr id="12" name="">
             <a:extLst xmlns:a="http://schemas.openxmlformats.org/drawingml/2006/main">
               <a:ext uri="{FF2B5EF4-FFF2-40B4-BE49-F238E27FC236}">
-                <a16:creationId xmlns:a16="http://schemas.microsoft.com/office/drawing/2014/main" id="{B6832A27-533F-4F6C-BDB8-F397D774E26E}"/>
+                <a16:creationId xmlns:a16="http://schemas.microsoft.com/office/drawing/2014/main" id="{379C2017-0569-44F6-8EC7-75B09EFA1CF4}"/>
               </a:ext>
             </a:extLst>
           </p:cNvPr>
@@ -3492,7 +3636,7 @@
           <p:cNvPr id="2" name="">
             <a:extLst xmlns:a="http://schemas.openxmlformats.org/drawingml/2006/main">
               <a:ext uri="{FF2B5EF4-FFF2-40B4-BE49-F238E27FC236}">
-                <a16:creationId xmlns:a16="http://schemas.microsoft.com/office/drawing/2014/main" id="{2FBB9F19-4D98-4343-BA6E-C335BCD61E18}"/>
+                <a16:creationId xmlns:a16="http://schemas.microsoft.com/office/drawing/2014/main" id="{74A494D5-3569-4380-BC83-E1BE60071778}"/>
               </a:ext>
             </a:extLst>
           </p:cNvPr>
@@ -3549,7 +3693,7 @@
           <p:cNvPr id="3" name="">
             <a:extLst xmlns:a="http://schemas.openxmlformats.org/drawingml/2006/main">
               <a:ext uri="{FF2B5EF4-FFF2-40B4-BE49-F238E27FC236}">
-                <a16:creationId xmlns:a16="http://schemas.microsoft.com/office/drawing/2014/main" id="{E5455645-9FBD-4972-8C71-5D970F8C5D2E}"/>
+                <a16:creationId xmlns:a16="http://schemas.microsoft.com/office/drawing/2014/main" id="{9B0625AE-7F91-4195-A3B3-5611593DFF19}"/>
               </a:ext>
             </a:extLst>
           </p:cNvPr>
@@ -3580,7 +3724,7 @@
           <p:cNvPr id="4" name="">
             <a:extLst xmlns:a="http://schemas.openxmlformats.org/drawingml/2006/main">
               <a:ext uri="{FF2B5EF4-FFF2-40B4-BE49-F238E27FC236}">
-                <a16:creationId xmlns:a16="http://schemas.microsoft.com/office/drawing/2014/main" id="{7F76059E-87C0-4AA5-BF20-00ADCAEA9907}"/>
+                <a16:creationId xmlns:a16="http://schemas.microsoft.com/office/drawing/2014/main" id="{D81A1824-549E-43AE-88C0-0ED05A5A533C}"/>
               </a:ext>
             </a:extLst>
           </p:cNvPr>
@@ -3718,7 +3862,7 @@
           <p:cNvPr id="5" name="">
             <a:extLst xmlns:a="http://schemas.openxmlformats.org/drawingml/2006/main">
               <a:ext uri="{FF2B5EF4-FFF2-40B4-BE49-F238E27FC236}">
-                <a16:creationId xmlns:a16="http://schemas.microsoft.com/office/drawing/2014/main" id="{35441CF2-3011-49E5-BF99-AB6D0BE42639}"/>
+                <a16:creationId xmlns:a16="http://schemas.microsoft.com/office/drawing/2014/main" id="{365DFB68-A86D-4E4C-80DC-0F8868FD6EBD}"/>
               </a:ext>
             </a:extLst>
           </p:cNvPr>
@@ -3879,7 +4023,7 @@
           <p:cNvPr id="6" name="">
             <a:extLst xmlns:a="http://schemas.openxmlformats.org/drawingml/2006/main">
               <a:ext uri="{FF2B5EF4-FFF2-40B4-BE49-F238E27FC236}">
-                <a16:creationId xmlns:a16="http://schemas.microsoft.com/office/drawing/2014/main" id="{C7D38E10-E9BD-48BA-B900-F73B3885BB83}"/>
+                <a16:creationId xmlns:a16="http://schemas.microsoft.com/office/drawing/2014/main" id="{5A1878BE-D948-45D7-8447-E9EC97E10EB1}"/>
               </a:ext>
             </a:extLst>
           </p:cNvPr>
@@ -4040,7 +4184,7 @@
           <p:cNvPr id="7" name="">
             <a:extLst xmlns:a="http://schemas.openxmlformats.org/drawingml/2006/main">
               <a:ext uri="{FF2B5EF4-FFF2-40B4-BE49-F238E27FC236}">
-                <a16:creationId xmlns:a16="http://schemas.microsoft.com/office/drawing/2014/main" id="{36C07D18-674D-41ED-8E6E-86C165573749}"/>
+                <a16:creationId xmlns:a16="http://schemas.microsoft.com/office/drawing/2014/main" id="{D2013C5C-C799-48DD-9265-028B798A0688}"/>
               </a:ext>
             </a:extLst>
           </p:cNvPr>
@@ -4072,7 +4216,7 @@
           <p:cNvPr id="8" name="">
             <a:extLst xmlns:a="http://schemas.openxmlformats.org/drawingml/2006/main">
               <a:ext uri="{FF2B5EF4-FFF2-40B4-BE49-F238E27FC236}">
-                <a16:creationId xmlns:a16="http://schemas.microsoft.com/office/drawing/2014/main" id="{B120883D-762F-4F0C-9085-0DC591C24784}"/>
+                <a16:creationId xmlns:a16="http://schemas.microsoft.com/office/drawing/2014/main" id="{FB1E9C1D-5F09-465B-A29F-3D3F6AAD4C92}"/>
               </a:ext>
             </a:extLst>
           </p:cNvPr>
@@ -4104,19 +4248,19 @@
           <p:cNvPr id="9" name="">
             <a:extLst xmlns:a="http://schemas.openxmlformats.org/drawingml/2006/main">
               <a:ext uri="{FF2B5EF4-FFF2-40B4-BE49-F238E27FC236}">
-                <a16:creationId xmlns:a16="http://schemas.microsoft.com/office/drawing/2014/main" id="{8B24B816-8051-4C8E-BC73-89431D1B993D}"/>
-              </a:ext>
-            </a:extLst>
-          </p:cNvPr>
-          <p:cNvSpPr>
-            <a:spLocks xmlns:a="http://schemas.openxmlformats.org/drawingml/2006/main" noGrp="1"/>
-          </p:cNvSpPr>
-          <p:nvPr/>
-        </p:nvSpPr>
-        <p:spPr>
-          <a:xfrm xmlns:a="http://schemas.openxmlformats.org/drawingml/2006/main">
-            <a:off x="1809750" y="5381625"/>
-            <a:ext cx="8572500" cy="438150"/>
+                <a16:creationId xmlns:a16="http://schemas.microsoft.com/office/drawing/2014/main" id="{C6079861-9FE5-4767-982A-7372C2DFB1DB}"/>
+              </a:ext>
+            </a:extLst>
+          </p:cNvPr>
+          <p:cNvSpPr>
+            <a:spLocks xmlns:a="http://schemas.openxmlformats.org/drawingml/2006/main" noGrp="1"/>
+          </p:cNvSpPr>
+          <p:nvPr/>
+        </p:nvSpPr>
+        <p:spPr>
+          <a:xfrm xmlns:a="http://schemas.openxmlformats.org/drawingml/2006/main">
+            <a:off x="1571625" y="5381625"/>
+            <a:ext cx="9048750" cy="438150"/>
           </a:xfrm>
           <a:prstGeom xmlns:a="http://schemas.openxmlformats.org/drawingml/2006/main" prst="rect">
             <a:avLst/>
@@ -4128,12 +4272,12 @@
         </p:spPr>
         <p:txBody>
           <a:bodyPr xmlns:a="http://schemas.openxmlformats.org/drawingml/2006/main" anchor="ctr">
-            <a:normAutofit fontScale="78724"/>
+            <a:normAutofit fontScale="100000"/>
           </a:bodyPr>
           <a:lstStyle xmlns:a="http://schemas.openxmlformats.org/drawingml/2006/main"/>
           <a:p xmlns:a="http://schemas.openxmlformats.org/drawingml/2006/main">
             <a:pPr algn="ctr">
-              <a:defRPr sz="2025" b="1">
+              <a:defRPr sz="1875" b="1">
                 <a:solidFill>
                   <a:srgbClr val="13283C"/>
                 </a:solidFill>
@@ -4143,7 +4287,7 @@
               </a:defRPr>
             </a:pPr>
             <a:r>
-              <a:rPr sz="2025" b="1">
+              <a:rPr sz="1875" b="1">
                 <a:solidFill>
                   <a:srgbClr val="13283C"/>
                 </a:solidFill>
@@ -4151,7 +4295,7 @@
                 <a:ea typeface="Helvetica Neue"/>
                 <a:cs typeface="Helvetica Neue"/>
               </a:rPr>
-              <a:t>Human review preserved the scientific constraint instead of forcing a successful demo.</a:t>
+              <a:t>Working task: Model-release readiness review for a selected clinical trial.</a:t>
             </a:r>
           </a:p>
         </p:txBody>
@@ -4161,7 +4305,7 @@
           <p:cNvPr id="10" name="">
             <a:extLst xmlns:a="http://schemas.openxmlformats.org/drawingml/2006/main">
               <a:ext uri="{FF2B5EF4-FFF2-40B4-BE49-F238E27FC236}">
-                <a16:creationId xmlns:a16="http://schemas.microsoft.com/office/drawing/2014/main" id="{665C11C1-FF27-4513-AE07-DB2F9016D040}"/>
+                <a16:creationId xmlns:a16="http://schemas.microsoft.com/office/drawing/2014/main" id="{203513D5-67AC-4C7C-9EA7-7BE1F777EEA0}"/>
               </a:ext>
             </a:extLst>
           </p:cNvPr>
@@ -4218,7 +4362,7 @@
           <p:cNvPr id="11" name="">
             <a:extLst xmlns:a="http://schemas.openxmlformats.org/drawingml/2006/main">
               <a:ext uri="{FF2B5EF4-FFF2-40B4-BE49-F238E27FC236}">
-                <a16:creationId xmlns:a16="http://schemas.microsoft.com/office/drawing/2014/main" id="{270CFD68-5F35-4AE0-B15E-021E99E82CE4}"/>
+                <a16:creationId xmlns:a16="http://schemas.microsoft.com/office/drawing/2014/main" id="{EB5CADC7-B33A-45D5-A0DC-560D3C1DAAE7}"/>
               </a:ext>
             </a:extLst>
           </p:cNvPr>
@@ -4273,7 +4417,7 @@
     </p:spTree>
     <p:extLst>
       <p:ext uri="{BB962C8B-B14F-4D97-AF65-F5344CB8AC3E}">
-        <p14:creationId xmlns:p14="http://schemas.microsoft.com/office/powerpoint/2010/main" val="1026317435"/>
+        <p14:creationId xmlns:p14="http://schemas.microsoft.com/office/powerpoint/2010/main" val="755129276"/>
       </p:ext>
     </p:extLst>
   </p:cSld>
@@ -4304,7 +4448,7 @@
           <p:cNvPr id="20" name="">
             <a:extLst xmlns:a="http://schemas.openxmlformats.org/drawingml/2006/main">
               <a:ext uri="{FF2B5EF4-FFF2-40B4-BE49-F238E27FC236}">
-                <a16:creationId xmlns:a16="http://schemas.microsoft.com/office/drawing/2014/main" id="{80E80A8D-6D0B-4A63-A18B-8BFE26B227CD}"/>
+                <a16:creationId xmlns:a16="http://schemas.microsoft.com/office/drawing/2014/main" id="{4ED04C7E-DEC3-48BB-84A7-2B9C0FAB97F5}"/>
               </a:ext>
             </a:extLst>
           </p:cNvPr>
@@ -4361,7 +4505,7 @@
           <p:cNvPr id="2" name="">
             <a:extLst xmlns:a="http://schemas.openxmlformats.org/drawingml/2006/main">
               <a:ext uri="{FF2B5EF4-FFF2-40B4-BE49-F238E27FC236}">
-                <a16:creationId xmlns:a16="http://schemas.microsoft.com/office/drawing/2014/main" id="{CD266349-6F4E-420A-B093-53E20E253E1F}"/>
+                <a16:creationId xmlns:a16="http://schemas.microsoft.com/office/drawing/2014/main" id="{4874FBB4-D709-4EE3-AD7E-953E3A5EAA5C}"/>
               </a:ext>
             </a:extLst>
           </p:cNvPr>
@@ -4408,7 +4552,7 @@
                 <a:ea typeface="Helvetica Neue"/>
                 <a:cs typeface="Helvetica Neue"/>
               </a:rPr>
-              <a:t>The validation gate controls whether trial-level results may appear</a:t>
+              <a:t>Model-release readiness review for a selected clinical trial</a:t>
             </a:r>
           </a:p>
         </p:txBody>
@@ -4418,7 +4562,7 @@
           <p:cNvPr id="3" name="">
             <a:extLst xmlns:a="http://schemas.openxmlformats.org/drawingml/2006/main">
               <a:ext uri="{FF2B5EF4-FFF2-40B4-BE49-F238E27FC236}">
-                <a16:creationId xmlns:a16="http://schemas.microsoft.com/office/drawing/2014/main" id="{96977C8A-D3B4-41B4-B3D2-E23C495A5192}"/>
+                <a16:creationId xmlns:a16="http://schemas.microsoft.com/office/drawing/2014/main" id="{3C83F8E2-3516-484E-B078-3BCE648ECF9B}"/>
               </a:ext>
             </a:extLst>
           </p:cNvPr>
@@ -4449,7 +4593,7 @@
           <p:cNvPr id="4" name="">
             <a:extLst xmlns:a="http://schemas.openxmlformats.org/drawingml/2006/main">
               <a:ext uri="{FF2B5EF4-FFF2-40B4-BE49-F238E27FC236}">
-                <a16:creationId xmlns:a16="http://schemas.microsoft.com/office/drawing/2014/main" id="{79303ACD-E5D8-4E7E-BAB9-7FD5D59BFA7E}"/>
+                <a16:creationId xmlns:a16="http://schemas.microsoft.com/office/drawing/2014/main" id="{EF9DB6F4-0810-43B7-B802-65A4AC57AA9C}"/>
               </a:ext>
             </a:extLst>
           </p:cNvPr>
@@ -4513,7 +4657,7 @@
           <p:cNvPr id="5" name="">
             <a:extLst xmlns:a="http://schemas.openxmlformats.org/drawingml/2006/main">
               <a:ext uri="{FF2B5EF4-FFF2-40B4-BE49-F238E27FC236}">
-                <a16:creationId xmlns:a16="http://schemas.microsoft.com/office/drawing/2014/main" id="{2AA67DAF-0A01-4AD5-B5B2-2024C8F3ABAF}"/>
+                <a16:creationId xmlns:a16="http://schemas.microsoft.com/office/drawing/2014/main" id="{88692327-8E94-4E34-8BF3-0F18A005D973}"/>
               </a:ext>
             </a:extLst>
           </p:cNvPr>
@@ -4545,7 +4689,7 @@
           <p:cNvPr id="6" name="">
             <a:extLst xmlns:a="http://schemas.openxmlformats.org/drawingml/2006/main">
               <a:ext uri="{FF2B5EF4-FFF2-40B4-BE49-F238E27FC236}">
-                <a16:creationId xmlns:a16="http://schemas.microsoft.com/office/drawing/2014/main" id="{AF1FA6A2-30C1-4F59-AA87-6967FCCCC4EF}"/>
+                <a16:creationId xmlns:a16="http://schemas.microsoft.com/office/drawing/2014/main" id="{DBA8596F-7A5E-4379-97FC-E15E1C347C14}"/>
               </a:ext>
             </a:extLst>
           </p:cNvPr>
@@ -4632,7 +4776,7 @@
           <p:cNvPr id="7" name="">
             <a:extLst xmlns:a="http://schemas.openxmlformats.org/drawingml/2006/main">
               <a:ext uri="{FF2B5EF4-FFF2-40B4-BE49-F238E27FC236}">
-                <a16:creationId xmlns:a16="http://schemas.microsoft.com/office/drawing/2014/main" id="{66F57A0F-B866-4ED6-87D1-7957C702112F}"/>
+                <a16:creationId xmlns:a16="http://schemas.microsoft.com/office/drawing/2014/main" id="{03B197EF-7252-4DA3-A781-5387CFDA4737}"/>
               </a:ext>
             </a:extLst>
           </p:cNvPr>
@@ -4664,7 +4808,7 @@
           <p:cNvPr id="8" name="">
             <a:extLst xmlns:a="http://schemas.openxmlformats.org/drawingml/2006/main">
               <a:ext uri="{FF2B5EF4-FFF2-40B4-BE49-F238E27FC236}">
-                <a16:creationId xmlns:a16="http://schemas.microsoft.com/office/drawing/2014/main" id="{F85F3CF6-4E54-4EB4-82E2-B2AADF1AB681}"/>
+                <a16:creationId xmlns:a16="http://schemas.microsoft.com/office/drawing/2014/main" id="{BD787210-BCBC-4CFC-A6B1-2638F084BBFF}"/>
               </a:ext>
             </a:extLst>
           </p:cNvPr>
@@ -4718,7 +4862,7 @@
                 <a:ea typeface="Helvetica Neue"/>
                 <a:cs typeface="Helvetica Neue"/>
               </a:rPr>
-              <a:t>Run temporal</a:t>
+              <a:t>Check model</a:t>
             </a:r>
           </a:p>
           <a:p xmlns:a="http://schemas.openxmlformats.org/drawingml/2006/main">
@@ -4741,7 +4885,7 @@
                 <a:ea typeface="Helvetica Neue"/>
                 <a:cs typeface="Helvetica Neue"/>
               </a:rPr>
-              <a:t>baseline</a:t>
+              <a:t>validation</a:t>
             </a:r>
           </a:p>
         </p:txBody>
@@ -4751,7 +4895,7 @@
           <p:cNvPr id="9" name="">
             <a:extLst xmlns:a="http://schemas.openxmlformats.org/drawingml/2006/main">
               <a:ext uri="{FF2B5EF4-FFF2-40B4-BE49-F238E27FC236}">
-                <a16:creationId xmlns:a16="http://schemas.microsoft.com/office/drawing/2014/main" id="{9D29887A-9731-4097-84F8-783CD827AF27}"/>
+                <a16:creationId xmlns:a16="http://schemas.microsoft.com/office/drawing/2014/main" id="{61D21C26-BB08-46B6-BA23-FAC235AD0D6F}"/>
               </a:ext>
             </a:extLst>
           </p:cNvPr>
@@ -4783,7 +4927,7 @@
           <p:cNvPr id="10" name="">
             <a:extLst xmlns:a="http://schemas.openxmlformats.org/drawingml/2006/main">
               <a:ext uri="{FF2B5EF4-FFF2-40B4-BE49-F238E27FC236}">
-                <a16:creationId xmlns:a16="http://schemas.microsoft.com/office/drawing/2014/main" id="{E2EBC096-B01B-43D6-AB08-7D5420F635B8}"/>
+                <a16:creationId xmlns:a16="http://schemas.microsoft.com/office/drawing/2014/main" id="{47A2E997-7784-4F3F-B17B-E3BF2EEC9DE2}"/>
               </a:ext>
             </a:extLst>
           </p:cNvPr>
@@ -4837,7 +4981,7 @@
                 <a:ea typeface="Helvetica Neue"/>
                 <a:cs typeface="Helvetica Neue"/>
               </a:rPr>
-              <a:t>Apply validation</a:t>
+              <a:t>Read model</a:t>
             </a:r>
           </a:p>
           <a:p xmlns:a="http://schemas.openxmlformats.org/drawingml/2006/main">
@@ -4860,7 +5004,7 @@
                 <a:ea typeface="Helvetica Neue"/>
                 <a:cs typeface="Helvetica Neue"/>
               </a:rPr>
-              <a:t>release gate</a:t>
+              <a:t>release status</a:t>
             </a:r>
           </a:p>
         </p:txBody>
@@ -4870,7 +5014,7 @@
           <p:cNvPr id="11" name="">
             <a:extLst xmlns:a="http://schemas.openxmlformats.org/drawingml/2006/main">
               <a:ext uri="{FF2B5EF4-FFF2-40B4-BE49-F238E27FC236}">
-                <a16:creationId xmlns:a16="http://schemas.microsoft.com/office/drawing/2014/main" id="{C6103DBE-09CB-4777-A439-C62EEA1483B6}"/>
+                <a16:creationId xmlns:a16="http://schemas.microsoft.com/office/drawing/2014/main" id="{D323B510-B1C1-4324-9718-58A421578148}"/>
               </a:ext>
             </a:extLst>
           </p:cNvPr>
@@ -4902,7 +5046,7 @@
           <p:cNvPr id="12" name="">
             <a:extLst xmlns:a="http://schemas.openxmlformats.org/drawingml/2006/main">
               <a:ext uri="{FF2B5EF4-FFF2-40B4-BE49-F238E27FC236}">
-                <a16:creationId xmlns:a16="http://schemas.microsoft.com/office/drawing/2014/main" id="{30CB6519-F6A9-48D2-B721-B30B46D44FA8}"/>
+                <a16:creationId xmlns:a16="http://schemas.microsoft.com/office/drawing/2014/main" id="{74052FF8-414A-4D13-B94B-950909AF4B8E}"/>
               </a:ext>
             </a:extLst>
           </p:cNvPr>
@@ -4956,7 +5100,7 @@
                 <a:ea typeface="Helvetica Neue"/>
                 <a:cs typeface="Helvetica Neue"/>
               </a:rPr>
-              <a:t>Block</a:t>
+              <a:t>Display grounded</a:t>
             </a:r>
           </a:p>
           <a:p xmlns:a="http://schemas.openxmlformats.org/drawingml/2006/main">
@@ -4979,7 +5123,7 @@
                 <a:ea typeface="Helvetica Neue"/>
                 <a:cs typeface="Helvetica Neue"/>
               </a:rPr>
-              <a:t>risk output</a:t>
+              <a:t>BLOCKED result</a:t>
             </a:r>
           </a:p>
         </p:txBody>
@@ -4989,7 +5133,7 @@
           <p:cNvPr id="13" name="">
             <a:extLst xmlns:a="http://schemas.openxmlformats.org/drawingml/2006/main">
               <a:ext uri="{FF2B5EF4-FFF2-40B4-BE49-F238E27FC236}">
-                <a16:creationId xmlns:a16="http://schemas.microsoft.com/office/drawing/2014/main" id="{AE4F7A55-68DB-4E18-8153-181D6301D771}"/>
+                <a16:creationId xmlns:a16="http://schemas.microsoft.com/office/drawing/2014/main" id="{35B69BCC-7304-4682-864F-A0A738394A6B}"/>
               </a:ext>
             </a:extLst>
           </p:cNvPr>
@@ -5021,7 +5165,7 @@
           <p:cNvPr id="14" name="">
             <a:extLst xmlns:a="http://schemas.openxmlformats.org/drawingml/2006/main">
               <a:ext uri="{FF2B5EF4-FFF2-40B4-BE49-F238E27FC236}">
-                <a16:creationId xmlns:a16="http://schemas.microsoft.com/office/drawing/2014/main" id="{BDBE1958-0790-45D9-8589-F2F37565490D}"/>
+                <a16:creationId xmlns:a16="http://schemas.microsoft.com/office/drawing/2014/main" id="{F7279B12-0C48-4B6E-9717-4876961DD807}"/>
               </a:ext>
             </a:extLst>
           </p:cNvPr>
@@ -5108,7 +5252,7 @@
           <p:cNvPr id="15" name="">
             <a:extLst xmlns:a="http://schemas.openxmlformats.org/drawingml/2006/main">
               <a:ext uri="{FF2B5EF4-FFF2-40B4-BE49-F238E27FC236}">
-                <a16:creationId xmlns:a16="http://schemas.microsoft.com/office/drawing/2014/main" id="{530282DE-51DA-451D-83A8-F2E34C088EE5}"/>
+                <a16:creationId xmlns:a16="http://schemas.microsoft.com/office/drawing/2014/main" id="{CFFA99D5-6BE0-4359-9149-06766A7ACC8F}"/>
               </a:ext>
             </a:extLst>
           </p:cNvPr>
@@ -5165,7 +5309,7 @@
           <p:cNvPr id="16" name="">
             <a:extLst xmlns:a="http://schemas.openxmlformats.org/drawingml/2006/main">
               <a:ext uri="{FF2B5EF4-FFF2-40B4-BE49-F238E27FC236}">
-                <a16:creationId xmlns:a16="http://schemas.microsoft.com/office/drawing/2014/main" id="{17004D8F-D97F-4CA3-A78B-52FF34DC3168}"/>
+                <a16:creationId xmlns:a16="http://schemas.microsoft.com/office/drawing/2014/main" id="{C8B8B7E2-A507-44E5-9345-A92875139A91}"/>
               </a:ext>
             </a:extLst>
           </p:cNvPr>
@@ -5222,19 +5366,19 @@
           <p:cNvPr id="17" name="">
             <a:extLst xmlns:a="http://schemas.openxmlformats.org/drawingml/2006/main">
               <a:ext uri="{FF2B5EF4-FFF2-40B4-BE49-F238E27FC236}">
-                <a16:creationId xmlns:a16="http://schemas.microsoft.com/office/drawing/2014/main" id="{5EEF836A-83F0-4C62-B343-5539A666C8E6}"/>
-              </a:ext>
-            </a:extLst>
-          </p:cNvPr>
-          <p:cNvSpPr>
-            <a:spLocks xmlns:a="http://schemas.openxmlformats.org/drawingml/2006/main" noGrp="1"/>
-          </p:cNvSpPr>
-          <p:nvPr/>
-        </p:nvSpPr>
-        <p:spPr>
-          <a:xfrm xmlns:a="http://schemas.openxmlformats.org/drawingml/2006/main">
-            <a:off x="2095500" y="5000625"/>
-            <a:ext cx="8001000" cy="381000"/>
+                <a16:creationId xmlns:a16="http://schemas.microsoft.com/office/drawing/2014/main" id="{9BD60228-801C-42BB-B5B6-3376719FFFB0}"/>
+              </a:ext>
+            </a:extLst>
+          </p:cNvPr>
+          <p:cNvSpPr>
+            <a:spLocks xmlns:a="http://schemas.openxmlformats.org/drawingml/2006/main" noGrp="1"/>
+          </p:cNvSpPr>
+          <p:nvPr/>
+        </p:nvSpPr>
+        <p:spPr>
+          <a:xfrm xmlns:a="http://schemas.openxmlformats.org/drawingml/2006/main">
+            <a:off x="1381125" y="5000625"/>
+            <a:ext cx="9429750" cy="381000"/>
           </a:xfrm>
           <a:prstGeom xmlns:a="http://schemas.openxmlformats.org/drawingml/2006/main" prst="rect">
             <a:avLst/>
@@ -5246,12 +5390,12 @@
         </p:spPr>
         <p:txBody>
           <a:bodyPr xmlns:a="http://schemas.openxmlformats.org/drawingml/2006/main" anchor="ctr">
-            <a:normAutofit fontScale="100000"/>
+            <a:normAutofit fontScale="98080"/>
           </a:bodyPr>
           <a:lstStyle xmlns:a="http://schemas.openxmlformats.org/drawingml/2006/main"/>
           <a:p xmlns:a="http://schemas.openxmlformats.org/drawingml/2006/main">
             <a:pPr algn="ctr">
-              <a:defRPr sz="1725" b="0">
+              <a:defRPr sz="1650" b="0">
                 <a:solidFill>
                   <a:srgbClr val="13283C"/>
                 </a:solidFill>
@@ -5261,7 +5405,7 @@
               </a:defRPr>
             </a:pPr>
             <a:r>
-              <a:rPr sz="1725" b="0">
+              <a:rPr sz="1650" b="0">
                 <a:solidFill>
                   <a:srgbClr val="13283C"/>
                 </a:solidFill>
@@ -5269,7 +5413,7 @@
                 <a:ea typeface="Helvetica Neue"/>
                 <a:cs typeface="Helvetica Neue"/>
               </a:rPr>
-              <a:t>Exact provenance and a safety explanation remain available for review.</a:t>
+              <a:t>Exact provenance, uncertainty, and a deterministic readiness explanation remain available for review.</a:t>
             </a:r>
           </a:p>
         </p:txBody>
@@ -5279,7 +5423,7 @@
           <p:cNvPr id="18" name="">
             <a:extLst xmlns:a="http://schemas.openxmlformats.org/drawingml/2006/main">
               <a:ext uri="{FF2B5EF4-FFF2-40B4-BE49-F238E27FC236}">
-                <a16:creationId xmlns:a16="http://schemas.microsoft.com/office/drawing/2014/main" id="{F79F9C59-881F-406F-A442-3DAAA54CB619}"/>
+                <a16:creationId xmlns:a16="http://schemas.microsoft.com/office/drawing/2014/main" id="{D877847F-D1AD-4267-8F06-65985620B7E4}"/>
               </a:ext>
             </a:extLst>
           </p:cNvPr>
@@ -5336,7 +5480,7 @@
           <p:cNvPr id="19" name="">
             <a:extLst xmlns:a="http://schemas.openxmlformats.org/drawingml/2006/main">
               <a:ext uri="{FF2B5EF4-FFF2-40B4-BE49-F238E27FC236}">
-                <a16:creationId xmlns:a16="http://schemas.microsoft.com/office/drawing/2014/main" id="{444CCFD5-5738-46E0-A676-96F496E92047}"/>
+                <a16:creationId xmlns:a16="http://schemas.microsoft.com/office/drawing/2014/main" id="{F16D650A-6EA9-445D-AA43-6CEF26E947AD}"/>
               </a:ext>
             </a:extLst>
           </p:cNvPr>
@@ -5391,7 +5535,7 @@
     </p:spTree>
     <p:extLst>
       <p:ext uri="{BB962C8B-B14F-4D97-AF65-F5344CB8AC3E}">
-        <p14:creationId xmlns:p14="http://schemas.microsoft.com/office/powerpoint/2010/main" val="407396841"/>
+        <p14:creationId xmlns:p14="http://schemas.microsoft.com/office/powerpoint/2010/main" val="775813661"/>
       </p:ext>
     </p:extLst>
   </p:cSld>
@@ -5422,7 +5566,7 @@
           <p:cNvPr id="19" name="">
             <a:extLst xmlns:a="http://schemas.openxmlformats.org/drawingml/2006/main">
               <a:ext uri="{FF2B5EF4-FFF2-40B4-BE49-F238E27FC236}">
-                <a16:creationId xmlns:a16="http://schemas.microsoft.com/office/drawing/2014/main" id="{EF3C516A-08F8-4E85-9CF1-CD4AF4343B5D}"/>
+                <a16:creationId xmlns:a16="http://schemas.microsoft.com/office/drawing/2014/main" id="{0C07512B-3459-4EAF-B43F-D9F2D00E491F}"/>
               </a:ext>
             </a:extLst>
           </p:cNvPr>
@@ -5479,7 +5623,7 @@
           <p:cNvPr id="2" name="">
             <a:extLst xmlns:a="http://schemas.openxmlformats.org/drawingml/2006/main">
               <a:ext uri="{FF2B5EF4-FFF2-40B4-BE49-F238E27FC236}">
-                <a16:creationId xmlns:a16="http://schemas.microsoft.com/office/drawing/2014/main" id="{1A9A8DBD-D967-476D-B563-870A0968EF95}"/>
+                <a16:creationId xmlns:a16="http://schemas.microsoft.com/office/drawing/2014/main" id="{AB77DD9F-1032-4FF0-9C9F-28DEDB020A3E}"/>
               </a:ext>
             </a:extLst>
           </p:cNvPr>
@@ -5536,7 +5680,7 @@
           <p:cNvPr id="3" name="">
             <a:extLst xmlns:a="http://schemas.openxmlformats.org/drawingml/2006/main">
               <a:ext uri="{FF2B5EF4-FFF2-40B4-BE49-F238E27FC236}">
-                <a16:creationId xmlns:a16="http://schemas.microsoft.com/office/drawing/2014/main" id="{0CCA06DD-40D4-45EE-971C-E9B5ED57D5CA}"/>
+                <a16:creationId xmlns:a16="http://schemas.microsoft.com/office/drawing/2014/main" id="{ADAEBC88-DE8E-4798-B5AC-D504B13B3D84}"/>
               </a:ext>
             </a:extLst>
           </p:cNvPr>
@@ -5567,7 +5711,7 @@
           <p:cNvPr id="4" name="">
             <a:extLst xmlns:a="http://schemas.openxmlformats.org/drawingml/2006/main">
               <a:ext uri="{FF2B5EF4-FFF2-40B4-BE49-F238E27FC236}">
-                <a16:creationId xmlns:a16="http://schemas.microsoft.com/office/drawing/2014/main" id="{37DF3880-4E16-4EE9-93C8-7CBA85DD8A15}"/>
+                <a16:creationId xmlns:a16="http://schemas.microsoft.com/office/drawing/2014/main" id="{B8B432AB-0DEE-4E54-BF3A-14016461475D}"/>
               </a:ext>
             </a:extLst>
           </p:cNvPr>
@@ -5654,7 +5798,7 @@
           <p:cNvPr id="5" name="">
             <a:extLst xmlns:a="http://schemas.openxmlformats.org/drawingml/2006/main">
               <a:ext uri="{FF2B5EF4-FFF2-40B4-BE49-F238E27FC236}">
-                <a16:creationId xmlns:a16="http://schemas.microsoft.com/office/drawing/2014/main" id="{3E3EDDE2-F698-4BCB-9F1B-9BAC90DDA331}"/>
+                <a16:creationId xmlns:a16="http://schemas.microsoft.com/office/drawing/2014/main" id="{6F694A43-7186-448B-92A9-3A118BED4244}"/>
               </a:ext>
             </a:extLst>
           </p:cNvPr>
@@ -5741,7 +5885,7 @@
           <p:cNvPr id="6" name="">
             <a:extLst xmlns:a="http://schemas.openxmlformats.org/drawingml/2006/main">
               <a:ext uri="{FF2B5EF4-FFF2-40B4-BE49-F238E27FC236}">
-                <a16:creationId xmlns:a16="http://schemas.microsoft.com/office/drawing/2014/main" id="{78C1A7F8-376E-4635-A550-8CA08BC65065}"/>
+                <a16:creationId xmlns:a16="http://schemas.microsoft.com/office/drawing/2014/main" id="{E1C4B088-C9FD-47CD-B12B-C8546078286D}"/>
               </a:ext>
             </a:extLst>
           </p:cNvPr>
@@ -5828,7 +5972,7 @@
           <p:cNvPr id="7" name="">
             <a:extLst xmlns:a="http://schemas.openxmlformats.org/drawingml/2006/main">
               <a:ext uri="{FF2B5EF4-FFF2-40B4-BE49-F238E27FC236}">
-                <a16:creationId xmlns:a16="http://schemas.microsoft.com/office/drawing/2014/main" id="{11760B21-6684-4DFD-93EC-2E808C774A25}"/>
+                <a16:creationId xmlns:a16="http://schemas.microsoft.com/office/drawing/2014/main" id="{AF652DD8-6368-4DC7-A961-18D2AB29D542}"/>
               </a:ext>
             </a:extLst>
           </p:cNvPr>
@@ -5915,7 +6059,7 @@
           <p:cNvPr id="8" name="">
             <a:extLst xmlns:a="http://schemas.openxmlformats.org/drawingml/2006/main">
               <a:ext uri="{FF2B5EF4-FFF2-40B4-BE49-F238E27FC236}">
-                <a16:creationId xmlns:a16="http://schemas.microsoft.com/office/drawing/2014/main" id="{58936427-670C-4E39-945A-5A4C7E16648A}"/>
+                <a16:creationId xmlns:a16="http://schemas.microsoft.com/office/drawing/2014/main" id="{4D8A351F-C101-4B2D-A57A-61A6D8A16235}"/>
               </a:ext>
             </a:extLst>
           </p:cNvPr>
@@ -5947,7 +6091,7 @@
           <p:cNvPr id="9" name="">
             <a:extLst xmlns:a="http://schemas.openxmlformats.org/drawingml/2006/main">
               <a:ext uri="{FF2B5EF4-FFF2-40B4-BE49-F238E27FC236}">
-                <a16:creationId xmlns:a16="http://schemas.microsoft.com/office/drawing/2014/main" id="{456055C2-FBF4-49A7-BE35-2853F07E1A1A}"/>
+                <a16:creationId xmlns:a16="http://schemas.microsoft.com/office/drawing/2014/main" id="{EE655484-376D-4013-932C-53AB5765BD17}"/>
               </a:ext>
             </a:extLst>
           </p:cNvPr>
@@ -5979,7 +6123,7 @@
           <p:cNvPr id="10" name="">
             <a:extLst xmlns:a="http://schemas.openxmlformats.org/drawingml/2006/main">
               <a:ext uri="{FF2B5EF4-FFF2-40B4-BE49-F238E27FC236}">
-                <a16:creationId xmlns:a16="http://schemas.microsoft.com/office/drawing/2014/main" id="{75710B4C-C380-43FA-A35E-51620D29F40C}"/>
+                <a16:creationId xmlns:a16="http://schemas.microsoft.com/office/drawing/2014/main" id="{0BD90289-4DA6-4434-94C0-CF91BFB278C1}"/>
               </a:ext>
             </a:extLst>
           </p:cNvPr>
@@ -6011,7 +6155,7 @@
           <p:cNvPr id="11" name="">
             <a:extLst xmlns:a="http://schemas.openxmlformats.org/drawingml/2006/main">
               <a:ext uri="{FF2B5EF4-FFF2-40B4-BE49-F238E27FC236}">
-                <a16:creationId xmlns:a16="http://schemas.microsoft.com/office/drawing/2014/main" id="{8C6A6477-5C3C-4062-8B00-1605497CC338}"/>
+                <a16:creationId xmlns:a16="http://schemas.microsoft.com/office/drawing/2014/main" id="{8340F306-C51B-451D-A902-FE9641AB3CA9}"/>
               </a:ext>
             </a:extLst>
           </p:cNvPr>
@@ -6098,7 +6242,7 @@
           <p:cNvPr id="12" name="">
             <a:extLst xmlns:a="http://schemas.openxmlformats.org/drawingml/2006/main">
               <a:ext uri="{FF2B5EF4-FFF2-40B4-BE49-F238E27FC236}">
-                <a16:creationId xmlns:a16="http://schemas.microsoft.com/office/drawing/2014/main" id="{863292E5-3EB4-4301-8A30-10008D1149A8}"/>
+                <a16:creationId xmlns:a16="http://schemas.microsoft.com/office/drawing/2014/main" id="{AEDD4A08-5EC6-4140-AA61-6AB3DE872DDF}"/>
               </a:ext>
             </a:extLst>
           </p:cNvPr>
@@ -6152,7 +6296,7 @@
                 <a:ea typeface="Helvetica Neue"/>
                 <a:cs typeface="Helvetica Neue"/>
               </a:rPr>
-              <a:t>Streamlit safe failure state</a:t>
+              <a:t>Release-readiness result</a:t>
             </a:r>
           </a:p>
           <a:p xmlns:a="http://schemas.openxmlformats.org/drawingml/2006/main">
@@ -6175,7 +6319,7 @@
                 <a:ea typeface="Helvetica Neue"/>
                 <a:cs typeface="Helvetica Neue"/>
               </a:rPr>
-              <a:t>Risk output blocked</a:t>
+              <a:t>Risk output BLOCKED</a:t>
             </a:r>
           </a:p>
         </p:txBody>
@@ -6185,7 +6329,7 @@
           <p:cNvPr id="13" name="">
             <a:extLst xmlns:a="http://schemas.openxmlformats.org/drawingml/2006/main">
               <a:ext uri="{FF2B5EF4-FFF2-40B4-BE49-F238E27FC236}">
-                <a16:creationId xmlns:a16="http://schemas.microsoft.com/office/drawing/2014/main" id="{51F0521E-B4C9-4401-BE8F-50D23EE1A2F4}"/>
+                <a16:creationId xmlns:a16="http://schemas.microsoft.com/office/drawing/2014/main" id="{5ED53480-FFF0-4150-9ADA-8A052D781C84}"/>
               </a:ext>
             </a:extLst>
           </p:cNvPr>
@@ -6239,7 +6383,7 @@
                 <a:ea typeface="Helvetica Neue"/>
                 <a:cs typeface="Helvetica Neue"/>
               </a:rPr>
-              <a:t>Deterministic safety explanation</a:t>
+              <a:t>Deterministic explanation</a:t>
             </a:r>
           </a:p>
           <a:p xmlns:a="http://schemas.openxmlformats.org/drawingml/2006/main">
@@ -6262,7 +6406,7 @@
                 <a:ea typeface="Helvetica Neue"/>
                 <a:cs typeface="Helvetica Neue"/>
               </a:rPr>
-              <a:t>Human review audit log</a:t>
+              <a:t>Session-only review log</a:t>
             </a:r>
           </a:p>
         </p:txBody>
@@ -6272,7 +6416,7 @@
           <p:cNvPr id="14" name="">
             <a:extLst xmlns:a="http://schemas.openxmlformats.org/drawingml/2006/main">
               <a:ext uri="{FF2B5EF4-FFF2-40B4-BE49-F238E27FC236}">
-                <a16:creationId xmlns:a16="http://schemas.microsoft.com/office/drawing/2014/main" id="{840A2FCB-21A8-4F5D-A401-AAAC7D4CB731}"/>
+                <a16:creationId xmlns:a16="http://schemas.microsoft.com/office/drawing/2014/main" id="{757399EE-E8C7-45BA-8A16-4A7325B1A9E2}"/>
               </a:ext>
             </a:extLst>
           </p:cNvPr>
@@ -6304,7 +6448,7 @@
           <p:cNvPr id="15" name="">
             <a:extLst xmlns:a="http://schemas.openxmlformats.org/drawingml/2006/main">
               <a:ext uri="{FF2B5EF4-FFF2-40B4-BE49-F238E27FC236}">
-                <a16:creationId xmlns:a16="http://schemas.microsoft.com/office/drawing/2014/main" id="{C688304D-9098-4F27-A02B-95710AFBF878}"/>
+                <a16:creationId xmlns:a16="http://schemas.microsoft.com/office/drawing/2014/main" id="{B7AA863E-EFDB-47BC-ADA5-136D71B1EB84}"/>
               </a:ext>
             </a:extLst>
           </p:cNvPr>
@@ -6336,7 +6480,7 @@
           <p:cNvPr id="16" name="">
             <a:extLst xmlns:a="http://schemas.openxmlformats.org/drawingml/2006/main">
               <a:ext uri="{FF2B5EF4-FFF2-40B4-BE49-F238E27FC236}">
-                <a16:creationId xmlns:a16="http://schemas.microsoft.com/office/drawing/2014/main" id="{09D50D7C-9590-40FB-91F1-A7CAE65F89CF}"/>
+                <a16:creationId xmlns:a16="http://schemas.microsoft.com/office/drawing/2014/main" id="{4354E5D2-63F6-4D2E-B778-D34556B0578A}"/>
               </a:ext>
             </a:extLst>
           </p:cNvPr>
@@ -6393,7 +6537,7 @@
           <p:cNvPr id="17" name="">
             <a:extLst xmlns:a="http://schemas.openxmlformats.org/drawingml/2006/main">
               <a:ext uri="{FF2B5EF4-FFF2-40B4-BE49-F238E27FC236}">
-                <a16:creationId xmlns:a16="http://schemas.microsoft.com/office/drawing/2014/main" id="{53C121C2-4FEE-412A-9651-6C08E6E44EC0}"/>
+                <a16:creationId xmlns:a16="http://schemas.microsoft.com/office/drawing/2014/main" id="{0031ED24-B5A7-4984-A3A8-84C66C7261DB}"/>
               </a:ext>
             </a:extLst>
           </p:cNvPr>
@@ -6450,7 +6594,7 @@
           <p:cNvPr id="18" name="">
             <a:extLst xmlns:a="http://schemas.openxmlformats.org/drawingml/2006/main">
               <a:ext uri="{FF2B5EF4-FFF2-40B4-BE49-F238E27FC236}">
-                <a16:creationId xmlns:a16="http://schemas.microsoft.com/office/drawing/2014/main" id="{F3F7FAE0-04C9-4EDD-9977-1991105AEC02}"/>
+                <a16:creationId xmlns:a16="http://schemas.microsoft.com/office/drawing/2014/main" id="{7169153C-C094-40E6-88C0-CE044EF96DA0}"/>
               </a:ext>
             </a:extLst>
           </p:cNvPr>
@@ -6505,7 +6649,7 @@
     </p:spTree>
     <p:extLst>
       <p:ext uri="{BB962C8B-B14F-4D97-AF65-F5344CB8AC3E}">
-        <p14:creationId xmlns:p14="http://schemas.microsoft.com/office/powerpoint/2010/main" val="1532081915"/>
+        <p14:creationId xmlns:p14="http://schemas.microsoft.com/office/powerpoint/2010/main" val="723839055"/>
       </p:ext>
     </p:extLst>
   </p:cSld>
@@ -6533,10 +6677,10 @@
       </p:grpSpPr>
       <p:sp>
         <p:nvSpPr>
-          <p:cNvPr id="13" name="">
-            <a:extLst xmlns:a="http://schemas.openxmlformats.org/drawingml/2006/main">
-              <a:ext uri="{FF2B5EF4-FFF2-40B4-BE49-F238E27FC236}">
-                <a16:creationId xmlns:a16="http://schemas.microsoft.com/office/drawing/2014/main" id="{C36B86FD-5F4A-4E1F-B68D-C53EBB024CBB}"/>
+          <p:cNvPr id="11" name="">
+            <a:extLst xmlns:a="http://schemas.openxmlformats.org/drawingml/2006/main">
+              <a:ext uri="{FF2B5EF4-FFF2-40B4-BE49-F238E27FC236}">
+                <a16:creationId xmlns:a16="http://schemas.microsoft.com/office/drawing/2014/main" id="{C67315F7-7749-4146-820A-6E2F2C9A00BF}"/>
               </a:ext>
             </a:extLst>
           </p:cNvPr>
@@ -6593,7 +6737,7 @@
           <p:cNvPr id="2" name="">
             <a:extLst xmlns:a="http://schemas.openxmlformats.org/drawingml/2006/main">
               <a:ext uri="{FF2B5EF4-FFF2-40B4-BE49-F238E27FC236}">
-                <a16:creationId xmlns:a16="http://schemas.microsoft.com/office/drawing/2014/main" id="{99630314-F8E9-4869-B18E-7914A67D08AD}"/>
+                <a16:creationId xmlns:a16="http://schemas.microsoft.com/office/drawing/2014/main" id="{94AAE131-145D-4755-A2B3-606F926DCB5D}"/>
               </a:ext>
             </a:extLst>
           </p:cNvPr>
@@ -6640,7 +6784,7 @@
                 <a:ea typeface="Helvetica Neue"/>
                 <a:cs typeface="Helvetica Neue"/>
               </a:rPr>
-              <a:t>The frozen cohort remains intact while the baseline uses one verified predictor</a:t>
+              <a:t>Trained-but-rejected ML remains separate from the operational safety output</a:t>
             </a:r>
           </a:p>
         </p:txBody>
@@ -6650,7 +6794,7 @@
           <p:cNvPr id="3" name="">
             <a:extLst xmlns:a="http://schemas.openxmlformats.org/drawingml/2006/main">
               <a:ext uri="{FF2B5EF4-FFF2-40B4-BE49-F238E27FC236}">
-                <a16:creationId xmlns:a16="http://schemas.microsoft.com/office/drawing/2014/main" id="{2BE80564-4113-4942-B69B-1C272DB494BC}"/>
+                <a16:creationId xmlns:a16="http://schemas.microsoft.com/office/drawing/2014/main" id="{B091E1DA-8A3A-4D0E-9D9F-A1038011E62A}"/>
               </a:ext>
             </a:extLst>
           </p:cNvPr>
@@ -6678,7 +6822,7 @@
       </p:sp>
       <p:graphicFrame>
         <p:nvGraphicFramePr>
-          <p:cNvPr id="16" name="Chart"/>
+          <p:cNvPr id="14" name="Chart"/>
           <p:cNvGraphicFramePr/>
           <p:nvPr/>
         </p:nvGraphicFramePr>
@@ -6688,7 +6832,7 @@
         </p:xfrm>
         <a:graphic xmlns:a="http://schemas.openxmlformats.org/drawingml/2006/main">
           <a:graphicData uri="http://schemas.openxmlformats.org/drawingml/2006/chart">
-            <c:chart xmlns:r="http://schemas.openxmlformats.org/officeDocument/2006/relationships" xmlns:c="http://schemas.openxmlformats.org/drawingml/2006/chart" r:id="R5f266ded44274e69"/>
+            <c:chart xmlns:r="http://schemas.openxmlformats.org/officeDocument/2006/relationships" xmlns:c="http://schemas.openxmlformats.org/drawingml/2006/chart" r:id="R62b4154fd5b140a6"/>
           </a:graphicData>
         </a:graphic>
       </p:graphicFrame>
@@ -6697,19 +6841,19 @@
           <p:cNvPr id="5" name="">
             <a:extLst xmlns:a="http://schemas.openxmlformats.org/drawingml/2006/main">
               <a:ext uri="{FF2B5EF4-FFF2-40B4-BE49-F238E27FC236}">
-                <a16:creationId xmlns:a16="http://schemas.microsoft.com/office/drawing/2014/main" id="{60697D44-A302-43C2-8472-C154A3EB218A}"/>
-              </a:ext>
-            </a:extLst>
-          </p:cNvPr>
-          <p:cNvSpPr>
-            <a:spLocks xmlns:a="http://schemas.openxmlformats.org/drawingml/2006/main" noGrp="1"/>
-          </p:cNvSpPr>
-          <p:nvPr/>
-        </p:nvSpPr>
-        <p:spPr>
-          <a:xfrm xmlns:a="http://schemas.openxmlformats.org/drawingml/2006/main">
-            <a:off x="7905750" y="1695450"/>
-            <a:ext cx="2476500" cy="666750"/>
+                <a16:creationId xmlns:a16="http://schemas.microsoft.com/office/drawing/2014/main" id="{7067F349-F274-4428-B546-014FE37E7859}"/>
+              </a:ext>
+            </a:extLst>
+          </p:cNvPr>
+          <p:cNvSpPr>
+            <a:spLocks xmlns:a="http://schemas.openxmlformats.org/drawingml/2006/main" noGrp="1"/>
+          </p:cNvSpPr>
+          <p:nvPr/>
+        </p:nvSpPr>
+        <p:spPr>
+          <a:xfrm xmlns:a="http://schemas.openxmlformats.org/drawingml/2006/main">
+            <a:off x="7524750" y="1619250"/>
+            <a:ext cx="3238500" cy="723900"/>
           </a:xfrm>
           <a:prstGeom xmlns:a="http://schemas.openxmlformats.org/drawingml/2006/main" prst="rect">
             <a:avLst/>
@@ -6721,12 +6865,12 @@
         </p:spPr>
         <p:txBody>
           <a:bodyPr xmlns:a="http://schemas.openxmlformats.org/drawingml/2006/main" anchor="ctr">
-            <a:normAutofit fontScale="100000"/>
+            <a:normAutofit fontScale="89247"/>
           </a:bodyPr>
           <a:lstStyle xmlns:a="http://schemas.openxmlformats.org/drawingml/2006/main"/>
           <a:p xmlns:a="http://schemas.openxmlformats.org/drawingml/2006/main">
             <a:pPr algn="ctr">
-              <a:defRPr sz="3750" b="1">
+              <a:defRPr sz="2325" b="1">
                 <a:solidFill>
                   <a:srgbClr val="13283C"/>
                 </a:solidFill>
@@ -6736,7 +6880,7 @@
               </a:defRPr>
             </a:pPr>
             <a:r>
-              <a:rPr sz="3750" b="1">
+              <a:rPr sz="2325" b="1">
                 <a:solidFill>
                   <a:srgbClr val="13283C"/>
                 </a:solidFill>
@@ -6744,7 +6888,30 @@
                 <a:ea typeface="Helvetica Neue"/>
                 <a:cs typeface="Helvetica Neue"/>
               </a:rPr>
-              <a:t>2,824</a:t>
+              <a:t>2,824 frozen trials</a:t>
+            </a:r>
+          </a:p>
+          <a:p xmlns:a="http://schemas.openxmlformats.org/drawingml/2006/main">
+            <a:pPr algn="ctr">
+              <a:defRPr sz="2325" b="1">
+                <a:solidFill>
+                  <a:srgbClr val="13283C"/>
+                </a:solidFill>
+                <a:latin typeface="Helvetica Neue"/>
+                <a:ea typeface="Helvetica Neue"/>
+                <a:cs typeface="Helvetica Neue"/>
+              </a:defRPr>
+            </a:pPr>
+            <a:r>
+              <a:rPr sz="2325" b="1">
+                <a:solidFill>
+                  <a:srgbClr val="13283C"/>
+                </a:solidFill>
+                <a:latin typeface="Helvetica Neue"/>
+                <a:ea typeface="Helvetica Neue"/>
+                <a:cs typeface="Helvetica Neue"/>
+              </a:rPr>
+              <a:t>587 discontinued</a:t>
             </a:r>
           </a:p>
         </p:txBody>
@@ -6754,83 +6921,33 @@
           <p:cNvPr id="6" name="">
             <a:extLst xmlns:a="http://schemas.openxmlformats.org/drawingml/2006/main">
               <a:ext uri="{FF2B5EF4-FFF2-40B4-BE49-F238E27FC236}">
-                <a16:creationId xmlns:a16="http://schemas.microsoft.com/office/drawing/2014/main" id="{D80EF6F9-04BE-4CFB-A66E-FE7C90F3B695}"/>
-              </a:ext>
-            </a:extLst>
-          </p:cNvPr>
-          <p:cNvSpPr>
-            <a:spLocks xmlns:a="http://schemas.openxmlformats.org/drawingml/2006/main" noGrp="1"/>
-          </p:cNvSpPr>
-          <p:nvPr/>
-        </p:nvSpPr>
-        <p:spPr>
-          <a:xfrm xmlns:a="http://schemas.openxmlformats.org/drawingml/2006/main">
-            <a:off x="7715250" y="2324100"/>
-            <a:ext cx="2857500" cy="323850"/>
-          </a:xfrm>
-          <a:prstGeom xmlns:a="http://schemas.openxmlformats.org/drawingml/2006/main" prst="rect">
-            <a:avLst/>
-          </a:prstGeom>
-          <a:noFill xmlns:a="http://schemas.openxmlformats.org/drawingml/2006/main"/>
-          <a:ln xmlns:a="http://schemas.openxmlformats.org/drawingml/2006/main" w="0">
-            <a:noFill/>
-          </a:ln>
-        </p:spPr>
-        <p:txBody>
-          <a:bodyPr xmlns:a="http://schemas.openxmlformats.org/drawingml/2006/main" anchor="ctr">
-            <a:normAutofit fontScale="92424"/>
-          </a:bodyPr>
-          <a:lstStyle xmlns:a="http://schemas.openxmlformats.org/drawingml/2006/main"/>
-          <a:p xmlns:a="http://schemas.openxmlformats.org/drawingml/2006/main">
-            <a:pPr algn="ctr">
-              <a:defRPr sz="1650" b="0">
-                <a:solidFill>
-                  <a:srgbClr val="64748B"/>
-                </a:solidFill>
-                <a:latin typeface="Helvetica Neue"/>
-                <a:ea typeface="Helvetica Neue"/>
-                <a:cs typeface="Helvetica Neue"/>
-              </a:defRPr>
-            </a:pPr>
-            <a:r>
-              <a:rPr sz="1650" b="0">
-                <a:solidFill>
-                  <a:srgbClr val="64748B"/>
-                </a:solidFill>
-                <a:latin typeface="Helvetica Neue"/>
-                <a:ea typeface="Helvetica Neue"/>
-                <a:cs typeface="Helvetica Neue"/>
-              </a:rPr>
-              <a:t>frozen modeling trials</a:t>
-            </a:r>
-          </a:p>
-        </p:txBody>
-      </p:sp>
-      <p:sp>
-        <p:nvSpPr>
-          <p:cNvPr id="7" name="">
-            <a:extLst xmlns:a="http://schemas.openxmlformats.org/drawingml/2006/main">
-              <a:ext uri="{FF2B5EF4-FFF2-40B4-BE49-F238E27FC236}">
-                <a16:creationId xmlns:a16="http://schemas.microsoft.com/office/drawing/2014/main" id="{D97BC30C-FAEF-4255-B930-8EB7B10AB673}"/>
-              </a:ext>
-            </a:extLst>
-          </p:cNvPr>
-          <p:cNvSpPr>
-            <a:spLocks xmlns:a="http://schemas.openxmlformats.org/drawingml/2006/main" noGrp="1"/>
-          </p:cNvSpPr>
-          <p:nvPr/>
-        </p:nvSpPr>
-        <p:spPr>
-          <a:xfrm xmlns:a="http://schemas.openxmlformats.org/drawingml/2006/main">
-            <a:off x="7905750" y="3028950"/>
-            <a:ext cx="2476500" cy="666750"/>
-          </a:xfrm>
-          <a:prstGeom xmlns:a="http://schemas.openxmlformats.org/drawingml/2006/main" prst="rect">
-            <a:avLst/>
-          </a:prstGeom>
-          <a:noFill xmlns:a="http://schemas.openxmlformats.org/drawingml/2006/main"/>
-          <a:ln xmlns:a="http://schemas.openxmlformats.org/drawingml/2006/main" w="0">
-            <a:noFill/>
+                <a16:creationId xmlns:a16="http://schemas.microsoft.com/office/drawing/2014/main" id="{57B9E992-2971-49AA-9564-846FBF1F593E}"/>
+              </a:ext>
+            </a:extLst>
+          </p:cNvPr>
+          <p:cNvSpPr>
+            <a:spLocks xmlns:a="http://schemas.openxmlformats.org/drawingml/2006/main" noGrp="1"/>
+          </p:cNvSpPr>
+          <p:nvPr/>
+        </p:nvSpPr>
+        <p:spPr>
+          <a:xfrm xmlns:a="http://schemas.openxmlformats.org/drawingml/2006/main">
+            <a:off x="7524750" y="2667000"/>
+            <a:ext cx="3238500" cy="1066800"/>
+          </a:xfrm>
+          <a:prstGeom xmlns:a="http://schemas.openxmlformats.org/drawingml/2006/main" prst="roundRect">
+            <a:avLst>
+              <a:gd name="adj" fmla="val 7143"/>
+            </a:avLst>
+          </a:prstGeom>
+          <a:solidFill xmlns:a="http://schemas.openxmlformats.org/drawingml/2006/main">
+            <a:srgbClr val="FBE8E8"/>
+          </a:solidFill>
+          <a:ln xmlns:a="http://schemas.openxmlformats.org/drawingml/2006/main" w="9525">
+            <a:solidFill>
+              <a:srgbClr val="FBE8E8"/>
+            </a:solidFill>
+            <a:prstDash val="solid"/>
           </a:ln>
         </p:spPr>
         <p:txBody>
@@ -6840,7 +6957,7 @@
           <a:lstStyle xmlns:a="http://schemas.openxmlformats.org/drawingml/2006/main"/>
           <a:p xmlns:a="http://schemas.openxmlformats.org/drawingml/2006/main">
             <a:pPr algn="ctr">
-              <a:defRPr sz="3750" b="1">
+              <a:defRPr sz="1650" b="1">
                 <a:solidFill>
                   <a:srgbClr val="C43C45"/>
                 </a:solidFill>
@@ -6850,7 +6967,7 @@
               </a:defRPr>
             </a:pPr>
             <a:r>
-              <a:rPr sz="3750" b="1">
+              <a:rPr sz="1650" b="1">
                 <a:solidFill>
                   <a:srgbClr val="C43C45"/>
                 </a:solidFill>
@@ -6858,90 +6975,79 @@
                 <a:ea typeface="Helvetica Neue"/>
                 <a:cs typeface="Helvetica Neue"/>
               </a:rPr>
-              <a:t>587</a:t>
-            </a:r>
-          </a:p>
-        </p:txBody>
-      </p:sp>
-      <p:sp>
-        <p:nvSpPr>
-          <p:cNvPr id="8" name="">
-            <a:extLst xmlns:a="http://schemas.openxmlformats.org/drawingml/2006/main">
-              <a:ext uri="{FF2B5EF4-FFF2-40B4-BE49-F238E27FC236}">
-                <a16:creationId xmlns:a16="http://schemas.microsoft.com/office/drawing/2014/main" id="{F01A9EE1-0D28-445A-905B-8CC8F81440DD}"/>
-              </a:ext>
-            </a:extLst>
-          </p:cNvPr>
-          <p:cNvSpPr>
-            <a:spLocks xmlns:a="http://schemas.openxmlformats.org/drawingml/2006/main" noGrp="1"/>
-          </p:cNvSpPr>
-          <p:nvPr/>
-        </p:nvSpPr>
-        <p:spPr>
-          <a:xfrm xmlns:a="http://schemas.openxmlformats.org/drawingml/2006/main">
-            <a:off x="7239000" y="3657600"/>
-            <a:ext cx="3810000" cy="323850"/>
-          </a:xfrm>
-          <a:prstGeom xmlns:a="http://schemas.openxmlformats.org/drawingml/2006/main" prst="rect">
-            <a:avLst/>
-          </a:prstGeom>
-          <a:noFill xmlns:a="http://schemas.openxmlformats.org/drawingml/2006/main"/>
-          <a:ln xmlns:a="http://schemas.openxmlformats.org/drawingml/2006/main" w="0">
-            <a:noFill/>
-          </a:ln>
-        </p:spPr>
-        <p:txBody>
-          <a:bodyPr xmlns:a="http://schemas.openxmlformats.org/drawingml/2006/main" anchor="ctr">
-            <a:normAutofit fontScale="92424"/>
-          </a:bodyPr>
-          <a:lstStyle xmlns:a="http://schemas.openxmlformats.org/drawingml/2006/main"/>
+              <a:t>ML baseline</a:t>
+            </a:r>
+          </a:p>
           <a:p xmlns:a="http://schemas.openxmlformats.org/drawingml/2006/main">
             <a:pPr algn="ctr">
-              <a:defRPr sz="1650" b="0">
-                <a:solidFill>
-                  <a:srgbClr val="64748B"/>
-                </a:solidFill>
-                <a:latin typeface="Helvetica Neue"/>
-                <a:ea typeface="Helvetica Neue"/>
-                <a:cs typeface="Helvetica Neue"/>
-              </a:defRPr>
-            </a:pPr>
-            <a:r>
-              <a:rPr sz="1650" b="0">
-                <a:solidFill>
-                  <a:srgbClr val="64748B"/>
-                </a:solidFill>
-                <a:latin typeface="Helvetica Neue"/>
-                <a:ea typeface="Helvetica Neue"/>
-                <a:cs typeface="Helvetica Neue"/>
-              </a:rPr>
-              <a:t>discontinued in the frozen cohort</a:t>
-            </a:r>
-          </a:p>
-        </p:txBody>
-      </p:sp>
-      <p:sp>
-        <p:nvSpPr>
-          <p:cNvPr id="9" name="">
-            <a:extLst xmlns:a="http://schemas.openxmlformats.org/drawingml/2006/main">
-              <a:ext uri="{FF2B5EF4-FFF2-40B4-BE49-F238E27FC236}">
-                <a16:creationId xmlns:a16="http://schemas.microsoft.com/office/drawing/2014/main" id="{0AE49C46-4F54-4A4B-AC71-E653987C40C3}"/>
-              </a:ext>
-            </a:extLst>
-          </p:cNvPr>
-          <p:cNvSpPr>
-            <a:spLocks xmlns:a="http://schemas.openxmlformats.org/drawingml/2006/main" noGrp="1"/>
-          </p:cNvSpPr>
-          <p:nvPr/>
-        </p:nvSpPr>
-        <p:spPr>
-          <a:xfrm xmlns:a="http://schemas.openxmlformats.org/drawingml/2006/main">
-            <a:off x="7620000" y="4476750"/>
-            <a:ext cx="3048000" cy="838200"/>
+              <a:defRPr sz="1650" b="1">
+                <a:solidFill>
+                  <a:srgbClr val="C43C45"/>
+                </a:solidFill>
+                <a:latin typeface="Helvetica Neue"/>
+                <a:ea typeface="Helvetica Neue"/>
+                <a:cs typeface="Helvetica Neue"/>
+              </a:defRPr>
+            </a:pPr>
+            <a:r>
+              <a:rPr sz="1650" b="1">
+                <a:solidFill>
+                  <a:srgbClr val="C43C45"/>
+                </a:solidFill>
+                <a:latin typeface="Helvetica Neue"/>
+                <a:ea typeface="Helvetica Neue"/>
+                <a:cs typeface="Helvetica Neue"/>
+              </a:rPr>
+              <a:t>Trained and evaluated</a:t>
+            </a:r>
+          </a:p>
+          <a:p xmlns:a="http://schemas.openxmlformats.org/drawingml/2006/main">
+            <a:pPr algn="ctr">
+              <a:defRPr sz="1650" b="1">
+                <a:solidFill>
+                  <a:srgbClr val="C43C45"/>
+                </a:solidFill>
+                <a:latin typeface="Helvetica Neue"/>
+                <a:ea typeface="Helvetica Neue"/>
+                <a:cs typeface="Helvetica Neue"/>
+              </a:defRPr>
+            </a:pPr>
+            <a:r>
+              <a:rPr sz="1650" b="1">
+                <a:solidFill>
+                  <a:srgbClr val="C43C45"/>
+                </a:solidFill>
+                <a:latin typeface="Helvetica Neue"/>
+                <a:ea typeface="Helvetica Neue"/>
+                <a:cs typeface="Helvetica Neue"/>
+              </a:rPr>
+              <a:t>Release status: FAIL</a:t>
+            </a:r>
+          </a:p>
+        </p:txBody>
+      </p:sp>
+      <p:sp>
+        <p:nvSpPr>
+          <p:cNvPr id="7" name="">
+            <a:extLst xmlns:a="http://schemas.openxmlformats.org/drawingml/2006/main">
+              <a:ext uri="{FF2B5EF4-FFF2-40B4-BE49-F238E27FC236}">
+                <a16:creationId xmlns:a16="http://schemas.microsoft.com/office/drawing/2014/main" id="{D2FAC35B-694F-4036-96A1-C48CF94E11E9}"/>
+              </a:ext>
+            </a:extLst>
+          </p:cNvPr>
+          <p:cNvSpPr>
+            <a:spLocks xmlns:a="http://schemas.openxmlformats.org/drawingml/2006/main" noGrp="1"/>
+          </p:cNvSpPr>
+          <p:nvPr/>
+        </p:nvSpPr>
+        <p:spPr>
+          <a:xfrm xmlns:a="http://schemas.openxmlformats.org/drawingml/2006/main">
+            <a:off x="7524750" y="4048125"/>
+            <a:ext cx="3238500" cy="1066800"/>
           </a:xfrm>
           <a:prstGeom xmlns:a="http://schemas.openxmlformats.org/drawingml/2006/main" prst="roundRect">
             <a:avLst>
-              <a:gd name="adj" fmla="val 9091"/>
+              <a:gd name="adj" fmla="val 7143"/>
             </a:avLst>
           </a:prstGeom>
           <a:solidFill xmlns:a="http://schemas.openxmlformats.org/drawingml/2006/main">
@@ -6961,7 +7067,7 @@
           <a:lstStyle xmlns:a="http://schemas.openxmlformats.org/drawingml/2006/main"/>
           <a:p xmlns:a="http://schemas.openxmlformats.org/drawingml/2006/main">
             <a:pPr algn="ctr">
-              <a:defRPr sz="1725" b="1">
+              <a:defRPr sz="1575" b="1">
                 <a:solidFill>
                   <a:srgbClr val="13283C"/>
                 </a:solidFill>
@@ -6971,7 +7077,7 @@
               </a:defRPr>
             </a:pPr>
             <a:r>
-              <a:rPr sz="1725" b="1">
+              <a:rPr sz="1575" b="1">
                 <a:solidFill>
                   <a:srgbClr val="13283C"/>
                 </a:solidFill>
@@ -6979,12 +7085,12 @@
                 <a:ea typeface="Helvetica Neue"/>
                 <a:cs typeface="Helvetica Neue"/>
               </a:rPr>
-              <a:t>Verified predictor</a:t>
+              <a:t>Operational output</a:t>
             </a:r>
           </a:p>
           <a:p xmlns:a="http://schemas.openxmlformats.org/drawingml/2006/main">
             <a:pPr algn="ctr">
-              <a:defRPr sz="1725" b="1">
+              <a:defRPr sz="1575" b="1">
                 <a:solidFill>
                   <a:srgbClr val="13283C"/>
                 </a:solidFill>
@@ -6994,7 +7100,7 @@
               </a:defRPr>
             </a:pPr>
             <a:r>
-              <a:rPr sz="1725" b="1">
+              <a:rPr sz="1575" b="1">
                 <a:solidFill>
                   <a:srgbClr val="13283C"/>
                 </a:solidFill>
@@ -7002,29 +7108,52 @@
                 <a:ea typeface="Helvetica Neue"/>
                 <a:cs typeface="Helvetica Neue"/>
               </a:rPr>
-              <a:t>submission_year</a:t>
-            </a:r>
-          </a:p>
-        </p:txBody>
-      </p:sp>
-      <p:sp>
-        <p:nvSpPr>
-          <p:cNvPr id="10" name="">
-            <a:extLst xmlns:a="http://schemas.openxmlformats.org/drawingml/2006/main">
-              <a:ext uri="{FF2B5EF4-FFF2-40B4-BE49-F238E27FC236}">
-                <a16:creationId xmlns:a16="http://schemas.microsoft.com/office/drawing/2014/main" id="{CC748BC4-CB38-4B97-B289-80FF2F1B3812}"/>
-              </a:ext>
-            </a:extLst>
-          </p:cNvPr>
-          <p:cNvSpPr>
-            <a:spLocks xmlns:a="http://schemas.openxmlformats.org/drawingml/2006/main" noGrp="1"/>
-          </p:cNvSpPr>
-          <p:nvPr/>
-        </p:nvSpPr>
-        <p:spPr>
-          <a:xfrm xmlns:a="http://schemas.openxmlformats.org/drawingml/2006/main">
-            <a:off x="7429500" y="5638800"/>
-            <a:ext cx="3429000" cy="323850"/>
+              <a:t>Deterministic readiness result</a:t>
+            </a:r>
+          </a:p>
+          <a:p xmlns:a="http://schemas.openxmlformats.org/drawingml/2006/main">
+            <a:pPr algn="ctr">
+              <a:defRPr sz="1575" b="1">
+                <a:solidFill>
+                  <a:srgbClr val="13283C"/>
+                </a:solidFill>
+                <a:latin typeface="Helvetica Neue"/>
+                <a:ea typeface="Helvetica Neue"/>
+                <a:cs typeface="Helvetica Neue"/>
+              </a:defRPr>
+            </a:pPr>
+            <a:r>
+              <a:rPr sz="1575" b="1">
+                <a:solidFill>
+                  <a:srgbClr val="13283C"/>
+                </a:solidFill>
+                <a:latin typeface="Helvetica Neue"/>
+                <a:ea typeface="Helvetica Neue"/>
+                <a:cs typeface="Helvetica Neue"/>
+              </a:rPr>
+              <a:t>No probability or SHAP</a:t>
+            </a:r>
+          </a:p>
+        </p:txBody>
+      </p:sp>
+      <p:sp>
+        <p:nvSpPr>
+          <p:cNvPr id="8" name="">
+            <a:extLst xmlns:a="http://schemas.openxmlformats.org/drawingml/2006/main">
+              <a:ext uri="{FF2B5EF4-FFF2-40B4-BE49-F238E27FC236}">
+                <a16:creationId xmlns:a16="http://schemas.microsoft.com/office/drawing/2014/main" id="{4382D580-AE66-413E-94BB-7A3EAE044C70}"/>
+              </a:ext>
+            </a:extLst>
+          </p:cNvPr>
+          <p:cNvSpPr>
+            <a:spLocks xmlns:a="http://schemas.openxmlformats.org/drawingml/2006/main" noGrp="1"/>
+          </p:cNvSpPr>
+          <p:nvPr/>
+        </p:nvSpPr>
+        <p:spPr>
+          <a:xfrm xmlns:a="http://schemas.openxmlformats.org/drawingml/2006/main">
+            <a:off x="7381875" y="5448300"/>
+            <a:ext cx="3524250" cy="571500"/>
           </a:xfrm>
           <a:prstGeom xmlns:a="http://schemas.openxmlformats.org/drawingml/2006/main" prst="rect">
             <a:avLst/>
@@ -7036,12 +7165,12 @@
         </p:spPr>
         <p:txBody>
           <a:bodyPr xmlns:a="http://schemas.openxmlformats.org/drawingml/2006/main" anchor="ctr">
-            <a:normAutofit fontScale="96097"/>
+            <a:normAutofit fontScale="100000"/>
           </a:bodyPr>
           <a:lstStyle xmlns:a="http://schemas.openxmlformats.org/drawingml/2006/main"/>
           <a:p xmlns:a="http://schemas.openxmlformats.org/drawingml/2006/main">
             <a:pPr algn="ctr">
-              <a:defRPr sz="1500" b="1">
+              <a:defRPr sz="1425" b="1">
                 <a:solidFill>
                   <a:srgbClr val="237A57"/>
                 </a:solidFill>
@@ -7051,7 +7180,7 @@
               </a:defRPr>
             </a:pPr>
             <a:r>
-              <a:rPr sz="1500" b="1">
+              <a:rPr sz="1425" b="1">
                 <a:solidFill>
                   <a:srgbClr val="237A57"/>
                 </a:solidFill>
@@ -7059,6 +7188,29 @@
                 <a:ea typeface="Helvetica Neue"/>
                 <a:cs typeface="Helvetica Neue"/>
               </a:rPr>
+              <a:t>Verified predictor: submission_year</a:t>
+            </a:r>
+          </a:p>
+          <a:p xmlns:a="http://schemas.openxmlformats.org/drawingml/2006/main">
+            <a:pPr algn="ctr">
+              <a:defRPr sz="1425" b="1">
+                <a:solidFill>
+                  <a:srgbClr val="237A57"/>
+                </a:solidFill>
+                <a:latin typeface="Helvetica Neue"/>
+                <a:ea typeface="Helvetica Neue"/>
+                <a:cs typeface="Helvetica Neue"/>
+              </a:defRPr>
+            </a:pPr>
+            <a:r>
+              <a:rPr sz="1425" b="1">
+                <a:solidFill>
+                  <a:srgbClr val="237A57"/>
+                </a:solidFill>
+                <a:latin typeface="Helvetica Neue"/>
+                <a:ea typeface="Helvetica Neue"/>
+                <a:cs typeface="Helvetica Neue"/>
+              </a:rPr>
               <a:t>Final-test outcomes remained locked</a:t>
             </a:r>
           </a:p>
@@ -7066,10 +7218,10 @@
       </p:sp>
       <p:sp>
         <p:nvSpPr>
-          <p:cNvPr id="11" name="">
-            <a:extLst xmlns:a="http://schemas.openxmlformats.org/drawingml/2006/main">
-              <a:ext uri="{FF2B5EF4-FFF2-40B4-BE49-F238E27FC236}">
-                <a16:creationId xmlns:a16="http://schemas.microsoft.com/office/drawing/2014/main" id="{E31AD508-31A3-474F-BB65-151EBF28E014}"/>
+          <p:cNvPr id="9" name="">
+            <a:extLst xmlns:a="http://schemas.openxmlformats.org/drawingml/2006/main">
+              <a:ext uri="{FF2B5EF4-FFF2-40B4-BE49-F238E27FC236}">
+                <a16:creationId xmlns:a16="http://schemas.microsoft.com/office/drawing/2014/main" id="{2224395E-0EC3-4239-9F61-C1E46EB7AF58}"/>
               </a:ext>
             </a:extLst>
           </p:cNvPr>
@@ -7123,10 +7275,10 @@
       </p:sp>
       <p:sp>
         <p:nvSpPr>
-          <p:cNvPr id="12" name="">
-            <a:extLst xmlns:a="http://schemas.openxmlformats.org/drawingml/2006/main">
-              <a:ext uri="{FF2B5EF4-FFF2-40B4-BE49-F238E27FC236}">
-                <a16:creationId xmlns:a16="http://schemas.microsoft.com/office/drawing/2014/main" id="{B31BBC45-4B0D-4A1A-9FA8-AB68D143D9A3}"/>
+          <p:cNvPr id="10" name="">
+            <a:extLst xmlns:a="http://schemas.openxmlformats.org/drawingml/2006/main">
+              <a:ext uri="{FF2B5EF4-FFF2-40B4-BE49-F238E27FC236}">
+                <a16:creationId xmlns:a16="http://schemas.microsoft.com/office/drawing/2014/main" id="{BCB21F27-E0F4-40FE-9BC6-E059EEBF8430}"/>
               </a:ext>
             </a:extLst>
           </p:cNvPr>
@@ -7181,7 +7333,7 @@
     </p:spTree>
     <p:extLst>
       <p:ext uri="{BB962C8B-B14F-4D97-AF65-F5344CB8AC3E}">
-        <p14:creationId xmlns:p14="http://schemas.microsoft.com/office/powerpoint/2010/main" val="1666305599"/>
+        <p14:creationId xmlns:p14="http://schemas.microsoft.com/office/powerpoint/2010/main" val="229968401"/>
       </p:ext>
     </p:extLst>
   </p:cSld>
@@ -7212,7 +7364,7 @@
           <p:cNvPr id="13" name="">
             <a:extLst xmlns:a="http://schemas.openxmlformats.org/drawingml/2006/main">
               <a:ext uri="{FF2B5EF4-FFF2-40B4-BE49-F238E27FC236}">
-                <a16:creationId xmlns:a16="http://schemas.microsoft.com/office/drawing/2014/main" id="{AD2425A0-B947-4C25-89AB-4F249815E616}"/>
+                <a16:creationId xmlns:a16="http://schemas.microsoft.com/office/drawing/2014/main" id="{FE66C405-B4FE-4D48-9B50-5690D0574E28}"/>
               </a:ext>
             </a:extLst>
           </p:cNvPr>
@@ -7259,7 +7411,7 @@
                 <a:ea typeface="Helvetica Neue"/>
                 <a:cs typeface="Helvetica Neue"/>
               </a:rPr>
-              <a:t>Streamlit safe failure state</a:t>
+              <a:t>Release-readiness result in Streamlit</a:t>
             </a:r>
           </a:p>
         </p:txBody>
@@ -7269,7 +7421,7 @@
           <p:cNvPr id="2" name="">
             <a:extLst xmlns:a="http://schemas.openxmlformats.org/drawingml/2006/main">
               <a:ext uri="{FF2B5EF4-FFF2-40B4-BE49-F238E27FC236}">
-                <a16:creationId xmlns:a16="http://schemas.microsoft.com/office/drawing/2014/main" id="{745906FD-6E65-41C4-AE13-F117306242AA}"/>
+                <a16:creationId xmlns:a16="http://schemas.microsoft.com/office/drawing/2014/main" id="{0A3CBF32-4B4F-44E1-A0B4-6FFE93F80593}"/>
               </a:ext>
             </a:extLst>
           </p:cNvPr>
@@ -7316,7 +7468,7 @@
                 <a:ea typeface="Helvetica Neue"/>
                 <a:cs typeface="Helvetica Neue"/>
               </a:rPr>
-              <a:t>Actual application screen for NCT03414632</a:t>
+              <a:t>Model-release readiness review for NCT03414632</a:t>
             </a:r>
           </a:p>
         </p:txBody>
@@ -7326,7 +7478,7 @@
           <p:cNvPr id="3" name="">
             <a:extLst xmlns:a="http://schemas.openxmlformats.org/drawingml/2006/main">
               <a:ext uri="{FF2B5EF4-FFF2-40B4-BE49-F238E27FC236}">
-                <a16:creationId xmlns:a16="http://schemas.microsoft.com/office/drawing/2014/main" id="{E5EFA67D-ADCF-46D4-8D7D-D1FBBBF1F318}"/>
+                <a16:creationId xmlns:a16="http://schemas.microsoft.com/office/drawing/2014/main" id="{D1519FAB-C3DB-4073-A6E1-1055616F2066}"/>
               </a:ext>
             </a:extLst>
           </p:cNvPr>
@@ -7361,7 +7513,7 @@
           <p:nvPr/>
         </p:nvPicPr>
         <p:blipFill>
-          <a:blip xmlns:r="http://schemas.openxmlformats.org/officeDocument/2006/relationships" xmlns:a="http://schemas.openxmlformats.org/drawingml/2006/main" r:embed="R05b7f746bd774f9e"/>
+          <a:blip xmlns:r="http://schemas.openxmlformats.org/officeDocument/2006/relationships" xmlns:a="http://schemas.openxmlformats.org/drawingml/2006/main" r:embed="R3ee4b09818af4916"/>
           <a:stretch xmlns:a="http://schemas.openxmlformats.org/drawingml/2006/main"/>
         </p:blipFill>
         <p:spPr>
@@ -7379,7 +7531,7 @@
           <p:cNvPr id="5" name="">
             <a:extLst xmlns:a="http://schemas.openxmlformats.org/drawingml/2006/main">
               <a:ext uri="{FF2B5EF4-FFF2-40B4-BE49-F238E27FC236}">
-                <a16:creationId xmlns:a16="http://schemas.microsoft.com/office/drawing/2014/main" id="{3F23EE03-33D6-4AE2-B126-304CB29FB402}"/>
+                <a16:creationId xmlns:a16="http://schemas.microsoft.com/office/drawing/2014/main" id="{952F3741-7505-448B-ABD7-79E8DB16A600}"/>
               </a:ext>
             </a:extLst>
           </p:cNvPr>
@@ -7436,7 +7588,7 @@
           <p:cNvPr id="6" name="">
             <a:extLst xmlns:a="http://schemas.openxmlformats.org/drawingml/2006/main">
               <a:ext uri="{FF2B5EF4-FFF2-40B4-BE49-F238E27FC236}">
-                <a16:creationId xmlns:a16="http://schemas.microsoft.com/office/drawing/2014/main" id="{CB75FF97-5DD4-4D7A-A815-0DFF2717055B}"/>
+                <a16:creationId xmlns:a16="http://schemas.microsoft.com/office/drawing/2014/main" id="{B061019B-0511-4DAB-9D59-9DE241B8CC28}"/>
               </a:ext>
             </a:extLst>
           </p:cNvPr>
@@ -7493,7 +7645,7 @@
           <p:cNvPr id="7" name="">
             <a:extLst xmlns:a="http://schemas.openxmlformats.org/drawingml/2006/main">
               <a:ext uri="{FF2B5EF4-FFF2-40B4-BE49-F238E27FC236}">
-                <a16:creationId xmlns:a16="http://schemas.microsoft.com/office/drawing/2014/main" id="{A60FDB1A-4D8E-4F8C-AA5A-D74ED67EB13F}"/>
+                <a16:creationId xmlns:a16="http://schemas.microsoft.com/office/drawing/2014/main" id="{98BCC90D-161B-4844-8F47-EFE4F6AA9DD1}"/>
               </a:ext>
             </a:extLst>
           </p:cNvPr>
@@ -7550,7 +7702,7 @@
           <p:cNvPr id="8" name="">
             <a:extLst xmlns:a="http://schemas.openxmlformats.org/drawingml/2006/main">
               <a:ext uri="{FF2B5EF4-FFF2-40B4-BE49-F238E27FC236}">
-                <a16:creationId xmlns:a16="http://schemas.microsoft.com/office/drawing/2014/main" id="{8E3C17CD-3862-423B-A398-E7F9098EB451}"/>
+                <a16:creationId xmlns:a16="http://schemas.microsoft.com/office/drawing/2014/main" id="{70D82E98-0FF6-40B4-8F24-51F166B5862A}"/>
               </a:ext>
             </a:extLst>
           </p:cNvPr>
@@ -7574,7 +7726,7 @@
         </p:spPr>
         <p:txBody>
           <a:bodyPr xmlns:a="http://schemas.openxmlformats.org/drawingml/2006/main" anchor="ctr">
-            <a:normAutofit fontScale="92620"/>
+            <a:normAutofit fontScale="87511"/>
           </a:bodyPr>
           <a:lstStyle xmlns:a="http://schemas.openxmlformats.org/drawingml/2006/main"/>
           <a:p xmlns:a="http://schemas.openxmlformats.org/drawingml/2006/main">
@@ -7597,7 +7749,7 @@
                 <a:ea typeface="Helvetica Neue"/>
                 <a:cs typeface="Helvetica Neue"/>
               </a:rPr>
-              <a:t>Validation metrics in the sidebar</a:t>
+              <a:t>Validation metrics and uncertainty</a:t>
             </a:r>
           </a:p>
         </p:txBody>
@@ -7607,7 +7759,7 @@
           <p:cNvPr id="9" name="">
             <a:extLst xmlns:a="http://schemas.openxmlformats.org/drawingml/2006/main">
               <a:ext uri="{FF2B5EF4-FFF2-40B4-BE49-F238E27FC236}">
-                <a16:creationId xmlns:a16="http://schemas.microsoft.com/office/drawing/2014/main" id="{B3046182-5248-444A-AE2B-E6ED2805F241}"/>
+                <a16:creationId xmlns:a16="http://schemas.microsoft.com/office/drawing/2014/main" id="{E1F0DFBE-40E9-4D43-B93E-7453C4C55BC2}"/>
               </a:ext>
             </a:extLst>
           </p:cNvPr>
@@ -7631,7 +7783,7 @@
         </p:spPr>
         <p:txBody>
           <a:bodyPr xmlns:a="http://schemas.openxmlformats.org/drawingml/2006/main" anchor="ctr">
-            <a:normAutofit fontScale="99643"/>
+            <a:normAutofit fontScale="87361"/>
           </a:bodyPr>
           <a:lstStyle xmlns:a="http://schemas.openxmlformats.org/drawingml/2006/main"/>
           <a:p xmlns:a="http://schemas.openxmlformats.org/drawingml/2006/main">
@@ -7654,7 +7806,7 @@
                 <a:ea typeface="Helvetica Neue"/>
                 <a:cs typeface="Helvetica Neue"/>
               </a:rPr>
-              <a:t>Red release-block message</a:t>
+              <a:t>BLOCKED model release status</a:t>
             </a:r>
           </a:p>
         </p:txBody>
@@ -7664,7 +7816,7 @@
           <p:cNvPr id="10" name="">
             <a:extLst xmlns:a="http://schemas.openxmlformats.org/drawingml/2006/main">
               <a:ext uri="{FF2B5EF4-FFF2-40B4-BE49-F238E27FC236}">
-                <a16:creationId xmlns:a16="http://schemas.microsoft.com/office/drawing/2014/main" id="{C6D3D799-D65C-418D-AC00-66D5F13425C2}"/>
+                <a16:creationId xmlns:a16="http://schemas.microsoft.com/office/drawing/2014/main" id="{7AD5485E-9BD3-4E82-9285-0DD7FD1792FA}"/>
               </a:ext>
             </a:extLst>
           </p:cNvPr>
@@ -7728,7 +7880,7 @@
           <p:cNvPr id="11" name="">
             <a:extLst xmlns:a="http://schemas.openxmlformats.org/drawingml/2006/main">
               <a:ext uri="{FF2B5EF4-FFF2-40B4-BE49-F238E27FC236}">
-                <a16:creationId xmlns:a16="http://schemas.microsoft.com/office/drawing/2014/main" id="{D2E53B68-28E1-4462-8EAF-C4AF592C11D8}"/>
+                <a16:creationId xmlns:a16="http://schemas.microsoft.com/office/drawing/2014/main" id="{166DAD63-C8F8-4C28-B9D5-7FBBC1F851B0}"/>
               </a:ext>
             </a:extLst>
           </p:cNvPr>
@@ -7785,7 +7937,7 @@
           <p:cNvPr id="12" name="">
             <a:extLst xmlns:a="http://schemas.openxmlformats.org/drawingml/2006/main">
               <a:ext uri="{FF2B5EF4-FFF2-40B4-BE49-F238E27FC236}">
-                <a16:creationId xmlns:a16="http://schemas.microsoft.com/office/drawing/2014/main" id="{D95E92B1-3112-425B-8B3D-E3BEF8C6965E}"/>
+                <a16:creationId xmlns:a16="http://schemas.microsoft.com/office/drawing/2014/main" id="{9202FD4E-6F2B-4657-AA8D-5983ECE89535}"/>
               </a:ext>
             </a:extLst>
           </p:cNvPr>
@@ -7840,7 +7992,7 @@
     </p:spTree>
     <p:extLst>
       <p:ext uri="{BB962C8B-B14F-4D97-AF65-F5344CB8AC3E}">
-        <p14:creationId xmlns:p14="http://schemas.microsoft.com/office/powerpoint/2010/main" val="120862078"/>
+        <p14:creationId xmlns:p14="http://schemas.microsoft.com/office/powerpoint/2010/main" val="45563976"/>
       </p:ext>
     </p:extLst>
   </p:cSld>
@@ -7871,7 +8023,7 @@
           <p:cNvPr id="13" name="">
             <a:extLst xmlns:a="http://schemas.openxmlformats.org/drawingml/2006/main">
               <a:ext uri="{FF2B5EF4-FFF2-40B4-BE49-F238E27FC236}">
-                <a16:creationId xmlns:a16="http://schemas.microsoft.com/office/drawing/2014/main" id="{CD486B99-2BC3-4432-B1FB-201C4E301767}"/>
+                <a16:creationId xmlns:a16="http://schemas.microsoft.com/office/drawing/2014/main" id="{C4A6FD14-3C75-4DB9-8843-DEBDABD8153A}"/>
               </a:ext>
             </a:extLst>
           </p:cNvPr>
@@ -7928,7 +8080,7 @@
           <p:cNvPr id="2" name="">
             <a:extLst xmlns:a="http://schemas.openxmlformats.org/drawingml/2006/main">
               <a:ext uri="{FF2B5EF4-FFF2-40B4-BE49-F238E27FC236}">
-                <a16:creationId xmlns:a16="http://schemas.microsoft.com/office/drawing/2014/main" id="{8B693FC2-CE59-4DA1-AC9F-88162736418C}"/>
+                <a16:creationId xmlns:a16="http://schemas.microsoft.com/office/drawing/2014/main" id="{B5755818-D694-4BDC-B12E-F8B7D4C6CD9E}"/>
               </a:ext>
             </a:extLst>
           </p:cNvPr>
@@ -7985,7 +8137,7 @@
           <p:cNvPr id="3" name="">
             <a:extLst xmlns:a="http://schemas.openxmlformats.org/drawingml/2006/main">
               <a:ext uri="{FF2B5EF4-FFF2-40B4-BE49-F238E27FC236}">
-                <a16:creationId xmlns:a16="http://schemas.microsoft.com/office/drawing/2014/main" id="{9B02084C-B84C-403E-8D2B-24FE6EBEE0BE}"/>
+                <a16:creationId xmlns:a16="http://schemas.microsoft.com/office/drawing/2014/main" id="{24736901-B96E-451A-8EB2-03043005C704}"/>
               </a:ext>
             </a:extLst>
           </p:cNvPr>
@@ -8023,7 +8175,7 @@
         </p:xfrm>
         <a:graphic xmlns:a="http://schemas.openxmlformats.org/drawingml/2006/main">
           <a:graphicData uri="http://schemas.openxmlformats.org/drawingml/2006/chart">
-            <c:chart xmlns:r="http://schemas.openxmlformats.org/officeDocument/2006/relationships" xmlns:c="http://schemas.openxmlformats.org/drawingml/2006/chart" r:id="R0e180df2e2c34b3a"/>
+            <c:chart xmlns:r="http://schemas.openxmlformats.org/officeDocument/2006/relationships" xmlns:c="http://schemas.openxmlformats.org/drawingml/2006/chart" r:id="R48dfc21d3b6340f1"/>
           </a:graphicData>
         </a:graphic>
       </p:graphicFrame>
@@ -8032,7 +8184,7 @@
           <p:cNvPr id="5" name="">
             <a:extLst xmlns:a="http://schemas.openxmlformats.org/drawingml/2006/main">
               <a:ext uri="{FF2B5EF4-FFF2-40B4-BE49-F238E27FC236}">
-                <a16:creationId xmlns:a16="http://schemas.microsoft.com/office/drawing/2014/main" id="{BABDA742-0D56-430F-B404-A868F10E56D0}"/>
+                <a16:creationId xmlns:a16="http://schemas.microsoft.com/office/drawing/2014/main" id="{C920D090-26BE-425E-919D-16BE10836B2D}"/>
               </a:ext>
             </a:extLst>
           </p:cNvPr>
@@ -8089,7 +8241,7 @@
           <p:cNvPr id="6" name="">
             <a:extLst xmlns:a="http://schemas.openxmlformats.org/drawingml/2006/main">
               <a:ext uri="{FF2B5EF4-FFF2-40B4-BE49-F238E27FC236}">
-                <a16:creationId xmlns:a16="http://schemas.microsoft.com/office/drawing/2014/main" id="{F2DB24C9-CD4A-44F0-9945-4E7256478633}"/>
+                <a16:creationId xmlns:a16="http://schemas.microsoft.com/office/drawing/2014/main" id="{3518440B-5DF5-49D5-B57B-D05CA231E222}"/>
               </a:ext>
             </a:extLst>
           </p:cNvPr>
@@ -8146,7 +8298,7 @@
           <p:cNvPr id="7" name="">
             <a:extLst xmlns:a="http://schemas.openxmlformats.org/drawingml/2006/main">
               <a:ext uri="{FF2B5EF4-FFF2-40B4-BE49-F238E27FC236}">
-                <a16:creationId xmlns:a16="http://schemas.microsoft.com/office/drawing/2014/main" id="{F6140C55-02C9-4B5B-9138-A1BBC36C569A}"/>
+                <a16:creationId xmlns:a16="http://schemas.microsoft.com/office/drawing/2014/main" id="{772944A1-DBB9-4F07-90C0-E2E5A7245163}"/>
               </a:ext>
             </a:extLst>
           </p:cNvPr>
@@ -8203,7 +8355,7 @@
           <p:cNvPr id="8" name="">
             <a:extLst xmlns:a="http://schemas.openxmlformats.org/drawingml/2006/main">
               <a:ext uri="{FF2B5EF4-FFF2-40B4-BE49-F238E27FC236}">
-                <a16:creationId xmlns:a16="http://schemas.microsoft.com/office/drawing/2014/main" id="{014CB00D-CED0-4750-80E6-B1A444539D00}"/>
+                <a16:creationId xmlns:a16="http://schemas.microsoft.com/office/drawing/2014/main" id="{6CC2D761-F5D7-41DE-ADCC-80B3F1237C74}"/>
               </a:ext>
             </a:extLst>
           </p:cNvPr>
@@ -8290,7 +8442,7 @@
           <p:cNvPr id="9" name="">
             <a:extLst xmlns:a="http://schemas.openxmlformats.org/drawingml/2006/main">
               <a:ext uri="{FF2B5EF4-FFF2-40B4-BE49-F238E27FC236}">
-                <a16:creationId xmlns:a16="http://schemas.microsoft.com/office/drawing/2014/main" id="{756BC563-9E18-4605-A6A5-45162D1169E1}"/>
+                <a16:creationId xmlns:a16="http://schemas.microsoft.com/office/drawing/2014/main" id="{2085DB68-15AA-461E-AC2C-101B8ED0509F}"/>
               </a:ext>
             </a:extLst>
           </p:cNvPr>
@@ -8347,7 +8499,7 @@
           <p:cNvPr id="10" name="">
             <a:extLst xmlns:a="http://schemas.openxmlformats.org/drawingml/2006/main">
               <a:ext uri="{FF2B5EF4-FFF2-40B4-BE49-F238E27FC236}">
-                <a16:creationId xmlns:a16="http://schemas.microsoft.com/office/drawing/2014/main" id="{7B401496-04C6-42F4-8F37-505E270F70B9}"/>
+                <a16:creationId xmlns:a16="http://schemas.microsoft.com/office/drawing/2014/main" id="{29E5FC48-79CD-4D0A-9E1E-9E77CE07BBF7}"/>
               </a:ext>
             </a:extLst>
           </p:cNvPr>
@@ -8404,7 +8556,7 @@
           <p:cNvPr id="11" name="">
             <a:extLst xmlns:a="http://schemas.openxmlformats.org/drawingml/2006/main">
               <a:ext uri="{FF2B5EF4-FFF2-40B4-BE49-F238E27FC236}">
-                <a16:creationId xmlns:a16="http://schemas.microsoft.com/office/drawing/2014/main" id="{22F1A596-C66F-4117-A628-EBB2603142CF}"/>
+                <a16:creationId xmlns:a16="http://schemas.microsoft.com/office/drawing/2014/main" id="{235BFD50-942A-462F-AEC2-C47A19E59DC9}"/>
               </a:ext>
             </a:extLst>
           </p:cNvPr>
@@ -8461,7 +8613,7 @@
           <p:cNvPr id="12" name="">
             <a:extLst xmlns:a="http://schemas.openxmlformats.org/drawingml/2006/main">
               <a:ext uri="{FF2B5EF4-FFF2-40B4-BE49-F238E27FC236}">
-                <a16:creationId xmlns:a16="http://schemas.microsoft.com/office/drawing/2014/main" id="{A588C998-48AD-4F41-857A-D838037DF139}"/>
+                <a16:creationId xmlns:a16="http://schemas.microsoft.com/office/drawing/2014/main" id="{36334822-CDF3-4FF0-BDF7-A91795AA942E}"/>
               </a:ext>
             </a:extLst>
           </p:cNvPr>
@@ -8516,7 +8668,7 @@
     </p:spTree>
     <p:extLst>
       <p:ext uri="{BB962C8B-B14F-4D97-AF65-F5344CB8AC3E}">
-        <p14:creationId xmlns:p14="http://schemas.microsoft.com/office/powerpoint/2010/main" val="96921027"/>
+        <p14:creationId xmlns:p14="http://schemas.microsoft.com/office/powerpoint/2010/main" val="946239598"/>
       </p:ext>
     </p:extLst>
   </p:cSld>
@@ -8544,10 +8696,10 @@
       </p:grpSpPr>
       <p:sp>
         <p:nvSpPr>
-          <p:cNvPr id="13" name="">
-            <a:extLst xmlns:a="http://schemas.openxmlformats.org/drawingml/2006/main">
-              <a:ext uri="{FF2B5EF4-FFF2-40B4-BE49-F238E27FC236}">
-                <a16:creationId xmlns:a16="http://schemas.microsoft.com/office/drawing/2014/main" id="{0DB78CAB-F3C4-4F1D-9BE7-5DD0584BE0CB}"/>
+          <p:cNvPr id="14" name="">
+            <a:extLst xmlns:a="http://schemas.openxmlformats.org/drawingml/2006/main">
+              <a:ext uri="{FF2B5EF4-FFF2-40B4-BE49-F238E27FC236}">
+                <a16:creationId xmlns:a16="http://schemas.microsoft.com/office/drawing/2014/main" id="{E0B02795-8590-4967-A263-624B580A1F5E}"/>
               </a:ext>
             </a:extLst>
           </p:cNvPr>
@@ -8604,7 +8756,7 @@
           <p:cNvPr id="2" name="">
             <a:extLst xmlns:a="http://schemas.openxmlformats.org/drawingml/2006/main">
               <a:ext uri="{FF2B5EF4-FFF2-40B4-BE49-F238E27FC236}">
-                <a16:creationId xmlns:a16="http://schemas.microsoft.com/office/drawing/2014/main" id="{D1393494-F0E4-4B1C-AB5B-A00ECAE84B02}"/>
+                <a16:creationId xmlns:a16="http://schemas.microsoft.com/office/drawing/2014/main" id="{CBF1CAC2-513F-4F31-8E61-6FFE2246065C}"/>
               </a:ext>
             </a:extLst>
           </p:cNvPr>
@@ -8651,7 +8803,7 @@
                 <a:ea typeface="Helvetica Neue"/>
                 <a:cs typeface="Helvetica Neue"/>
               </a:rPr>
-              <a:t>Actual rejection workflow after a metrics-focused revision</a:t>
+              <a:t>Session-only review with a downloadable audit record</a:t>
             </a:r>
           </a:p>
         </p:txBody>
@@ -8661,7 +8813,7 @@
           <p:cNvPr id="3" name="">
             <a:extLst xmlns:a="http://schemas.openxmlformats.org/drawingml/2006/main">
               <a:ext uri="{FF2B5EF4-FFF2-40B4-BE49-F238E27FC236}">
-                <a16:creationId xmlns:a16="http://schemas.microsoft.com/office/drawing/2014/main" id="{349AD90A-BA35-4E07-823E-88C530B0B8A3}"/>
+                <a16:creationId xmlns:a16="http://schemas.microsoft.com/office/drawing/2014/main" id="{BB4FEA5A-6F85-423C-A8A6-5758B053DE8F}"/>
               </a:ext>
             </a:extLst>
           </p:cNvPr>
@@ -8689,14 +8841,14 @@
       </p:sp>
       <p:pic>
         <p:nvPicPr>
-          <p:cNvPr id="16" name=""/>
+          <p:cNvPr id="17" name=""/>
           <p:cNvPicPr>
             <a:picLocks xmlns:a="http://schemas.openxmlformats.org/drawingml/2006/main" noChangeAspect="1"/>
           </p:cNvPicPr>
           <p:nvPr/>
         </p:nvPicPr>
         <p:blipFill>
-          <a:blip xmlns:r="http://schemas.openxmlformats.org/officeDocument/2006/relationships" xmlns:a="http://schemas.openxmlformats.org/drawingml/2006/main" r:embed="Rf44e8487783b4b38"/>
+          <a:blip xmlns:r="http://schemas.openxmlformats.org/officeDocument/2006/relationships" xmlns:a="http://schemas.openxmlformats.org/drawingml/2006/main" r:embed="R5c3fd6030952421d"/>
           <a:stretch xmlns:a="http://schemas.openxmlformats.org/drawingml/2006/main"/>
         </p:blipFill>
         <p:spPr>
@@ -8714,7 +8866,7 @@
           <p:cNvPr id="5" name="">
             <a:extLst xmlns:a="http://schemas.openxmlformats.org/drawingml/2006/main">
               <a:ext uri="{FF2B5EF4-FFF2-40B4-BE49-F238E27FC236}">
-                <a16:creationId xmlns:a16="http://schemas.microsoft.com/office/drawing/2014/main" id="{F136B01B-8608-4747-82FF-4CEE6F09503A}"/>
+                <a16:creationId xmlns:a16="http://schemas.microsoft.com/office/drawing/2014/main" id="{4096BB89-8E33-477E-9AC9-02D463D53636}"/>
               </a:ext>
             </a:extLst>
           </p:cNvPr>
@@ -8771,7 +8923,7 @@
           <p:cNvPr id="6" name="">
             <a:extLst xmlns:a="http://schemas.openxmlformats.org/drawingml/2006/main">
               <a:ext uri="{FF2B5EF4-FFF2-40B4-BE49-F238E27FC236}">
-                <a16:creationId xmlns:a16="http://schemas.microsoft.com/office/drawing/2014/main" id="{43A029D9-1391-4E73-851D-AF36695941F9}"/>
+                <a16:creationId xmlns:a16="http://schemas.microsoft.com/office/drawing/2014/main" id="{4EA5F284-71D4-4B40-A836-74FFBA1A3D73}"/>
               </a:ext>
             </a:extLst>
           </p:cNvPr>
@@ -8828,7 +8980,7 @@
           <p:cNvPr id="7" name="">
             <a:extLst xmlns:a="http://schemas.openxmlformats.org/drawingml/2006/main">
               <a:ext uri="{FF2B5EF4-FFF2-40B4-BE49-F238E27FC236}">
-                <a16:creationId xmlns:a16="http://schemas.microsoft.com/office/drawing/2014/main" id="{8AF65A9A-0364-429E-A524-488179CA3DAD}"/>
+                <a16:creationId xmlns:a16="http://schemas.microsoft.com/office/drawing/2014/main" id="{132EAB74-A529-45D1-805A-AD889C185A55}"/>
               </a:ext>
             </a:extLst>
           </p:cNvPr>
@@ -8885,7 +9037,7 @@
           <p:cNvPr id="8" name="">
             <a:extLst xmlns:a="http://schemas.openxmlformats.org/drawingml/2006/main">
               <a:ext uri="{FF2B5EF4-FFF2-40B4-BE49-F238E27FC236}">
-                <a16:creationId xmlns:a16="http://schemas.microsoft.com/office/drawing/2014/main" id="{2C486A83-9443-4287-BB14-46570E45F894}"/>
+                <a16:creationId xmlns:a16="http://schemas.microsoft.com/office/drawing/2014/main" id="{6CA2A1D8-AC0A-4133-9F7B-E4E41BFF5AEC}"/>
               </a:ext>
             </a:extLst>
           </p:cNvPr>
@@ -8942,7 +9094,7 @@
           <p:cNvPr id="9" name="">
             <a:extLst xmlns:a="http://schemas.openxmlformats.org/drawingml/2006/main">
               <a:ext uri="{FF2B5EF4-FFF2-40B4-BE49-F238E27FC236}">
-                <a16:creationId xmlns:a16="http://schemas.microsoft.com/office/drawing/2014/main" id="{21B940A9-8CB2-441D-8770-D33CF4D7D676}"/>
+                <a16:creationId xmlns:a16="http://schemas.microsoft.com/office/drawing/2014/main" id="{A826B0CF-1DC7-48AE-9AA9-C687FEF9BF73}"/>
               </a:ext>
             </a:extLst>
           </p:cNvPr>
@@ -8999,23 +9151,80 @@
           <p:cNvPr id="10" name="">
             <a:extLst xmlns:a="http://schemas.openxmlformats.org/drawingml/2006/main">
               <a:ext uri="{FF2B5EF4-FFF2-40B4-BE49-F238E27FC236}">
-                <a16:creationId xmlns:a16="http://schemas.microsoft.com/office/drawing/2014/main" id="{0A85BCCC-AD92-4740-8290-E98903856EBE}"/>
-              </a:ext>
-            </a:extLst>
-          </p:cNvPr>
-          <p:cNvSpPr>
-            <a:spLocks xmlns:a="http://schemas.openxmlformats.org/drawingml/2006/main" noGrp="1"/>
-          </p:cNvSpPr>
-          <p:nvPr/>
-        </p:nvSpPr>
-        <p:spPr>
-          <a:xfrm xmlns:a="http://schemas.openxmlformats.org/drawingml/2006/main">
-            <a:off x="619125" y="5000625"/>
-            <a:ext cx="3143250" cy="781050"/>
+                <a16:creationId xmlns:a16="http://schemas.microsoft.com/office/drawing/2014/main" id="{1FF524C3-9643-40DB-A497-6DCB7BC85670}"/>
+              </a:ext>
+            </a:extLst>
+          </p:cNvPr>
+          <p:cNvSpPr>
+            <a:spLocks xmlns:a="http://schemas.openxmlformats.org/drawingml/2006/main" noGrp="1"/>
+          </p:cNvSpPr>
+          <p:nvPr/>
+        </p:nvSpPr>
+        <p:spPr>
+          <a:xfrm xmlns:a="http://schemas.openxmlformats.org/drawingml/2006/main">
+            <a:off x="666750" y="4724400"/>
+            <a:ext cx="3000375" cy="400050"/>
+          </a:xfrm>
+          <a:prstGeom xmlns:a="http://schemas.openxmlformats.org/drawingml/2006/main" prst="rect">
+            <a:avLst/>
+          </a:prstGeom>
+          <a:noFill xmlns:a="http://schemas.openxmlformats.org/drawingml/2006/main"/>
+          <a:ln xmlns:a="http://schemas.openxmlformats.org/drawingml/2006/main" w="0">
+            <a:noFill/>
+          </a:ln>
+        </p:spPr>
+        <p:txBody>
+          <a:bodyPr xmlns:a="http://schemas.openxmlformats.org/drawingml/2006/main" anchor="ctr">
+            <a:normAutofit fontScale="99432"/>
+          </a:bodyPr>
+          <a:lstStyle xmlns:a="http://schemas.openxmlformats.org/drawingml/2006/main"/>
+          <a:p xmlns:a="http://schemas.openxmlformats.org/drawingml/2006/main">
+            <a:pPr algn="l">
+              <a:defRPr sz="1500" b="1">
+                <a:solidFill>
+                  <a:srgbClr val="C43C45"/>
+                </a:solidFill>
+                <a:latin typeface="Helvetica Neue"/>
+                <a:ea typeface="Helvetica Neue"/>
+                <a:cs typeface="Helvetica Neue"/>
+              </a:defRPr>
+            </a:pPr>
+            <a:r>
+              <a:rPr sz="1500" b="1">
+                <a:solidFill>
+                  <a:srgbClr val="C43C45"/>
+                </a:solidFill>
+                <a:latin typeface="Helvetica Neue"/>
+                <a:ea typeface="Helvetica Neue"/>
+                <a:cs typeface="Helvetica Neue"/>
+              </a:rPr>
+              <a:t>Log clears after reload or close</a:t>
+            </a:r>
+          </a:p>
+        </p:txBody>
+      </p:sp>
+      <p:sp>
+        <p:nvSpPr>
+          <p:cNvPr id="11" name="">
+            <a:extLst xmlns:a="http://schemas.openxmlformats.org/drawingml/2006/main">
+              <a:ext uri="{FF2B5EF4-FFF2-40B4-BE49-F238E27FC236}">
+                <a16:creationId xmlns:a16="http://schemas.microsoft.com/office/drawing/2014/main" id="{B4780E5B-64A3-4126-9DE1-430D110216AD}"/>
+              </a:ext>
+            </a:extLst>
+          </p:cNvPr>
+          <p:cNvSpPr>
+            <a:spLocks xmlns:a="http://schemas.openxmlformats.org/drawingml/2006/main" noGrp="1"/>
+          </p:cNvSpPr>
+          <p:nvPr/>
+        </p:nvSpPr>
+        <p:spPr>
+          <a:xfrm xmlns:a="http://schemas.openxmlformats.org/drawingml/2006/main">
+            <a:off x="619125" y="5257800"/>
+            <a:ext cx="3143250" cy="647700"/>
           </a:xfrm>
           <a:prstGeom xmlns:a="http://schemas.openxmlformats.org/drawingml/2006/main" prst="roundRect">
             <a:avLst>
-              <a:gd name="adj" fmla="val 9756"/>
+              <a:gd name="adj" fmla="val 11765"/>
             </a:avLst>
           </a:prstGeom>
           <a:solidFill xmlns:a="http://schemas.openxmlformats.org/drawingml/2006/main">
@@ -9035,7 +9244,7 @@
           <a:lstStyle xmlns:a="http://schemas.openxmlformats.org/drawingml/2006/main"/>
           <a:p xmlns:a="http://schemas.openxmlformats.org/drawingml/2006/main">
             <a:pPr algn="ctr">
-              <a:defRPr sz="1575" b="1">
+              <a:defRPr sz="1500" b="1">
                 <a:solidFill>
                   <a:srgbClr val="237A57"/>
                 </a:solidFill>
@@ -9045,7 +9254,7 @@
               </a:defRPr>
             </a:pPr>
             <a:r>
-              <a:rPr sz="1575" b="1">
+              <a:rPr sz="1500" b="1">
                 <a:solidFill>
                   <a:srgbClr val="237A57"/>
                 </a:solidFill>
@@ -9053,17 +9262,40 @@
                 <a:ea typeface="Helvetica Neue"/>
                 <a:cs typeface="Helvetica Neue"/>
               </a:rPr>
-              <a:t>Reviewer comments stay separate from system text</a:t>
-            </a:r>
-          </a:p>
-        </p:txBody>
-      </p:sp>
-      <p:sp>
-        <p:nvSpPr>
-          <p:cNvPr id="11" name="">
-            <a:extLst xmlns:a="http://schemas.openxmlformats.org/drawingml/2006/main">
-              <a:ext uri="{FF2B5EF4-FFF2-40B4-BE49-F238E27FC236}">
-                <a16:creationId xmlns:a16="http://schemas.microsoft.com/office/drawing/2014/main" id="{CC11E60E-175E-434A-9109-94B7A2D3AD47}"/>
+              <a:t>Session-only log</a:t>
+            </a:r>
+          </a:p>
+          <a:p xmlns:a="http://schemas.openxmlformats.org/drawingml/2006/main">
+            <a:pPr algn="ctr">
+              <a:defRPr sz="1500" b="1">
+                <a:solidFill>
+                  <a:srgbClr val="237A57"/>
+                </a:solidFill>
+                <a:latin typeface="Helvetica Neue"/>
+                <a:ea typeface="Helvetica Neue"/>
+                <a:cs typeface="Helvetica Neue"/>
+              </a:defRPr>
+            </a:pPr>
+            <a:r>
+              <a:rPr sz="1500" b="1">
+                <a:solidFill>
+                  <a:srgbClr val="237A57"/>
+                </a:solidFill>
+                <a:latin typeface="Helvetica Neue"/>
+                <a:ea typeface="Helvetica Neue"/>
+                <a:cs typeface="Helvetica Neue"/>
+              </a:rPr>
+              <a:t>Download before reloading</a:t>
+            </a:r>
+          </a:p>
+        </p:txBody>
+      </p:sp>
+      <p:sp>
+        <p:nvSpPr>
+          <p:cNvPr id="12" name="">
+            <a:extLst xmlns:a="http://schemas.openxmlformats.org/drawingml/2006/main">
+              <a:ext uri="{FF2B5EF4-FFF2-40B4-BE49-F238E27FC236}">
+                <a16:creationId xmlns:a16="http://schemas.microsoft.com/office/drawing/2014/main" id="{CD33E66F-650F-4320-A7F7-F445E567EC0E}"/>
               </a:ext>
             </a:extLst>
           </p:cNvPr>
@@ -9117,10 +9349,10 @@
       </p:sp>
       <p:sp>
         <p:nvSpPr>
-          <p:cNvPr id="12" name="">
-            <a:extLst xmlns:a="http://schemas.openxmlformats.org/drawingml/2006/main">
-              <a:ext uri="{FF2B5EF4-FFF2-40B4-BE49-F238E27FC236}">
-                <a16:creationId xmlns:a16="http://schemas.microsoft.com/office/drawing/2014/main" id="{7E374E98-BA51-4EA3-A696-C7D60CB20A84}"/>
+          <p:cNvPr id="13" name="">
+            <a:extLst xmlns:a="http://schemas.openxmlformats.org/drawingml/2006/main">
+              <a:ext uri="{FF2B5EF4-FFF2-40B4-BE49-F238E27FC236}">
+                <a16:creationId xmlns:a16="http://schemas.microsoft.com/office/drawing/2014/main" id="{39DEAEAC-2F0D-4DD9-94B2-C197780154BF}"/>
               </a:ext>
             </a:extLst>
           </p:cNvPr>
@@ -9175,7 +9407,7 @@
     </p:spTree>
     <p:extLst>
       <p:ext uri="{BB962C8B-B14F-4D97-AF65-F5344CB8AC3E}">
-        <p14:creationId xmlns:p14="http://schemas.microsoft.com/office/powerpoint/2010/main" val="282599716"/>
+        <p14:creationId xmlns:p14="http://schemas.microsoft.com/office/powerpoint/2010/main" val="1737252537"/>
       </p:ext>
     </p:extLst>
   </p:cSld>
@@ -9203,10 +9435,10 @@
       </p:grpSpPr>
       <p:sp>
         <p:nvSpPr>
-          <p:cNvPr id="17" name="">
-            <a:extLst xmlns:a="http://schemas.openxmlformats.org/drawingml/2006/main">
-              <a:ext uri="{FF2B5EF4-FFF2-40B4-BE49-F238E27FC236}">
-                <a16:creationId xmlns:a16="http://schemas.microsoft.com/office/drawing/2014/main" id="{5CB0E3F2-F832-42FD-B406-B470EA980F54}"/>
+          <p:cNvPr id="16" name="">
+            <a:extLst xmlns:a="http://schemas.openxmlformats.org/drawingml/2006/main">
+              <a:ext uri="{FF2B5EF4-FFF2-40B4-BE49-F238E27FC236}">
+                <a16:creationId xmlns:a16="http://schemas.microsoft.com/office/drawing/2014/main" id="{A4022AB6-F518-47D9-8029-BA770072A25F}"/>
               </a:ext>
             </a:extLst>
           </p:cNvPr>
@@ -9253,7 +9485,7 @@
                 <a:ea typeface="Helvetica Neue"/>
                 <a:cs typeface="Helvetica Neue"/>
               </a:rPr>
-              <a:t>Bounded AI-assisted implementation</a:t>
+              <a:t>Codex-assisted implementation</a:t>
             </a:r>
           </a:p>
         </p:txBody>
@@ -9263,7 +9495,7 @@
           <p:cNvPr id="2" name="">
             <a:extLst xmlns:a="http://schemas.openxmlformats.org/drawingml/2006/main">
               <a:ext uri="{FF2B5EF4-FFF2-40B4-BE49-F238E27FC236}">
-                <a16:creationId xmlns:a16="http://schemas.microsoft.com/office/drawing/2014/main" id="{43B31A9F-6D8B-4212-8936-E60E80714B67}"/>
+                <a16:creationId xmlns:a16="http://schemas.microsoft.com/office/drawing/2014/main" id="{F63C4E4C-AD27-4F21-BF59-3489ADDB8417}"/>
               </a:ext>
             </a:extLst>
           </p:cNvPr>
@@ -9310,7 +9542,7 @@
                 <a:ea typeface="Helvetica Neue"/>
                 <a:cs typeface="Helvetica Neue"/>
               </a:rPr>
-              <a:t>Agentic development with human checkpoints, deterministic runtime</a:t>
+              <a:t>Human approval governed development. Runtime remains deterministic.</a:t>
             </a:r>
           </a:p>
         </p:txBody>
@@ -9320,7 +9552,7 @@
           <p:cNvPr id="3" name="">
             <a:extLst xmlns:a="http://schemas.openxmlformats.org/drawingml/2006/main">
               <a:ext uri="{FF2B5EF4-FFF2-40B4-BE49-F238E27FC236}">
-                <a16:creationId xmlns:a16="http://schemas.microsoft.com/office/drawing/2014/main" id="{FD499197-1EBC-440E-B200-0BFD15EC6C0F}"/>
+                <a16:creationId xmlns:a16="http://schemas.microsoft.com/office/drawing/2014/main" id="{C797CCBA-0E86-4FBD-91E0-442469210B62}"/>
               </a:ext>
             </a:extLst>
           </p:cNvPr>
@@ -9351,7 +9583,7 @@
           <p:cNvPr id="4" name="">
             <a:extLst xmlns:a="http://schemas.openxmlformats.org/drawingml/2006/main">
               <a:ext uri="{FF2B5EF4-FFF2-40B4-BE49-F238E27FC236}">
-                <a16:creationId xmlns:a16="http://schemas.microsoft.com/office/drawing/2014/main" id="{1E5EDDA6-EE9A-4C61-923A-DA2CF7FB7773}"/>
+                <a16:creationId xmlns:a16="http://schemas.microsoft.com/office/drawing/2014/main" id="{AD884AD9-3410-455D-A43E-5BAA498A563C}"/>
               </a:ext>
             </a:extLst>
           </p:cNvPr>
@@ -9408,7 +9640,7 @@
           <p:cNvPr id="5" name="">
             <a:extLst xmlns:a="http://schemas.openxmlformats.org/drawingml/2006/main">
               <a:ext uri="{FF2B5EF4-FFF2-40B4-BE49-F238E27FC236}">
-                <a16:creationId xmlns:a16="http://schemas.microsoft.com/office/drawing/2014/main" id="{A6547065-01E2-4DB2-B464-A466B05E63FD}"/>
+                <a16:creationId xmlns:a16="http://schemas.microsoft.com/office/drawing/2014/main" id="{252E3753-D536-4E8E-B892-E24717CDDA95}"/>
               </a:ext>
             </a:extLst>
           </p:cNvPr>
@@ -9420,7 +9652,7 @@
         <p:spPr>
           <a:xfrm xmlns:a="http://schemas.openxmlformats.org/drawingml/2006/main">
             <a:off x="809625" y="2095500"/>
-            <a:ext cx="2952750" cy="1809750"/>
+            <a:ext cx="2952750" cy="2000250"/>
           </a:xfrm>
           <a:prstGeom xmlns:a="http://schemas.openxmlformats.org/drawingml/2006/main" prst="rect">
             <a:avLst/>
@@ -9437,7 +9669,7 @@
           <a:lstStyle xmlns:a="http://schemas.openxmlformats.org/drawingml/2006/main"/>
           <a:p xmlns:a="http://schemas.openxmlformats.org/drawingml/2006/main">
             <a:pPr algn="l">
-              <a:defRPr sz="1725" b="0">
+              <a:defRPr sz="1650" b="0">
                 <a:solidFill>
                   <a:srgbClr val="1F2937"/>
                 </a:solidFill>
@@ -9447,7 +9679,7 @@
               </a:defRPr>
             </a:pPr>
             <a:r>
-              <a:rPr sz="1725" b="0">
+              <a:rPr sz="1650" b="0">
                 <a:solidFill>
                   <a:srgbClr val="1F2937"/>
                 </a:solidFill>
@@ -9455,12 +9687,12 @@
                 <a:ea typeface="Helvetica Neue"/>
                 <a:cs typeface="Helvetica Neue"/>
               </a:rPr>
-              <a:t>Approved the scope</a:t>
+              <a:t>Approved task and constraints</a:t>
             </a:r>
           </a:p>
           <a:p xmlns:a="http://schemas.openxmlformats.org/drawingml/2006/main">
             <a:pPr algn="l">
-              <a:defRPr sz="1725" b="0">
+              <a:defRPr sz="1650" b="0">
                 <a:solidFill>
                   <a:srgbClr val="1F2937"/>
                 </a:solidFill>
@@ -9470,7 +9702,7 @@
               </a:defRPr>
             </a:pPr>
             <a:r>
-              <a:rPr sz="1725" b="0">
+              <a:rPr sz="1650" b="0">
                 <a:solidFill>
                   <a:srgbClr val="1F2937"/>
                 </a:solidFill>
@@ -9483,7 +9715,7 @@
           </a:p>
           <a:p xmlns:a="http://schemas.openxmlformats.org/drawingml/2006/main">
             <a:pPr algn="l">
-              <a:defRPr sz="1725" b="0">
+              <a:defRPr sz="1650" b="0">
                 <a:solidFill>
                   <a:srgbClr val="1F2937"/>
                 </a:solidFill>
@@ -9493,7 +9725,7 @@
               </a:defRPr>
             </a:pPr>
             <a:r>
-              <a:rPr sz="1725" b="0">
+              <a:rPr sz="1650" b="0">
                 <a:solidFill>
                   <a:srgbClr val="1F2937"/>
                 </a:solidFill>
@@ -9501,12 +9733,12 @@
                 <a:ea typeface="Helvetica Neue"/>
                 <a:cs typeface="Helvetica Neue"/>
               </a:rPr>
-              <a:t>Rejected unsafe predictors</a:t>
+              <a:t>Reviewed validation evidence</a:t>
             </a:r>
           </a:p>
           <a:p xmlns:a="http://schemas.openxmlformats.org/drawingml/2006/main">
             <a:pPr algn="l">
-              <a:defRPr sz="1725" b="0">
+              <a:defRPr sz="1650" b="0">
                 <a:solidFill>
                   <a:srgbClr val="1F2937"/>
                 </a:solidFill>
@@ -9516,7 +9748,7 @@
               </a:defRPr>
             </a:pPr>
             <a:r>
-              <a:rPr sz="1725" b="0">
+              <a:rPr sz="1650" b="0">
                 <a:solidFill>
                   <a:srgbClr val="1F2937"/>
                 </a:solidFill>
@@ -9524,7 +9756,30 @@
                 <a:ea typeface="Helvetica Neue"/>
                 <a:cs typeface="Helvetica Neue"/>
               </a:rPr>
-              <a:t>Accepted the safe failure state</a:t>
+              <a:t>Required blocked outputs</a:t>
+            </a:r>
+          </a:p>
+          <a:p xmlns:a="http://schemas.openxmlformats.org/drawingml/2006/main">
+            <a:pPr algn="l">
+              <a:defRPr sz="1650" b="0">
+                <a:solidFill>
+                  <a:srgbClr val="1F2937"/>
+                </a:solidFill>
+                <a:latin typeface="Helvetica Neue"/>
+                <a:ea typeface="Helvetica Neue"/>
+                <a:cs typeface="Helvetica Neue"/>
+              </a:defRPr>
+            </a:pPr>
+            <a:r>
+              <a:rPr sz="1650" b="0">
+                <a:solidFill>
+                  <a:srgbClr val="1F2937"/>
+                </a:solidFill>
+                <a:latin typeface="Helvetica Neue"/>
+                <a:ea typeface="Helvetica Neue"/>
+                <a:cs typeface="Helvetica Neue"/>
+              </a:rPr>
+              <a:t>Authorized publication</a:t>
             </a:r>
           </a:p>
         </p:txBody>
@@ -9534,7 +9789,7 @@
           <p:cNvPr id="6" name="">
             <a:extLst xmlns:a="http://schemas.openxmlformats.org/drawingml/2006/main">
               <a:ext uri="{FF2B5EF4-FFF2-40B4-BE49-F238E27FC236}">
-                <a16:creationId xmlns:a16="http://schemas.microsoft.com/office/drawing/2014/main" id="{22150335-4A04-4CA8-83A6-02E9BF9F37C5}"/>
+                <a16:creationId xmlns:a16="http://schemas.microsoft.com/office/drawing/2014/main" id="{C084AF4C-CA1D-4D4F-A8BE-B369A20F8858}"/>
               </a:ext>
             </a:extLst>
           </p:cNvPr>
@@ -9581,7 +9836,7 @@
                 <a:ea typeface="Helvetica Neue"/>
                 <a:cs typeface="Helvetica Neue"/>
               </a:rPr>
-              <a:t>AI implementation</a:t>
+              <a:t>Codex contributions</a:t>
             </a:r>
           </a:p>
         </p:txBody>
@@ -9591,7 +9846,7 @@
           <p:cNvPr id="7" name="">
             <a:extLst xmlns:a="http://schemas.openxmlformats.org/drawingml/2006/main">
               <a:ext uri="{FF2B5EF4-FFF2-40B4-BE49-F238E27FC236}">
-                <a16:creationId xmlns:a16="http://schemas.microsoft.com/office/drawing/2014/main" id="{F16A6627-783F-42EB-8380-CEC4E48148DC}"/>
+                <a16:creationId xmlns:a16="http://schemas.microsoft.com/office/drawing/2014/main" id="{40C62D1C-60A8-4774-8611-428150B167EA}"/>
               </a:ext>
             </a:extLst>
           </p:cNvPr>
@@ -9603,7 +9858,7 @@
         <p:spPr>
           <a:xfrm xmlns:a="http://schemas.openxmlformats.org/drawingml/2006/main">
             <a:off x="4524375" y="2095500"/>
-            <a:ext cx="3048000" cy="1809750"/>
+            <a:ext cx="3048000" cy="2000250"/>
           </a:xfrm>
           <a:prstGeom xmlns:a="http://schemas.openxmlformats.org/drawingml/2006/main" prst="rect">
             <a:avLst/>
@@ -9620,7 +9875,7 @@
           <a:lstStyle xmlns:a="http://schemas.openxmlformats.org/drawingml/2006/main"/>
           <a:p xmlns:a="http://schemas.openxmlformats.org/drawingml/2006/main">
             <a:pPr algn="l">
-              <a:defRPr sz="1725" b="0">
+              <a:defRPr sz="1650" b="0">
                 <a:solidFill>
                   <a:srgbClr val="1F2937"/>
                 </a:solidFill>
@@ -9630,7 +9885,7 @@
               </a:defRPr>
             </a:pPr>
             <a:r>
-              <a:rPr sz="1725" b="0">
+              <a:rPr sz="1650" b="0">
                 <a:solidFill>
                   <a:srgbClr val="1F2937"/>
                 </a:solidFill>
@@ -9638,12 +9893,12 @@
                 <a:ea typeface="Helvetica Neue"/>
                 <a:cs typeface="Helvetica Neue"/>
               </a:rPr>
-              <a:t>Audited project data</a:t>
+              <a:t>Audited files and provenance</a:t>
             </a:r>
           </a:p>
           <a:p xmlns:a="http://schemas.openxmlformats.org/drawingml/2006/main">
             <a:pPr algn="l">
-              <a:defRPr sz="1725" b="0">
+              <a:defRPr sz="1650" b="0">
                 <a:solidFill>
                   <a:srgbClr val="1F2937"/>
                 </a:solidFill>
@@ -9653,7 +9908,7 @@
               </a:defRPr>
             </a:pPr>
             <a:r>
-              <a:rPr sz="1725" b="0">
+              <a:rPr sz="1650" b="0">
                 <a:solidFill>
                   <a:srgbClr val="1F2937"/>
                 </a:solidFill>
@@ -9661,12 +9916,12 @@
                 <a:ea typeface="Helvetica Neue"/>
                 <a:cs typeface="Helvetica Neue"/>
               </a:rPr>
-              <a:t>Built reproducible code</a:t>
+              <a:t>Implemented scoped code</a:t>
             </a:r>
           </a:p>
           <a:p xmlns:a="http://schemas.openxmlformats.org/drawingml/2006/main">
             <a:pPr algn="l">
-              <a:defRPr sz="1725" b="0">
+              <a:defRPr sz="1650" b="0">
                 <a:solidFill>
                   <a:srgbClr val="1F2937"/>
                 </a:solidFill>
@@ -9676,7 +9931,7 @@
               </a:defRPr>
             </a:pPr>
             <a:r>
-              <a:rPr sz="1725" b="0">
+              <a:rPr sz="1650" b="0">
                 <a:solidFill>
                   <a:srgbClr val="1F2937"/>
                 </a:solidFill>
@@ -9684,12 +9939,12 @@
                 <a:ea typeface="Helvetica Neue"/>
                 <a:cs typeface="Helvetica Neue"/>
               </a:rPr>
-              <a:t>Verified SHAP mathematics</a:t>
+              <a:t>Debugged and ran tests</a:t>
             </a:r>
           </a:p>
           <a:p xmlns:a="http://schemas.openxmlformats.org/drawingml/2006/main">
             <a:pPr algn="l">
-              <a:defRPr sz="1725" b="0">
+              <a:defRPr sz="1650" b="0">
                 <a:solidFill>
                   <a:srgbClr val="1F2937"/>
                 </a:solidFill>
@@ -9699,7 +9954,7 @@
               </a:defRPr>
             </a:pPr>
             <a:r>
-              <a:rPr sz="1725" b="0">
+              <a:rPr sz="1650" b="0">
                 <a:solidFill>
                   <a:srgbClr val="1F2937"/>
                 </a:solidFill>
@@ -9707,7 +9962,30 @@
                 <a:ea typeface="Helvetica Neue"/>
                 <a:cs typeface="Helvetica Neue"/>
               </a:rPr>
-              <a:t>Executed UI and test workflows</a:t>
+              <a:t>Verified UI and screenshots</a:t>
+            </a:r>
+          </a:p>
+          <a:p xmlns:a="http://schemas.openxmlformats.org/drawingml/2006/main">
+            <a:pPr algn="l">
+              <a:defRPr sz="1650" b="0">
+                <a:solidFill>
+                  <a:srgbClr val="1F2937"/>
+                </a:solidFill>
+                <a:latin typeface="Helvetica Neue"/>
+                <a:ea typeface="Helvetica Neue"/>
+                <a:cs typeface="Helvetica Neue"/>
+              </a:defRPr>
+            </a:pPr>
+            <a:r>
+              <a:rPr sz="1650" b="0">
+                <a:solidFill>
+                  <a:srgbClr val="1F2937"/>
+                </a:solidFill>
+                <a:latin typeface="Helvetica Neue"/>
+                <a:ea typeface="Helvetica Neue"/>
+                <a:cs typeface="Helvetica Neue"/>
+              </a:rPr>
+              <a:t>Prepared and validated slides</a:t>
             </a:r>
           </a:p>
         </p:txBody>
@@ -9717,7 +9995,7 @@
           <p:cNvPr id="8" name="">
             <a:extLst xmlns:a="http://schemas.openxmlformats.org/drawingml/2006/main">
               <a:ext uri="{FF2B5EF4-FFF2-40B4-BE49-F238E27FC236}">
-                <a16:creationId xmlns:a16="http://schemas.microsoft.com/office/drawing/2014/main" id="{36A25965-3CA0-40A7-A311-2DDC6281310C}"/>
+                <a16:creationId xmlns:a16="http://schemas.microsoft.com/office/drawing/2014/main" id="{9755436F-DFE2-4F30-A40D-A3D6F41B2705}"/>
               </a:ext>
             </a:extLst>
           </p:cNvPr>
@@ -9774,7 +10052,7 @@
           <p:cNvPr id="9" name="">
             <a:extLst xmlns:a="http://schemas.openxmlformats.org/drawingml/2006/main">
               <a:ext uri="{FF2B5EF4-FFF2-40B4-BE49-F238E27FC236}">
-                <a16:creationId xmlns:a16="http://schemas.microsoft.com/office/drawing/2014/main" id="{EDC7D1C6-0797-42D5-8C81-D5041BCABBD7}"/>
+                <a16:creationId xmlns:a16="http://schemas.microsoft.com/office/drawing/2014/main" id="{1032FD8A-A1C8-4053-A5CB-895AC6089EC7}"/>
               </a:ext>
             </a:extLst>
           </p:cNvPr>
@@ -9803,7 +10081,7 @@
           <a:lstStyle xmlns:a="http://schemas.openxmlformats.org/drawingml/2006/main"/>
           <a:p xmlns:a="http://schemas.openxmlformats.org/drawingml/2006/main">
             <a:pPr algn="l">
-              <a:defRPr sz="1725" b="0">
+              <a:defRPr sz="1650" b="0">
                 <a:solidFill>
                   <a:srgbClr val="1F2937"/>
                 </a:solidFill>
@@ -9813,7 +10091,7 @@
               </a:defRPr>
             </a:pPr>
             <a:r>
-              <a:rPr sz="1725" b="0">
+              <a:rPr sz="1650" b="0">
                 <a:solidFill>
                   <a:srgbClr val="1F2937"/>
                 </a:solidFill>
@@ -9821,12 +10099,12 @@
                 <a:ea typeface="Helvetica Neue"/>
                 <a:cs typeface="Helvetica Neue"/>
               </a:rPr>
-              <a:t>No autonomous agent</a:t>
+              <a:t>No autonomous runtime agent</a:t>
             </a:r>
           </a:p>
           <a:p xmlns:a="http://schemas.openxmlformats.org/drawingml/2006/main">
             <a:pPr algn="l">
-              <a:defRPr sz="1725" b="0">
+              <a:defRPr sz="1650" b="0">
                 <a:solidFill>
                   <a:srgbClr val="1F2937"/>
                 </a:solidFill>
@@ -9836,7 +10114,7 @@
               </a:defRPr>
             </a:pPr>
             <a:r>
-              <a:rPr sz="1725" b="0">
+              <a:rPr sz="1650" b="0">
                 <a:solidFill>
                   <a:srgbClr val="1F2937"/>
                 </a:solidFill>
@@ -9849,7 +10127,7 @@
           </a:p>
           <a:p xmlns:a="http://schemas.openxmlformats.org/drawingml/2006/main">
             <a:pPr algn="l">
-              <a:defRPr sz="1725" b="0">
+              <a:defRPr sz="1650" b="0">
                 <a:solidFill>
                   <a:srgbClr val="1F2937"/>
                 </a:solidFill>
@@ -9859,7 +10137,7 @@
               </a:defRPr>
             </a:pPr>
             <a:r>
-              <a:rPr sz="1725" b="0">
+              <a:rPr sz="1650" b="0">
                 <a:solidFill>
                   <a:srgbClr val="1F2937"/>
                 </a:solidFill>
@@ -9867,12 +10145,12 @@
                 <a:ea typeface="Helvetica Neue"/>
                 <a:cs typeface="Helvetica Neue"/>
               </a:rPr>
-              <a:t>Deterministic explanation</a:t>
+              <a:t>Deterministic safety output</a:t>
             </a:r>
           </a:p>
           <a:p xmlns:a="http://schemas.openxmlformats.org/drawingml/2006/main">
             <a:pPr algn="l">
-              <a:defRPr sz="1725" b="0">
+              <a:defRPr sz="1650" b="0">
                 <a:solidFill>
                   <a:srgbClr val="1F2937"/>
                 </a:solidFill>
@@ -9882,7 +10160,7 @@
               </a:defRPr>
             </a:pPr>
             <a:r>
-              <a:rPr sz="1725" b="0">
+              <a:rPr sz="1650" b="0">
                 <a:solidFill>
                   <a:srgbClr val="1F2937"/>
                 </a:solidFill>
@@ -9900,7 +10178,7 @@
           <p:cNvPr id="10" name="">
             <a:extLst xmlns:a="http://schemas.openxmlformats.org/drawingml/2006/main">
               <a:ext uri="{FF2B5EF4-FFF2-40B4-BE49-F238E27FC236}">
-                <a16:creationId xmlns:a16="http://schemas.microsoft.com/office/drawing/2014/main" id="{5AC62802-3B67-4C20-9D01-2160D113014D}"/>
+                <a16:creationId xmlns:a16="http://schemas.microsoft.com/office/drawing/2014/main" id="{FD6C3A67-1E1F-49A2-8513-2454C58F0890}"/>
               </a:ext>
             </a:extLst>
           </p:cNvPr>
@@ -9930,7 +10208,7 @@
           <p:cNvPr id="11" name="">
             <a:extLst xmlns:a="http://schemas.openxmlformats.org/drawingml/2006/main">
               <a:ext uri="{FF2B5EF4-FFF2-40B4-BE49-F238E27FC236}">
-                <a16:creationId xmlns:a16="http://schemas.microsoft.com/office/drawing/2014/main" id="{528BB851-A370-465C-BA59-054BB627B99D}"/>
+                <a16:creationId xmlns:a16="http://schemas.microsoft.com/office/drawing/2014/main" id="{04AADCD9-1701-44D7-A935-6811EC40A285}"/>
               </a:ext>
             </a:extLst>
           </p:cNvPr>
@@ -9960,23 +10238,23 @@
           <p:cNvPr id="12" name="">
             <a:extLst xmlns:a="http://schemas.openxmlformats.org/drawingml/2006/main">
               <a:ext uri="{FF2B5EF4-FFF2-40B4-BE49-F238E27FC236}">
-                <a16:creationId xmlns:a16="http://schemas.microsoft.com/office/drawing/2014/main" id="{7E66D5AE-D661-4378-BEFB-BC13E0E9FA65}"/>
-              </a:ext>
-            </a:extLst>
-          </p:cNvPr>
-          <p:cNvSpPr>
-            <a:spLocks xmlns:a="http://schemas.openxmlformats.org/drawingml/2006/main" noGrp="1"/>
-          </p:cNvSpPr>
-          <p:nvPr/>
-        </p:nvSpPr>
-        <p:spPr>
-          <a:xfrm xmlns:a="http://schemas.openxmlformats.org/drawingml/2006/main">
-            <a:off x="1333500" y="4667250"/>
-            <a:ext cx="2857500" cy="704850"/>
+                <a16:creationId xmlns:a16="http://schemas.microsoft.com/office/drawing/2014/main" id="{6457A99B-58CB-4601-A178-51576DA2F89E}"/>
+              </a:ext>
+            </a:extLst>
+          </p:cNvPr>
+          <p:cNvSpPr>
+            <a:spLocks xmlns:a="http://schemas.openxmlformats.org/drawingml/2006/main" noGrp="1"/>
+          </p:cNvSpPr>
+          <p:nvPr/>
+        </p:nvSpPr>
+        <p:spPr>
+          <a:xfrm xmlns:a="http://schemas.openxmlformats.org/drawingml/2006/main">
+            <a:off x="1285875" y="4667250"/>
+            <a:ext cx="4953000" cy="800100"/>
           </a:xfrm>
           <a:prstGeom xmlns:a="http://schemas.openxmlformats.org/drawingml/2006/main" prst="roundRect">
             <a:avLst>
-              <a:gd name="adj" fmla="val 10811"/>
+              <a:gd name="adj" fmla="val 9524"/>
             </a:avLst>
           </a:prstGeom>
           <a:solidFill xmlns:a="http://schemas.openxmlformats.org/drawingml/2006/main">
@@ -9996,7 +10274,7 @@
           <a:lstStyle xmlns:a="http://schemas.openxmlformats.org/drawingml/2006/main"/>
           <a:p xmlns:a="http://schemas.openxmlformats.org/drawingml/2006/main">
             <a:pPr algn="ctr">
-              <a:defRPr sz="1650" b="1">
+              <a:defRPr sz="1500" b="1">
                 <a:solidFill>
                   <a:srgbClr val="13283C"/>
                 </a:solidFill>
@@ -10006,7 +10284,7 @@
               </a:defRPr>
             </a:pPr>
             <a:r>
-              <a:rPr sz="1650" b="1">
+              <a:rPr sz="1500" b="1">
                 <a:solidFill>
                   <a:srgbClr val="13283C"/>
                 </a:solidFill>
@@ -10014,7 +10292,30 @@
                 <a:ea typeface="Helvetica Neue"/>
                 <a:cs typeface="Helvetica Neue"/>
               </a:rPr>
-              <a:t>Git repository prepared locally</a:t>
+              <a:t>Published GitHub repository</a:t>
+            </a:r>
+          </a:p>
+          <a:p xmlns:a="http://schemas.openxmlformats.org/drawingml/2006/main">
+            <a:pPr algn="ctr">
+              <a:defRPr sz="1500" b="1">
+                <a:solidFill>
+                  <a:srgbClr val="13283C"/>
+                </a:solidFill>
+                <a:latin typeface="Helvetica Neue"/>
+                <a:ea typeface="Helvetica Neue"/>
+                <a:cs typeface="Helvetica Neue"/>
+              </a:defRPr>
+            </a:pPr>
+            <a:r>
+              <a:rPr sz="1500" b="1">
+                <a:solidFill>
+                  <a:srgbClr val="13283C"/>
+                </a:solidFill>
+                <a:latin typeface="Helvetica Neue"/>
+                <a:ea typeface="Helvetica Neue"/>
+                <a:cs typeface="Helvetica Neue"/>
+              </a:rPr>
+              <a:t>github.com/akwasianing/HeartTrialTwin</a:t>
             </a:r>
           </a:p>
         </p:txBody>
@@ -10024,31 +10325,31 @@
           <p:cNvPr id="13" name="">
             <a:extLst xmlns:a="http://schemas.openxmlformats.org/drawingml/2006/main">
               <a:ext uri="{FF2B5EF4-FFF2-40B4-BE49-F238E27FC236}">
-                <a16:creationId xmlns:a16="http://schemas.microsoft.com/office/drawing/2014/main" id="{FDCE13A1-DBD4-4CA2-8BD7-5F836822C4D5}"/>
-              </a:ext>
-            </a:extLst>
-          </p:cNvPr>
-          <p:cNvSpPr>
-            <a:spLocks xmlns:a="http://schemas.openxmlformats.org/drawingml/2006/main" noGrp="1"/>
-          </p:cNvSpPr>
-          <p:nvPr/>
-        </p:nvSpPr>
-        <p:spPr>
-          <a:xfrm xmlns:a="http://schemas.openxmlformats.org/drawingml/2006/main">
-            <a:off x="4667250" y="4667250"/>
-            <a:ext cx="3048000" cy="704850"/>
+                <a16:creationId xmlns:a16="http://schemas.microsoft.com/office/drawing/2014/main" id="{253E1A44-532A-4FCD-9F82-D11FEC0C4397}"/>
+              </a:ext>
+            </a:extLst>
+          </p:cNvPr>
+          <p:cNvSpPr>
+            <a:spLocks xmlns:a="http://schemas.openxmlformats.org/drawingml/2006/main" noGrp="1"/>
+          </p:cNvSpPr>
+          <p:nvPr/>
+        </p:nvSpPr>
+        <p:spPr>
+          <a:xfrm xmlns:a="http://schemas.openxmlformats.org/drawingml/2006/main">
+            <a:off x="6715125" y="4667250"/>
+            <a:ext cx="4191000" cy="800100"/>
           </a:xfrm>
           <a:prstGeom xmlns:a="http://schemas.openxmlformats.org/drawingml/2006/main" prst="roundRect">
             <a:avLst>
-              <a:gd name="adj" fmla="val 10811"/>
+              <a:gd name="adj" fmla="val 9524"/>
             </a:avLst>
           </a:prstGeom>
           <a:solidFill xmlns:a="http://schemas.openxmlformats.org/drawingml/2006/main">
-            <a:srgbClr val="DCEFEB"/>
+            <a:srgbClr val="E3F0E8"/>
           </a:solidFill>
           <a:ln xmlns:a="http://schemas.openxmlformats.org/drawingml/2006/main" w="9525">
             <a:solidFill>
-              <a:srgbClr val="DCEFEB"/>
+              <a:srgbClr val="E3F0E8"/>
             </a:solidFill>
             <a:prstDash val="solid"/>
           </a:ln>
@@ -10062,7 +10363,7 @@
             <a:pPr algn="ctr">
               <a:defRPr sz="1575" b="1">
                 <a:solidFill>
-                  <a:srgbClr val="13283C"/>
+                  <a:srgbClr val="237A57"/>
                 </a:solidFill>
                 <a:latin typeface="Helvetica Neue"/>
                 <a:ea typeface="Helvetica Neue"/>
@@ -10072,7 +10373,7 @@
             <a:r>
               <a:rPr sz="1575" b="1">
                 <a:solidFill>
-                  <a:srgbClr val="13283C"/>
+                  <a:srgbClr val="237A57"/>
                 </a:solidFill>
                 <a:latin typeface="Helvetica Neue"/>
                 <a:ea typeface="Helvetica Neue"/>
@@ -10088,71 +10389,7 @@
           <p:cNvPr id="14" name="">
             <a:extLst xmlns:a="http://schemas.openxmlformats.org/drawingml/2006/main">
               <a:ext uri="{FF2B5EF4-FFF2-40B4-BE49-F238E27FC236}">
-                <a16:creationId xmlns:a16="http://schemas.microsoft.com/office/drawing/2014/main" id="{7EC86CB2-C04F-4337-9C77-85F138A41C6B}"/>
-              </a:ext>
-            </a:extLst>
-          </p:cNvPr>
-          <p:cNvSpPr>
-            <a:spLocks xmlns:a="http://schemas.openxmlformats.org/drawingml/2006/main" noGrp="1"/>
-          </p:cNvSpPr>
-          <p:nvPr/>
-        </p:nvSpPr>
-        <p:spPr>
-          <a:xfrm xmlns:a="http://schemas.openxmlformats.org/drawingml/2006/main">
-            <a:off x="8191500" y="4667250"/>
-            <a:ext cx="2857500" cy="704850"/>
-          </a:xfrm>
-          <a:prstGeom xmlns:a="http://schemas.openxmlformats.org/drawingml/2006/main" prst="roundRect">
-            <a:avLst>
-              <a:gd name="adj" fmla="val 10811"/>
-            </a:avLst>
-          </a:prstGeom>
-          <a:solidFill xmlns:a="http://schemas.openxmlformats.org/drawingml/2006/main">
-            <a:srgbClr val="FBE8E8"/>
-          </a:solidFill>
-          <a:ln xmlns:a="http://schemas.openxmlformats.org/drawingml/2006/main" w="9525">
-            <a:solidFill>
-              <a:srgbClr val="FBE8E8"/>
-            </a:solidFill>
-            <a:prstDash val="solid"/>
-          </a:ln>
-        </p:spPr>
-        <p:txBody>
-          <a:bodyPr xmlns:a="http://schemas.openxmlformats.org/drawingml/2006/main" anchor="ctr">
-            <a:normAutofit fontScale="100000"/>
-          </a:bodyPr>
-          <a:lstStyle xmlns:a="http://schemas.openxmlformats.org/drawingml/2006/main"/>
-          <a:p xmlns:a="http://schemas.openxmlformats.org/drawingml/2006/main">
-            <a:pPr algn="ctr">
-              <a:defRPr sz="1575" b="1">
-                <a:solidFill>
-                  <a:srgbClr val="C43C45"/>
-                </a:solidFill>
-                <a:latin typeface="Helvetica Neue"/>
-                <a:ea typeface="Helvetica Neue"/>
-                <a:cs typeface="Helvetica Neue"/>
-              </a:defRPr>
-            </a:pPr>
-            <a:r>
-              <a:rPr sz="1575" b="1">
-                <a:solidFill>
-                  <a:srgbClr val="C43C45"/>
-                </a:solidFill>
-                <a:latin typeface="Helvetica Neue"/>
-                <a:ea typeface="Helvetica Neue"/>
-                <a:cs typeface="Helvetica Neue"/>
-              </a:rPr>
-              <a:t>GitHub remote awaiting authorization</a:t>
-            </a:r>
-          </a:p>
-        </p:txBody>
-      </p:sp>
-      <p:sp>
-        <p:nvSpPr>
-          <p:cNvPr id="15" name="">
-            <a:extLst xmlns:a="http://schemas.openxmlformats.org/drawingml/2006/main">
-              <a:ext uri="{FF2B5EF4-FFF2-40B4-BE49-F238E27FC236}">
-                <a16:creationId xmlns:a16="http://schemas.microsoft.com/office/drawing/2014/main" id="{6994BD44-76C8-4752-AD3A-69AED22C3AAF}"/>
+                <a16:creationId xmlns:a16="http://schemas.microsoft.com/office/drawing/2014/main" id="{44A13369-7C09-4010-9BCA-7512C33A1134}"/>
               </a:ext>
             </a:extLst>
           </p:cNvPr>
@@ -10206,10 +10443,10 @@
       </p:sp>
       <p:sp>
         <p:nvSpPr>
-          <p:cNvPr id="16" name="">
-            <a:extLst xmlns:a="http://schemas.openxmlformats.org/drawingml/2006/main">
-              <a:ext uri="{FF2B5EF4-FFF2-40B4-BE49-F238E27FC236}">
-                <a16:creationId xmlns:a16="http://schemas.microsoft.com/office/drawing/2014/main" id="{D94975AD-E9DD-4636-9C50-487E444B2686}"/>
+          <p:cNvPr id="15" name="">
+            <a:extLst xmlns:a="http://schemas.openxmlformats.org/drawingml/2006/main">
+              <a:ext uri="{FF2B5EF4-FFF2-40B4-BE49-F238E27FC236}">
+                <a16:creationId xmlns:a16="http://schemas.microsoft.com/office/drawing/2014/main" id="{DD1E8700-5BAC-4FAC-A6D2-8B2ED703AE0F}"/>
               </a:ext>
             </a:extLst>
           </p:cNvPr>
@@ -10264,7 +10501,7 @@
     </p:spTree>
     <p:extLst>
       <p:ext uri="{BB962C8B-B14F-4D97-AF65-F5344CB8AC3E}">
-        <p14:creationId xmlns:p14="http://schemas.microsoft.com/office/powerpoint/2010/main" val="785427831"/>
+        <p14:creationId xmlns:p14="http://schemas.microsoft.com/office/powerpoint/2010/main" val="483959430"/>
       </p:ext>
     </p:extLst>
   </p:cSld>

</xml_diff>